<commit_message>
Bare AXI4: remove register stages, error checks and extra host signals; regenerate diagram, waveforms and presentation
</commit_message>
<xml_diff>
--- a/docs/AXI4_Viva_Presentation.pptx
+++ b/docs/AXI4_Viva_Presentation.pptx
@@ -518,7 +518,7 @@
           <a:lstStyle/>
           <a:p>
             <a:r>
-              <a:t>Open with the one-sentence summary: we built both ends of an AXI4 connection in Verilog. A manager that issues bursts, and a subordinate that is a 4 KiB memory. They are connected through five registered channels. Everything shown today comes from the simulation in the project folder, so every number can be reproduced live. The five amber pills are the five AXI channels; we come back to each one.</a:t>
+              <a:t>Open with the one-sentence summary: we built both ends of an AXI4 connection in Verilog. A manager that issues bursts, and a subordinate that is a 4 KiB memory. They are wired directly together over the five AXI channels. Everything shown today comes from the simulation in the project folder, so every number can be reproduced live. The five amber pills are the five AXI channels; we come back to each one.</a:t>
             </a:r>
           </a:p>
         </p:txBody>
@@ -588,7 +588,7 @@
           <a:lstStyle/>
           <a:p>
             <a:r>
-              <a:t>You asked for the modules to communicate only through flip-flops. A single flip-flop per wire loses data: the receiver's READY arrives one cycle late, so the sender can push a beat the flip-flop has already used. The skid buffer fixes that with a spare slot: if the output is stuck, the next beat parks in the slot and in_ready drops at once, so a third beat can never arrive. Cost: one clock per stage, so two cycles per transaction in total, and throughput stays at one beat per clock.</a:t>
+              <a:t>One request from start to finish: write four words to address 0x10. The host pulses the start with cmd_len = 3 and streams four words. The manager copies the description, sends the address and the beats and raises WLAST on the fourth. The subordinate takes the address first, then writes each word into memory. After WLAST it sends one response. The manager takes it and pulses cmd_done. Measured: six busy cycles for four beats.</a:t>
             </a:r>
           </a:p>
         </p:txBody>
@@ -658,7 +658,7 @@
           <a:lstStyle/>
           <a:p>
             <a:r>
-              <a:t>This waveform was recorded from our simulation of the full system with the flip-flop stages: a 4-beat write to address 0x10. Cycle 0, the host pulses start. Cycle 1, AWVALID and WVALID go up together and handshake straight away at the stage. Cycle 2, the address reaches the subordinate, one cycle later: that is the stage. The subordinate raises WREADY only after it has the address, so on the manager side WREADY dips for one cycle at 3 while the stage absorbs the wait. The four beats then flow, WLAST on the fourth, the response arrives at cycle 8 and cmd_done pulses at 9.</a:t>
+              <a:t>This waveform was recorded from our simulation of the full system: a 4-beat write to address 0x10. Cycle 0, the host pulses start. Cycle 1, AWVALID and WVALID go up together and the address handshakes straight away; WREADY is still low because the subordinate takes the address first. From cycle 2 the four beats flow one per clock, WLAST rides on the fourth at cycle 5, the response handshakes at cycle 6 and cmd_done pulses at 7. The master was busy for 6 cycles.</a:t>
             </a:r>
           </a:p>
         </p:txBody>
@@ -728,7 +728,7 @@
           <a:lstStyle/>
           <a:p>
             <a:r>
-              <a:t>Same address read back. One address goes out at cycle 2 and reaches the subordinate at 3. The manager raises RREADY as soon as the address is accepted. Data starts arriving at cycle 5 and the four beats come back to back, one per clock, with RLAST on the last at cycle 8; cmd_done at 9. After the first beat there are no gaps: that is the point of fetching the next word on each read handshake.</a:t>
+              <a:t>Same address read back. One address goes out and is accepted at cycle 1. The manager raises RREADY as soon as the address is accepted. The four beats come back to back at cycles 2 to 5, one per clock, with RLAST on the fourth. cmd_done pulses at 6. After the address there are no gaps: that is the point of fetching the next word on each read handshake.</a:t>
             </a:r>
           </a:p>
         </p:txBody>
@@ -798,7 +798,7 @@
           <a:lstStyle/>
           <a:p>
             <a:r>
-              <a:t>We verified at three levels so that a failure points at one place. Level 1 plays the manager against the subordinate alone and forces awkward cases that a real manager would not produce. Level 2 runs the manager against a mock subordinate whose delays we control, with always-on monitors that fail the test if VALID drops early or any payload bit changes while stalled. Level 3 runs the whole system, once with the flip-flop stages and once without, including a reset in the middle of a burst.</a:t>
+              <a:t>We verified at three levels so that a failure points at one place. Level 1 plays the manager against the subordinate alone and forces awkward cases that a real manager would not produce. Level 2 runs the manager against a mock subordinate whose delays we control, with always-on monitors that fail the test if VALID drops early or any payload bit changes while stalled. Level 3 runs the whole system through the host ports, including a reset in the middle of a burst.</a:t>
             </a:r>
           </a:p>
         </p:txBody>
@@ -868,7 +868,7 @@
           <a:lstStyle/>
           <a:p>
             <a:r>
-              <a:t>Three numbers to remember. All 251 checks pass. The flip-flop stages add a fixed two cycles per transaction, which we measured by running the same stimulus with and without them: a 32-beat write took 37 cycles against 35. Thirty-two beats cannot take fewer than 32 cycles, so the extra cycles are the whole cost, and it does not grow with burst length. Throughput stays at one beat per clock.</a:t>
+              <a:t>Three numbers to remember. All 156 checks pass. Sustained throughput is one beat per clock. A 32-beat write takes 35 cycles and a 32-beat read 34, measured from the start pulse to the done pulse. Thirty-two beats cannot take fewer than 32 cycles, so the remaining 3 and 2 cycles are the fixed cost of the address and response handshakes. That overhead does not grow with burst length: the 8-beat write took 11 cycles, the same 3 cycles over.</a:t>
             </a:r>
           </a:p>
         </p:txBody>
@@ -938,7 +938,7 @@
           <a:lstStyle/>
           <a:p>
             <a:r>
-              <a:t>Say these before you are asked. One burst at a time per direction, so IDs are echoed but never used to reorder. No exclusive access. Narrow reads return the whole word and the manager picks its lanes. Only the start address is range-checked, which is safe for legal bursts because a legal burst cannot cross a 4 KiB boundary. The host streams inside the manager are a combinational pass-through with a state gate; the flip-flop stages sit immediately after, so the module boundary is clean, but it is not true that every manager output is a flip-flop. A reset in mid-burst discards beats still in the stages.</a:t>
+              <a:t>Say these before you are asked. One burst at a time per direction, so IDs are echoed but never used to reorder. Every response is OKAY: there are no error responses, and an address beyond the 4 KiB wraps inside the memory. No exclusive access. Narrow reads return the whole word and the manager picks its lanes. The host streams inside the manager are a combinational pass-through with a state gate. A reset in mid-burst leaves the memory as it was, and which beats landed is not defined.</a:t>
             </a:r>
           </a:p>
         </p:txBody>
@@ -1008,7 +1008,7 @@
           <a:lstStyle/>
           <a:p>
             <a:r>
-              <a:t>Live demo, about two minutes. Open PowerShell in E:\FPGA_Project and run .\run_tests.ps1. It compiles and runs four suites. Point at the three result lines and the summary. Then run the top suite with -Wave to open the waveform in GTKWave and show the same shape as the recorded slides: the one-cycle shift from master side to slave side, and the WREADY dip. If the live run fails for any reason, the slides 11 and 12 are recorded from this exact simulation.</a:t>
+              <a:t>Live demo, about two minutes. Open PowerShell in E:\FPGA_Project and run .\run_tests.ps1. It compiles and runs three suites. Point at the three result lines and the summary. Then run the top suite with -Wave to open the waveform in GTKWave and show the same shape as the recorded slides: the one-cycle shift from master side to slave side, and the WREADY dip. If the live run fails for any reason, the slides 11 and 12 are recorded from this exact simulation.</a:t>
             </a:r>
           </a:p>
         </p:txBody>
@@ -1078,7 +1078,7 @@
           <a:lstStyle/>
           <a:p>
             <a:r>
-              <a:t>Likely questions with short answers. Why five channels: so address, data and response move independently and in both directions. Why not a single flip-flop: READY arrives late and a beat is lost; the spare slot catches it. Why does the subordinate use WLAST when it knows the length: it cross-checks and reports SLVERR instead of hanging. Why latch the command: the bus payload must stay stable until the handshake completes. What about a bad address mid-burst: the burst is still drained and DECERR is returned once.</a:t>
+              <a:t>Likely questions with short answers. Why five channels: so address, data and response move independently and in both directions. How does the subordinate know the burst ended: WLAST on writes, a beat count on reads. What about a bad address: this subordinate does no checking, the address wraps and the response is OKAY. Why latch the command: the bus payload must stay stable until the handshake completes. What limits throughput: one beat per clock after a few cycles of address and response overhead.</a:t>
             </a:r>
           </a:p>
         </p:txBody>
@@ -1148,7 +1148,7 @@
           <a:lstStyle/>
           <a:p>
             <a:r>
-              <a:t>Three pieces. The manager is the active side: your logic gives it a simple request and it runs the whole AXI conversation. The subordinate is a small memory that understands that conversation. The flip-flop stages sit between them. Stress that this is full AXI4: bursts, IDs and the LAST signals, not the single-word AXI4-Lite.</a:t>
+              <a:t>Three files. The manager is the active side: your logic gives it a simple request and it runs the whole AXI conversation. The subordinate is a small memory that understands that conversation. The top level only wires the two together. Stress that this is full AXI4: bursts, IDs and the LAST signals, not the single-word AXI4-Lite.</a:t>
             </a:r>
           </a:p>
         </p:txBody>
@@ -1428,7 +1428,7 @@
           <a:lstStyle/>
           <a:p>
             <a:r>
-              <a:t>Walk left to right. Your logic uses a command port and two data streams. The manager turns those into the five AXI channels. Every channel passes through its own amber flip-flop stage. AW, W and AR carry requests forward; B and R carry responses back. Inside the subordinate there is a write engine, a read engine and a 4 KiB memory. The three notes at the bottom are the three design decisions we will justify.</a:t>
+              <a:t>Walk left to right. Your logic uses a command port and two data streams. The manager turns those into the five AXI channels, shown with their real signal names. The channels run straight into the subordinate, which has a write engine, a read engine and a 4 KiB memory. The three cards at the bottom are the design points we will justify.</a:t>
             </a:r>
           </a:p>
         </p:txBody>
@@ -1498,7 +1498,7 @@
           <a:lstStyle/>
           <a:p>
             <a:r>
-              <a:t>The host side of the manager is deliberately simple. You pulse a start signal with a burst description; for a write you push beats into the write stream, for a read you pull them from the read stream. cmd_done is a one-cycle pulse when the burst finishes. Two rules: a start pulse is ignored while cmd_busy is high, and if both starts are high at once the write wins. The manager copies the description into registers, so you may change cmd_addr straight after the pulse.</a:t>
+              <a:t>The host side of the manager is deliberately small. You pulse a start signal with a burst description; for a write you push beats into the write stream, for a read you take them from the read stream. cmd_done is a one-cycle pulse when the burst finishes and cmd_resp carries the response. A start is taken only when the manager is idle, and if both starts are high the write wins. The manager copies the description into registers, so you may change cmd_addr straight after the pulse.</a:t>
             </a:r>
           </a:p>
         </p:txBody>
@@ -1638,7 +1638,7 @@
           <a:lstStyle/>
           <a:p>
             <a:r>
-              <a:t>The subordinate has two independent state machines because reads and writes use different channels. The write engine takes the address first and only then raises WREADY, applies WSTRB byte by byte, steps the address per beat, and sends one B response. The read engine fetches the first word on the address handshake and each following word on the previous beat's handshake, which is why beats come out one per clock. Errors: DECERR for an address outside the 4 KiB, SLVERR for a malformed request. Importantly, a failing write is still fully accepted and a failing read still returns every beat, so the manager never hangs.</a:t>
+              <a:t>The subordinate has two independent state machines because reads and writes use different channels. The write engine takes the address first and only then raises WREADY, applies WSTRB byte by byte, steps the address per beat, and sends one B response. The read engine fetches the first word on the address handshake and each following word on the previous beat's handshake, which is why beats come out one per clock. Every response is OKAY: this subordinate does no request checking, so an address beyond the 4 KiB simply wraps inside the memory.</a:t>
             </a:r>
           </a:p>
         </p:txBody>
@@ -4752,7 +4752,7 @@
                 </a:solidFill>
                 <a:latin typeface="Calibri"/>
               </a:rPr>
-              <a:t>Burst transfers over five registered channels, with 251 checks passing in simulation.</a:t>
+              <a:t>Burst transfers over the five AXI4 channels, with 156 checks passing in simulation.</a:t>
             </a:r>
           </a:p>
         </p:txBody>
@@ -5123,35 +5123,46 @@
                 </a:solidFill>
                 <a:latin typeface="Cambria"/>
               </a:rPr>
-              <a:t>The flip-flop stage: a skid buffer</a:t>
-            </a:r>
-          </a:p>
-        </p:txBody>
-      </p:sp>
-      <p:pic>
-        <p:nvPicPr>
-          <p:cNvPr id="3" name="Picture 2" descr="Skid buffer: an output register and a spare skid slot with in_ready equal to not skid_valid."/>
-          <p:cNvPicPr>
-            <a:picLocks noChangeAspect="1"/>
-          </p:cNvPicPr>
-          <p:nvPr/>
-        </p:nvPicPr>
-        <p:blipFill>
-          <a:blip r:embed="rId3"/>
-          <a:stretch>
-            <a:fillRect/>
-          </a:stretch>
-        </p:blipFill>
-        <p:spPr>
-          <a:xfrm>
-            <a:off x="640080" y="2194560"/>
-            <a:ext cx="6400800" cy="2700338"/>
-          </a:xfrm>
-          <a:prstGeom prst="rect">
-            <a:avLst/>
-          </a:prstGeom>
-        </p:spPr>
-      </p:pic>
+              <a:t>One write, end to end</a:t>
+            </a:r>
+          </a:p>
+        </p:txBody>
+      </p:sp>
+      <p:sp>
+        <p:nvSpPr>
+          <p:cNvPr id="3" name="TextBox 2"/>
+          <p:cNvSpPr txBox="1"/>
+          <p:nvPr/>
+        </p:nvSpPr>
+        <p:spPr>
+          <a:xfrm>
+            <a:off x="640080" y="1280160"/>
+            <a:ext cx="10881360" cy="457200"/>
+          </a:xfrm>
+          <a:prstGeom prst="rect">
+            <a:avLst/>
+          </a:prstGeom>
+          <a:noFill/>
+        </p:spPr>
+        <p:txBody>
+          <a:bodyPr wrap="square" lIns="0" rIns="0" tIns="0" bIns="0" anchor="t">
+            <a:spAutoFit/>
+          </a:bodyPr>
+          <a:lstStyle/>
+          <a:p>
+            <a:pPr algn="l"/>
+            <a:r>
+              <a:rPr sz="2000" b="0" i="0">
+                <a:solidFill>
+                  <a:srgbClr val="4F5F74"/>
+                </a:solidFill>
+                <a:latin typeface="Calibri"/>
+              </a:rPr>
+              <a:t>Writing four words to address 0x10.</a:t>
+            </a:r>
+          </a:p>
+        </p:txBody>
+      </p:sp>
       <p:sp>
         <p:nvSpPr>
           <p:cNvPr id="4" name="Rounded Rectangle 3"/>
@@ -5160,8 +5171,8 @@
         </p:nvSpPr>
         <p:spPr>
           <a:xfrm>
-            <a:off x="7315200" y="1463040"/>
-            <a:ext cx="4233672" cy="4617720"/>
+            <a:off x="640080" y="2057400"/>
+            <a:ext cx="1993392" cy="3383280"/>
           </a:xfrm>
           <a:prstGeom prst="roundRect">
             <a:avLst>
@@ -5169,7 +5180,7 @@
             </a:avLst>
           </a:prstGeom>
           <a:solidFill>
-            <a:srgbClr val="FFFFFF"/>
+            <a:srgbClr val="D6E6FF"/>
           </a:solidFill>
           <a:ln>
             <a:noFill/>
@@ -5204,8 +5215,8 @@
         </p:nvSpPr>
         <p:spPr>
           <a:xfrm>
-            <a:off x="7589520" y="1645920"/>
-            <a:ext cx="3657600" cy="365760"/>
+            <a:off x="822959" y="2240280"/>
+            <a:ext cx="1627632" cy="822960"/>
           </a:xfrm>
           <a:prstGeom prst="rect">
             <a:avLst/>
@@ -5220,13 +5231,13 @@
           <a:p>
             <a:pPr algn="l"/>
             <a:r>
-              <a:rPr sz="1900" b="1" i="0">
+              <a:rPr sz="2000" b="1" i="0">
                 <a:solidFill>
                   <a:srgbClr val="1E2A3B"/>
                 </a:solidFill>
                 <a:latin typeface="Cambria"/>
               </a:rPr>
-              <a:t>Why not one flip-flop?</a:t>
+              <a:t>1  Host</a:t>
             </a:r>
           </a:p>
         </p:txBody>
@@ -5239,8 +5250,8 @@
         </p:nvSpPr>
         <p:spPr>
           <a:xfrm>
-            <a:off x="7589520" y="2103120"/>
-            <a:ext cx="3703320" cy="1371600"/>
+            <a:off x="822959" y="3154680"/>
+            <a:ext cx="1627632" cy="2194560"/>
           </a:xfrm>
           <a:prstGeom prst="rect">
             <a:avLst/>
@@ -5255,27 +5266,107 @@
           <a:p>
             <a:pPr algn="l"/>
             <a:r>
-              <a:rPr sz="1500" b="0" i="0">
+              <a:rPr sz="1600" b="0" i="0">
                 <a:solidFill>
                   <a:srgbClr val="1E2A3B"/>
                 </a:solidFill>
                 <a:latin typeface="Calibri"/>
               </a:rPr>
-              <a:t>READY would reach the sender one cycle late, so it could push a beat the stage has already used. That beat would be lost.</a:t>
-            </a:r>
-          </a:p>
-        </p:txBody>
-      </p:sp>
-      <p:sp>
-        <p:nvSpPr>
-          <p:cNvPr id="7" name="TextBox 6"/>
-          <p:cNvSpPr txBox="1"/>
-          <p:nvPr/>
-        </p:nvSpPr>
-        <p:spPr>
-          <a:xfrm>
-            <a:off x="7589520" y="3520440"/>
-            <a:ext cx="3657600" cy="365760"/>
+              <a:t>Pulses cmd_start_write with cmd_addr = 0x10 and cmd_len = 3, then streams four words.</a:t>
+            </a:r>
+          </a:p>
+        </p:txBody>
+      </p:sp>
+      <p:cxnSp>
+        <p:nvCxnSpPr>
+          <p:cNvPr id="7" name="Connector 6"/>
+          <p:cNvCxnSpPr/>
+          <p:nvPr/>
+        </p:nvCxnSpPr>
+        <p:spPr>
+          <a:xfrm>
+            <a:off x="2651760" y="3749039"/>
+            <a:ext cx="192024" cy="0"/>
+          </a:xfrm>
+          <a:prstGeom prst="line">
+            <a:avLst/>
+          </a:prstGeom>
+          <a:ln w="25400">
+            <a:solidFill>
+              <a:srgbClr val="4F5F74"/>
+            </a:solidFill>
+            <a:tailEnd type="triangle" w="med" len="med"/>
+          </a:ln>
+        </p:spPr>
+        <p:style>
+          <a:lnRef idx="2">
+            <a:schemeClr val="accent1"/>
+          </a:lnRef>
+          <a:fillRef idx="0">
+            <a:schemeClr val="accent1"/>
+          </a:fillRef>
+          <a:effectRef idx="1">
+            <a:schemeClr val="accent1"/>
+          </a:effectRef>
+          <a:fontRef idx="minor">
+            <a:schemeClr val="tx1"/>
+          </a:fontRef>
+        </p:style>
+      </p:cxnSp>
+      <p:sp>
+        <p:nvSpPr>
+          <p:cNvPr id="8" name="Rounded Rectangle 7"/>
+          <p:cNvSpPr/>
+          <p:nvPr/>
+        </p:nvSpPr>
+        <p:spPr>
+          <a:xfrm>
+            <a:off x="2862072" y="2057400"/>
+            <a:ext cx="1993392" cy="3383280"/>
+          </a:xfrm>
+          <a:prstGeom prst="roundRect">
+            <a:avLst>
+              <a:gd name="adj" fmla="val 6000"/>
+            </a:avLst>
+          </a:prstGeom>
+          <a:solidFill>
+            <a:srgbClr val="D6E6FF"/>
+          </a:solidFill>
+          <a:ln>
+            <a:noFill/>
+          </a:ln>
+          <a:effectLst/>
+        </p:spPr>
+        <p:style>
+          <a:lnRef idx="1">
+            <a:schemeClr val="accent1"/>
+          </a:lnRef>
+          <a:fillRef idx="3">
+            <a:schemeClr val="accent1"/>
+          </a:fillRef>
+          <a:effectRef idx="2">
+            <a:schemeClr val="accent1"/>
+          </a:effectRef>
+          <a:fontRef idx="minor">
+            <a:schemeClr val="lt1"/>
+          </a:fontRef>
+        </p:style>
+        <p:txBody>
+          <a:bodyPr rtlCol="0" anchor="ctr"/>
+          <a:lstStyle/>
+          <a:p/>
+        </p:txBody>
+      </p:sp>
+      <p:sp>
+        <p:nvSpPr>
+          <p:cNvPr id="9" name="TextBox 8"/>
+          <p:cNvSpPr txBox="1"/>
+          <p:nvPr/>
+        </p:nvSpPr>
+        <p:spPr>
+          <a:xfrm>
+            <a:off x="3044952" y="2240280"/>
+            <a:ext cx="1627632" cy="822960"/>
           </a:xfrm>
           <a:prstGeom prst="rect">
             <a:avLst/>
@@ -5290,27 +5381,27 @@
           <a:p>
             <a:pPr algn="l"/>
             <a:r>
-              <a:rPr sz="1900" b="1" i="0">
+              <a:rPr sz="2000" b="1" i="0">
                 <a:solidFill>
                   <a:srgbClr val="1E2A3B"/>
                 </a:solidFill>
                 <a:latin typeface="Cambria"/>
               </a:rPr>
-              <a:t>What it costs</a:t>
-            </a:r>
-          </a:p>
-        </p:txBody>
-      </p:sp>
-      <p:sp>
-        <p:nvSpPr>
-          <p:cNvPr id="8" name="TextBox 7"/>
-          <p:cNvSpPr txBox="1"/>
-          <p:nvPr/>
-        </p:nvSpPr>
-        <p:spPr>
-          <a:xfrm>
-            <a:off x="7589520" y="3977639"/>
-            <a:ext cx="3703320" cy="2011680"/>
+              <a:t>2  Master</a:t>
+            </a:r>
+          </a:p>
+        </p:txBody>
+      </p:sp>
+      <p:sp>
+        <p:nvSpPr>
+          <p:cNvPr id="10" name="TextBox 9"/>
+          <p:cNvSpPr txBox="1"/>
+          <p:nvPr/>
+        </p:nvSpPr>
+        <p:spPr>
+          <a:xfrm>
+            <a:off x="3044952" y="3154680"/>
+            <a:ext cx="1627632" cy="2194560"/>
           </a:xfrm>
           <a:prstGeom prst="rect">
             <a:avLst/>
@@ -5323,58 +5414,507 @@
           </a:bodyPr>
           <a:lstStyle/>
           <a:p>
-            <a:pPr algn="l">
-              <a:spcAft>
-                <a:spcPts val="600"/>
-              </a:spcAft>
-            </a:pPr>
-            <a:r>
-              <a:rPr sz="1500" b="0" i="0">
+            <a:pPr algn="l"/>
+            <a:r>
+              <a:rPr sz="1600" b="0" i="0">
                 <a:solidFill>
                   <a:srgbClr val="1E2A3B"/>
                 </a:solidFill>
                 <a:latin typeface="Calibri"/>
               </a:rPr>
-              <a:t>+2 cycles per transaction, fixed</a:t>
-            </a:r>
-          </a:p>
-          <a:p>
-            <a:pPr algn="l">
-              <a:spcAft>
-                <a:spcPts val="600"/>
-              </a:spcAft>
-            </a:pPr>
-            <a:r>
-              <a:rPr sz="1500" b="0" i="0">
+              <a:t>Copies the description, sends AW, and sends the four beats on W with WLAST on the fourth.</a:t>
+            </a:r>
+          </a:p>
+        </p:txBody>
+      </p:sp>
+      <p:cxnSp>
+        <p:nvCxnSpPr>
+          <p:cNvPr id="11" name="Connector 10"/>
+          <p:cNvCxnSpPr/>
+          <p:nvPr/>
+        </p:nvCxnSpPr>
+        <p:spPr>
+          <a:xfrm>
+            <a:off x="4873752" y="3749039"/>
+            <a:ext cx="192024" cy="0"/>
+          </a:xfrm>
+          <a:prstGeom prst="line">
+            <a:avLst/>
+          </a:prstGeom>
+          <a:ln w="25400">
+            <a:solidFill>
+              <a:srgbClr val="4F5F74"/>
+            </a:solidFill>
+            <a:tailEnd type="triangle" w="med" len="med"/>
+          </a:ln>
+        </p:spPr>
+        <p:style>
+          <a:lnRef idx="2">
+            <a:schemeClr val="accent1"/>
+          </a:lnRef>
+          <a:fillRef idx="0">
+            <a:schemeClr val="accent1"/>
+          </a:fillRef>
+          <a:effectRef idx="1">
+            <a:schemeClr val="accent1"/>
+          </a:effectRef>
+          <a:fontRef idx="minor">
+            <a:schemeClr val="tx1"/>
+          </a:fontRef>
+        </p:style>
+      </p:cxnSp>
+      <p:sp>
+        <p:nvSpPr>
+          <p:cNvPr id="12" name="Rounded Rectangle 11"/>
+          <p:cNvSpPr/>
+          <p:nvPr/>
+        </p:nvSpPr>
+        <p:spPr>
+          <a:xfrm>
+            <a:off x="5084064" y="2057400"/>
+            <a:ext cx="1993392" cy="3383280"/>
+          </a:xfrm>
+          <a:prstGeom prst="roundRect">
+            <a:avLst>
+              <a:gd name="adj" fmla="val 6000"/>
+            </a:avLst>
+          </a:prstGeom>
+          <a:solidFill>
+            <a:srgbClr val="E6DEFA"/>
+          </a:solidFill>
+          <a:ln>
+            <a:noFill/>
+          </a:ln>
+          <a:effectLst/>
+        </p:spPr>
+        <p:style>
+          <a:lnRef idx="1">
+            <a:schemeClr val="accent1"/>
+          </a:lnRef>
+          <a:fillRef idx="3">
+            <a:schemeClr val="accent1"/>
+          </a:fillRef>
+          <a:effectRef idx="2">
+            <a:schemeClr val="accent1"/>
+          </a:effectRef>
+          <a:fontRef idx="minor">
+            <a:schemeClr val="lt1"/>
+          </a:fontRef>
+        </p:style>
+        <p:txBody>
+          <a:bodyPr rtlCol="0" anchor="ctr"/>
+          <a:lstStyle/>
+          <a:p/>
+        </p:txBody>
+      </p:sp>
+      <p:sp>
+        <p:nvSpPr>
+          <p:cNvPr id="13" name="TextBox 12"/>
+          <p:cNvSpPr txBox="1"/>
+          <p:nvPr/>
+        </p:nvSpPr>
+        <p:spPr>
+          <a:xfrm>
+            <a:off x="5266944" y="2240280"/>
+            <a:ext cx="1627632" cy="822960"/>
+          </a:xfrm>
+          <a:prstGeom prst="rect">
+            <a:avLst/>
+          </a:prstGeom>
+          <a:noFill/>
+        </p:spPr>
+        <p:txBody>
+          <a:bodyPr wrap="square" lIns="0" rIns="0" tIns="0" bIns="0" anchor="t">
+            <a:spAutoFit/>
+          </a:bodyPr>
+          <a:lstStyle/>
+          <a:p>
+            <a:pPr algn="l"/>
+            <a:r>
+              <a:rPr sz="2000" b="1" i="0">
                 <a:solidFill>
                   <a:srgbClr val="1E2A3B"/>
                 </a:solidFill>
+                <a:latin typeface="Cambria"/>
+              </a:rPr>
+              <a:t>3  Subordinate</a:t>
+            </a:r>
+          </a:p>
+        </p:txBody>
+      </p:sp>
+      <p:sp>
+        <p:nvSpPr>
+          <p:cNvPr id="14" name="TextBox 13"/>
+          <p:cNvSpPr txBox="1"/>
+          <p:nvPr/>
+        </p:nvSpPr>
+        <p:spPr>
+          <a:xfrm>
+            <a:off x="5266944" y="3154680"/>
+            <a:ext cx="1627632" cy="2194560"/>
+          </a:xfrm>
+          <a:prstGeom prst="rect">
+            <a:avLst/>
+          </a:prstGeom>
+          <a:noFill/>
+        </p:spPr>
+        <p:txBody>
+          <a:bodyPr wrap="square" lIns="0" rIns="0" tIns="0" bIns="0" anchor="t">
+            <a:spAutoFit/>
+          </a:bodyPr>
+          <a:lstStyle/>
+          <a:p>
+            <a:pPr algn="l"/>
+            <a:r>
+              <a:rPr sz="1600" b="0" i="0">
+                <a:solidFill>
+                  <a:srgbClr val="1E2A3B"/>
+                </a:solidFill>
                 <a:latin typeface="Calibri"/>
               </a:rPr>
-              <a:t>Still 1 beat per clock</a:t>
-            </a:r>
-          </a:p>
-          <a:p>
-            <a:pPr algn="l">
-              <a:spcAft>
-                <a:spcPts val="0"/>
-              </a:spcAft>
-            </a:pPr>
-            <a:r>
-              <a:rPr sz="1500" b="0" i="0">
+              <a:t>Takes the address first, then raises WREADY and writes each word into memory.</a:t>
+            </a:r>
+          </a:p>
+        </p:txBody>
+      </p:sp>
+      <p:cxnSp>
+        <p:nvCxnSpPr>
+          <p:cNvPr id="15" name="Connector 14"/>
+          <p:cNvCxnSpPr/>
+          <p:nvPr/>
+        </p:nvCxnSpPr>
+        <p:spPr>
+          <a:xfrm>
+            <a:off x="7095744" y="3749039"/>
+            <a:ext cx="192024" cy="0"/>
+          </a:xfrm>
+          <a:prstGeom prst="line">
+            <a:avLst/>
+          </a:prstGeom>
+          <a:ln w="25400">
+            <a:solidFill>
+              <a:srgbClr val="4F5F74"/>
+            </a:solidFill>
+            <a:tailEnd type="triangle" w="med" len="med"/>
+          </a:ln>
+        </p:spPr>
+        <p:style>
+          <a:lnRef idx="2">
+            <a:schemeClr val="accent1"/>
+          </a:lnRef>
+          <a:fillRef idx="0">
+            <a:schemeClr val="accent1"/>
+          </a:fillRef>
+          <a:effectRef idx="1">
+            <a:schemeClr val="accent1"/>
+          </a:effectRef>
+          <a:fontRef idx="minor">
+            <a:schemeClr val="tx1"/>
+          </a:fontRef>
+        </p:style>
+      </p:cxnSp>
+      <p:sp>
+        <p:nvSpPr>
+          <p:cNvPr id="16" name="Rounded Rectangle 15"/>
+          <p:cNvSpPr/>
+          <p:nvPr/>
+        </p:nvSpPr>
+        <p:spPr>
+          <a:xfrm>
+            <a:off x="7306056" y="2057400"/>
+            <a:ext cx="1993392" cy="3383280"/>
+          </a:xfrm>
+          <a:prstGeom prst="roundRect">
+            <a:avLst>
+              <a:gd name="adj" fmla="val 6000"/>
+            </a:avLst>
+          </a:prstGeom>
+          <a:solidFill>
+            <a:srgbClr val="E6DEFA"/>
+          </a:solidFill>
+          <a:ln>
+            <a:noFill/>
+          </a:ln>
+          <a:effectLst/>
+        </p:spPr>
+        <p:style>
+          <a:lnRef idx="1">
+            <a:schemeClr val="accent1"/>
+          </a:lnRef>
+          <a:fillRef idx="3">
+            <a:schemeClr val="accent1"/>
+          </a:fillRef>
+          <a:effectRef idx="2">
+            <a:schemeClr val="accent1"/>
+          </a:effectRef>
+          <a:fontRef idx="minor">
+            <a:schemeClr val="lt1"/>
+          </a:fontRef>
+        </p:style>
+        <p:txBody>
+          <a:bodyPr rtlCol="0" anchor="ctr"/>
+          <a:lstStyle/>
+          <a:p/>
+        </p:txBody>
+      </p:sp>
+      <p:sp>
+        <p:nvSpPr>
+          <p:cNvPr id="17" name="TextBox 16"/>
+          <p:cNvSpPr txBox="1"/>
+          <p:nvPr/>
+        </p:nvSpPr>
+        <p:spPr>
+          <a:xfrm>
+            <a:off x="7488936" y="2240280"/>
+            <a:ext cx="1627632" cy="822960"/>
+          </a:xfrm>
+          <a:prstGeom prst="rect">
+            <a:avLst/>
+          </a:prstGeom>
+          <a:noFill/>
+        </p:spPr>
+        <p:txBody>
+          <a:bodyPr wrap="square" lIns="0" rIns="0" tIns="0" bIns="0" anchor="t">
+            <a:spAutoFit/>
+          </a:bodyPr>
+          <a:lstStyle/>
+          <a:p>
+            <a:pPr algn="l"/>
+            <a:r>
+              <a:rPr sz="2000" b="1" i="0">
                 <a:solidFill>
                   <a:srgbClr val="1E2A3B"/>
                 </a:solidFill>
+                <a:latin typeface="Cambria"/>
+              </a:rPr>
+              <a:t>4  Response</a:t>
+            </a:r>
+          </a:p>
+        </p:txBody>
+      </p:sp>
+      <p:sp>
+        <p:nvSpPr>
+          <p:cNvPr id="18" name="TextBox 17"/>
+          <p:cNvSpPr txBox="1"/>
+          <p:nvPr/>
+        </p:nvSpPr>
+        <p:spPr>
+          <a:xfrm>
+            <a:off x="7488936" y="3154680"/>
+            <a:ext cx="1627632" cy="2194560"/>
+          </a:xfrm>
+          <a:prstGeom prst="rect">
+            <a:avLst/>
+          </a:prstGeom>
+          <a:noFill/>
+        </p:spPr>
+        <p:txBody>
+          <a:bodyPr wrap="square" lIns="0" rIns="0" tIns="0" bIns="0" anchor="t">
+            <a:spAutoFit/>
+          </a:bodyPr>
+          <a:lstStyle/>
+          <a:p>
+            <a:pPr algn="l"/>
+            <a:r>
+              <a:rPr sz="1600" b="0" i="0">
+                <a:solidFill>
+                  <a:srgbClr val="1E2A3B"/>
+                </a:solidFill>
                 <a:latin typeface="Calibri"/>
               </a:rPr>
-              <a:t>Every path between the modules is register to register</a:t>
-            </a:r>
-          </a:p>
-        </p:txBody>
-      </p:sp>
-      <p:sp>
-        <p:nvSpPr>
-          <p:cNvPr id="9" name="Footer"/>
+              <a:t>After WLAST it sends one B response: OKAY, with BID copied from AWID.</a:t>
+            </a:r>
+          </a:p>
+        </p:txBody>
+      </p:sp>
+      <p:cxnSp>
+        <p:nvCxnSpPr>
+          <p:cNvPr id="19" name="Connector 18"/>
+          <p:cNvCxnSpPr/>
+          <p:nvPr/>
+        </p:nvCxnSpPr>
+        <p:spPr>
+          <a:xfrm>
+            <a:off x="9317736" y="3749039"/>
+            <a:ext cx="192024" cy="0"/>
+          </a:xfrm>
+          <a:prstGeom prst="line">
+            <a:avLst/>
+          </a:prstGeom>
+          <a:ln w="25400">
+            <a:solidFill>
+              <a:srgbClr val="4F5F74"/>
+            </a:solidFill>
+            <a:tailEnd type="triangle" w="med" len="med"/>
+          </a:ln>
+        </p:spPr>
+        <p:style>
+          <a:lnRef idx="2">
+            <a:schemeClr val="accent1"/>
+          </a:lnRef>
+          <a:fillRef idx="0">
+            <a:schemeClr val="accent1"/>
+          </a:fillRef>
+          <a:effectRef idx="1">
+            <a:schemeClr val="accent1"/>
+          </a:effectRef>
+          <a:fontRef idx="minor">
+            <a:schemeClr val="tx1"/>
+          </a:fontRef>
+        </p:style>
+      </p:cxnSp>
+      <p:sp>
+        <p:nvSpPr>
+          <p:cNvPr id="20" name="Rounded Rectangle 19"/>
+          <p:cNvSpPr/>
+          <p:nvPr/>
+        </p:nvSpPr>
+        <p:spPr>
+          <a:xfrm>
+            <a:off x="9528048" y="2057400"/>
+            <a:ext cx="1993392" cy="3383280"/>
+          </a:xfrm>
+          <a:prstGeom prst="roundRect">
+            <a:avLst>
+              <a:gd name="adj" fmla="val 6000"/>
+            </a:avLst>
+          </a:prstGeom>
+          <a:solidFill>
+            <a:srgbClr val="D9F0E3"/>
+          </a:solidFill>
+          <a:ln>
+            <a:noFill/>
+          </a:ln>
+          <a:effectLst/>
+        </p:spPr>
+        <p:style>
+          <a:lnRef idx="1">
+            <a:schemeClr val="accent1"/>
+          </a:lnRef>
+          <a:fillRef idx="3">
+            <a:schemeClr val="accent1"/>
+          </a:fillRef>
+          <a:effectRef idx="2">
+            <a:schemeClr val="accent1"/>
+          </a:effectRef>
+          <a:fontRef idx="minor">
+            <a:schemeClr val="lt1"/>
+          </a:fontRef>
+        </p:style>
+        <p:txBody>
+          <a:bodyPr rtlCol="0" anchor="ctr"/>
+          <a:lstStyle/>
+          <a:p/>
+        </p:txBody>
+      </p:sp>
+      <p:sp>
+        <p:nvSpPr>
+          <p:cNvPr id="21" name="TextBox 20"/>
+          <p:cNvSpPr txBox="1"/>
+          <p:nvPr/>
+        </p:nvSpPr>
+        <p:spPr>
+          <a:xfrm>
+            <a:off x="9710928" y="2240280"/>
+            <a:ext cx="1627632" cy="822960"/>
+          </a:xfrm>
+          <a:prstGeom prst="rect">
+            <a:avLst/>
+          </a:prstGeom>
+          <a:noFill/>
+        </p:spPr>
+        <p:txBody>
+          <a:bodyPr wrap="square" lIns="0" rIns="0" tIns="0" bIns="0" anchor="t">
+            <a:spAutoFit/>
+          </a:bodyPr>
+          <a:lstStyle/>
+          <a:p>
+            <a:pPr algn="l"/>
+            <a:r>
+              <a:rPr sz="2000" b="1" i="0">
+                <a:solidFill>
+                  <a:srgbClr val="1E2A3B"/>
+                </a:solidFill>
+                <a:latin typeface="Cambria"/>
+              </a:rPr>
+              <a:t>5  Done</a:t>
+            </a:r>
+          </a:p>
+        </p:txBody>
+      </p:sp>
+      <p:sp>
+        <p:nvSpPr>
+          <p:cNvPr id="22" name="TextBox 21"/>
+          <p:cNvSpPr txBox="1"/>
+          <p:nvPr/>
+        </p:nvSpPr>
+        <p:spPr>
+          <a:xfrm>
+            <a:off x="9710928" y="3154680"/>
+            <a:ext cx="1627632" cy="2194560"/>
+          </a:xfrm>
+          <a:prstGeom prst="rect">
+            <a:avLst/>
+          </a:prstGeom>
+          <a:noFill/>
+        </p:spPr>
+        <p:txBody>
+          <a:bodyPr wrap="square" lIns="0" rIns="0" tIns="0" bIns="0" anchor="t">
+            <a:spAutoFit/>
+          </a:bodyPr>
+          <a:lstStyle/>
+          <a:p>
+            <a:pPr algn="l"/>
+            <a:r>
+              <a:rPr sz="1600" b="0" i="0">
+                <a:solidFill>
+                  <a:srgbClr val="1E2A3B"/>
+                </a:solidFill>
+                <a:latin typeface="Calibri"/>
+              </a:rPr>
+              <a:t>The master takes the response and pulses cmd_done. The burst kept it busy for 6 cycles.</a:t>
+            </a:r>
+          </a:p>
+        </p:txBody>
+      </p:sp>
+      <p:sp>
+        <p:nvSpPr>
+          <p:cNvPr id="23" name="TextBox 22"/>
+          <p:cNvSpPr txBox="1"/>
+          <p:nvPr/>
+        </p:nvSpPr>
+        <p:spPr>
+          <a:xfrm>
+            <a:off x="640080" y="5760720"/>
+            <a:ext cx="10881360" cy="457200"/>
+          </a:xfrm>
+          <a:prstGeom prst="rect">
+            <a:avLst/>
+          </a:prstGeom>
+          <a:noFill/>
+        </p:spPr>
+        <p:txBody>
+          <a:bodyPr wrap="square" lIns="0" rIns="0" tIns="0" bIns="0" anchor="t">
+            <a:spAutoFit/>
+          </a:bodyPr>
+          <a:lstStyle/>
+          <a:p>
+            <a:pPr algn="l"/>
+            <a:r>
+              <a:rPr sz="1600" b="0" i="1">
+                <a:solidFill>
+                  <a:srgbClr val="4F5F74"/>
+                </a:solidFill>
+                <a:latin typeface="Calibri"/>
+              </a:rPr>
+              <a:t>The waveforms on the next two slides show the same write and the matching read.</a:t>
+            </a:r>
+          </a:p>
+        </p:txBody>
+      </p:sp>
+      <p:sp>
+        <p:nvSpPr>
+          <p:cNvPr id="24" name="Footer"/>
           <p:cNvSpPr txBox="1"/>
           <p:nvPr/>
         </p:nvSpPr>
@@ -5402,14 +5942,14 @@
                 </a:solidFill>
                 <a:latin typeface="Calibri"/>
               </a:rPr>
-              <a:t>AXI4 manager, subordinate and registered channels</a:t>
-            </a:r>
-          </a:p>
-        </p:txBody>
-      </p:sp>
-      <p:sp>
-        <p:nvSpPr>
-          <p:cNvPr id="10" name="Page number"/>
+              <a:t>AXI4 manager and subordinate in Verilog</a:t>
+            </a:r>
+          </a:p>
+        </p:txBody>
+      </p:sp>
+      <p:sp>
+        <p:nvSpPr>
+          <p:cNvPr id="25" name="Page number"/>
           <p:cNvSpPr txBox="1"/>
           <p:nvPr/>
         </p:nvSpPr>
@@ -5505,7 +6045,7 @@
       </p:sp>
       <p:pic>
         <p:nvPicPr>
-          <p:cNvPr id="3" name="Picture 2" descr="Waveform of a 4-beat write through the flip-flop stages."/>
+          <p:cNvPr id="3" name="Picture 2" descr="Waveform of a 4-beat write on the bare design."/>
           <p:cNvPicPr>
             <a:picLocks noChangeAspect="1"/>
           </p:cNvPicPr>
@@ -5519,8 +6059,8 @@
         </p:blipFill>
         <p:spPr>
           <a:xfrm>
-            <a:off x="640080" y="1325880"/>
-            <a:ext cx="7575104" cy="4846320"/>
+            <a:off x="640080" y="1371600"/>
+            <a:ext cx="7680960" cy="4593992"/>
           </a:xfrm>
           <a:prstGeom prst="rect">
             <a:avLst/>
@@ -5593,7 +6133,7 @@
                 </a:solidFill>
                 <a:latin typeface="Calibri"/>
               </a:rPr>
-              <a:t>Slave side is one cycle after master side: that is the flip-flop stage.</a:t>
+              <a:t>WREADY stays low in cycle 1: the subordinate takes the address first.</a:t>
             </a:r>
           </a:p>
           <a:p>
@@ -5609,7 +6149,7 @@
                 </a:solidFill>
                 <a:latin typeface="Calibri"/>
               </a:rPr>
-              <a:t>Master WREADY dips at cycle 3 while the slave waits for the address.</a:t>
+              <a:t>Four beats at cycles 2 to 5, WLAST on the fourth.</a:t>
             </a:r>
           </a:p>
           <a:p>
@@ -5625,7 +6165,7 @@
                 </a:solidFill>
                 <a:latin typeface="Calibri"/>
               </a:rPr>
-              <a:t>Four beats, WLAST on the fourth, busy for 8 cycles.</a:t>
+              <a:t>One response at cycle 6, cmd_done at 7. Busy for 6 cycles.</a:t>
             </a:r>
           </a:p>
         </p:txBody>
@@ -5660,7 +6200,7 @@
                 </a:solidFill>
                 <a:latin typeface="Calibri"/>
               </a:rPr>
-              <a:t>AXI4 manager, subordinate and registered channels</a:t>
+              <a:t>AXI4 manager and subordinate in Verilog</a:t>
             </a:r>
           </a:p>
         </p:txBody>
@@ -5763,7 +6303,7 @@
       </p:sp>
       <p:pic>
         <p:nvPicPr>
-          <p:cNvPr id="3" name="Picture 2" descr="Waveform of a 4-beat read through the flip-flop stages."/>
+          <p:cNvPr id="3" name="Picture 2" descr="Waveform of a 4-beat read on the bare design."/>
           <p:cNvPicPr>
             <a:picLocks noChangeAspect="1"/>
           </p:cNvPicPr>
@@ -5778,7 +6318,7 @@
         <p:spPr>
           <a:xfrm>
             <a:off x="640080" y="1828800"/>
-            <a:ext cx="7589520" cy="3543234"/>
+            <a:ext cx="7589520" cy="4108809"/>
           </a:xfrm>
           <a:prstGeom prst="rect">
             <a:avLst/>
@@ -5835,7 +6375,7 @@
                 </a:solidFill>
                 <a:latin typeface="Calibri"/>
               </a:rPr>
-              <a:t>One address, then four beats.</a:t>
+              <a:t>One address at cycle 1.</a:t>
             </a:r>
           </a:p>
           <a:p>
@@ -5851,7 +6391,7 @@
                 </a:solidFill>
                 <a:latin typeface="Calibri"/>
               </a:rPr>
-              <a:t>Beats arrive at cycles 5, 6, 7 and 8, one per clock, no gaps.</a:t>
+              <a:t>Four beats at cycles 2 to 5, one per clock, no gaps.</a:t>
             </a:r>
           </a:p>
           <a:p>
@@ -5867,7 +6407,7 @@
                 </a:solidFill>
                 <a:latin typeface="Calibri"/>
               </a:rPr>
-              <a:t>RLAST rides on the fourth beat.</a:t>
+              <a:t>RLAST rides on the fourth beat. cmd_done at 6. Busy for 5 cycles.</a:t>
             </a:r>
           </a:p>
         </p:txBody>
@@ -5902,7 +6442,7 @@
                 </a:solidFill>
                 <a:latin typeface="Calibri"/>
               </a:rPr>
-              <a:t>AXI4 manager, subordinate and registered channels</a:t>
+              <a:t>AXI4 manager and subordinate in Verilog</a:t>
             </a:r>
           </a:p>
         </p:txBody>
@@ -6147,7 +6687,7 @@
                 </a:solidFill>
                 <a:latin typeface="Cambria"/>
               </a:rPr>
-              <a:t>45</a:t>
+              <a:t>38</a:t>
             </a:r>
           </a:p>
         </p:txBody>
@@ -6217,7 +6757,7 @@
                 </a:solidFill>
                 <a:latin typeface="Calibri"/>
               </a:rPr>
-              <a:t>Testbench plays the manager: AW before W, W before AW, response stalls, WRAP, FIXED, byte strobes, bad addresses, ID echo, narrow beats.</a:t>
+              <a:t>Testbench plays the manager: AW before W, stalled responses, WRAP, FIXED, INCR, byte strobes, ID echo, narrow 1-byte beats.</a:t>
             </a:r>
           </a:p>
         </p:txBody>
@@ -6366,7 +6906,7 @@
                 </a:solidFill>
                 <a:latin typeface="Cambria"/>
               </a:rPr>
-              <a:t>52</a:t>
+              <a:t>46</a:t>
             </a:r>
           </a:p>
         </p:txBody>
@@ -6550,7 +7090,7 @@
                 </a:solidFill>
                 <a:latin typeface="Cambria"/>
               </a:rPr>
-              <a:t>Whole system, run twice</a:t>
+              <a:t>Whole system</a:t>
             </a:r>
           </a:p>
         </p:txBody>
@@ -6585,7 +7125,7 @@
                 </a:solidFill>
                 <a:latin typeface="Cambria"/>
               </a:rPr>
-              <a:t>77 × 2</a:t>
+              <a:t>72</a:t>
             </a:r>
           </a:p>
         </p:txBody>
@@ -6655,7 +7195,7 @@
                 </a:solidFill>
                 <a:latin typeface="Calibri"/>
               </a:rPr>
-              <a:t>With and without the flip-flop stages. All burst types, errors, back-pressure, throughput and a mid-burst reset.</a:t>
+              <a:t>All burst types, byte strobes, host back-pressure, throughput and a reset in the middle of a burst.</a:t>
             </a:r>
           </a:p>
         </p:txBody>
@@ -6734,7 +7274,7 @@
                 </a:solidFill>
                 <a:latin typeface="Calibri"/>
               </a:rPr>
-              <a:t>Total: 45 + 52 + 77 + 77 = 251 checks, 0 failing.   Run it:  .\run_tests.ps1</a:t>
+              <a:t>Total: 38 + 46 + 72 = 156 checks, 0 failing.   Run it:  .\run_tests.ps1</a:t>
             </a:r>
           </a:p>
         </p:txBody>
@@ -6769,7 +7309,7 @@
                 </a:solidFill>
                 <a:latin typeface="Calibri"/>
               </a:rPr>
-              <a:t>AXI4 manager, subordinate and registered channels</a:t>
+              <a:t>AXI4 manager and subordinate in Verilog</a:t>
             </a:r>
           </a:p>
         </p:txBody>
@@ -6944,7 +7484,7 @@
                 </a:solidFill>
                 <a:latin typeface="Cambria"/>
               </a:rPr>
-              <a:t>251 / 251</a:t>
+              <a:t>156 / 156</a:t>
             </a:r>
           </a:p>
         </p:txBody>
@@ -6993,6 +7533,120 @@
         <p:spPr>
           <a:xfrm>
             <a:off x="4334256" y="1417320"/>
+            <a:ext cx="3493008" cy="1920240"/>
+          </a:xfrm>
+          <a:prstGeom prst="roundRect">
+            <a:avLst>
+              <a:gd name="adj" fmla="val 6000"/>
+            </a:avLst>
+          </a:prstGeom>
+          <a:solidFill>
+            <a:srgbClr val="D6E6FF"/>
+          </a:solidFill>
+          <a:ln>
+            <a:noFill/>
+          </a:ln>
+          <a:effectLst/>
+        </p:spPr>
+        <p:style>
+          <a:lnRef idx="1">
+            <a:schemeClr val="accent1"/>
+          </a:lnRef>
+          <a:fillRef idx="3">
+            <a:schemeClr val="accent1"/>
+          </a:fillRef>
+          <a:effectRef idx="2">
+            <a:schemeClr val="accent1"/>
+          </a:effectRef>
+          <a:fontRef idx="minor">
+            <a:schemeClr val="lt1"/>
+          </a:fontRef>
+        </p:style>
+        <p:txBody>
+          <a:bodyPr rtlCol="0" anchor="ctr"/>
+          <a:lstStyle/>
+          <a:p/>
+        </p:txBody>
+      </p:sp>
+      <p:sp>
+        <p:nvSpPr>
+          <p:cNvPr id="7" name="TextBox 6"/>
+          <p:cNvSpPr txBox="1"/>
+          <p:nvPr/>
+        </p:nvSpPr>
+        <p:spPr>
+          <a:xfrm>
+            <a:off x="4608576" y="1691640"/>
+            <a:ext cx="3017520" cy="731520"/>
+          </a:xfrm>
+          <a:prstGeom prst="rect">
+            <a:avLst/>
+          </a:prstGeom>
+          <a:noFill/>
+        </p:spPr>
+        <p:txBody>
+          <a:bodyPr wrap="square" lIns="0" rIns="0" tIns="0" bIns="0" anchor="t">
+            <a:spAutoFit/>
+          </a:bodyPr>
+          <a:lstStyle/>
+          <a:p>
+            <a:pPr algn="l"/>
+            <a:r>
+              <a:rPr sz="3800" b="1" i="0">
+                <a:solidFill>
+                  <a:srgbClr val="1E2A3B"/>
+                </a:solidFill>
+                <a:latin typeface="Cambria"/>
+              </a:rPr>
+              <a:t>1 beat / clock</a:t>
+            </a:r>
+          </a:p>
+        </p:txBody>
+      </p:sp>
+      <p:sp>
+        <p:nvSpPr>
+          <p:cNvPr id="8" name="TextBox 7"/>
+          <p:cNvSpPr txBox="1"/>
+          <p:nvPr/>
+        </p:nvSpPr>
+        <p:spPr>
+          <a:xfrm>
+            <a:off x="4608576" y="2606040"/>
+            <a:ext cx="3017520" cy="457200"/>
+          </a:xfrm>
+          <a:prstGeom prst="rect">
+            <a:avLst/>
+          </a:prstGeom>
+          <a:noFill/>
+        </p:spPr>
+        <p:txBody>
+          <a:bodyPr wrap="square" lIns="0" rIns="0" tIns="0" bIns="0" anchor="t">
+            <a:spAutoFit/>
+          </a:bodyPr>
+          <a:lstStyle/>
+          <a:p>
+            <a:pPr algn="l"/>
+            <a:r>
+              <a:rPr sz="1600" b="0" i="0">
+                <a:solidFill>
+                  <a:srgbClr val="4F5F74"/>
+                </a:solidFill>
+                <a:latin typeface="Calibri"/>
+              </a:rPr>
+              <a:t>sustained throughput</a:t>
+            </a:r>
+          </a:p>
+        </p:txBody>
+      </p:sp>
+      <p:sp>
+        <p:nvSpPr>
+          <p:cNvPr id="9" name="Rounded Rectangle 8"/>
+          <p:cNvSpPr/>
+          <p:nvPr/>
+        </p:nvSpPr>
+        <p:spPr>
+          <a:xfrm>
+            <a:off x="8028432" y="1417320"/>
             <a:ext cx="3493008" cy="1920240"/>
           </a:xfrm>
           <a:prstGeom prst="roundRect">
@@ -7030,120 +7684,6 @@
       </p:sp>
       <p:sp>
         <p:nvSpPr>
-          <p:cNvPr id="7" name="TextBox 6"/>
-          <p:cNvSpPr txBox="1"/>
-          <p:nvPr/>
-        </p:nvSpPr>
-        <p:spPr>
-          <a:xfrm>
-            <a:off x="4608576" y="1691640"/>
-            <a:ext cx="3017520" cy="731520"/>
-          </a:xfrm>
-          <a:prstGeom prst="rect">
-            <a:avLst/>
-          </a:prstGeom>
-          <a:noFill/>
-        </p:spPr>
-        <p:txBody>
-          <a:bodyPr wrap="square" lIns="0" rIns="0" tIns="0" bIns="0" anchor="t">
-            <a:spAutoFit/>
-          </a:bodyPr>
-          <a:lstStyle/>
-          <a:p>
-            <a:pPr algn="l"/>
-            <a:r>
-              <a:rPr sz="3800" b="1" i="0">
-                <a:solidFill>
-                  <a:srgbClr val="1E2A3B"/>
-                </a:solidFill>
-                <a:latin typeface="Cambria"/>
-              </a:rPr>
-              <a:t>+2 cycles</a:t>
-            </a:r>
-          </a:p>
-        </p:txBody>
-      </p:sp>
-      <p:sp>
-        <p:nvSpPr>
-          <p:cNvPr id="8" name="TextBox 7"/>
-          <p:cNvSpPr txBox="1"/>
-          <p:nvPr/>
-        </p:nvSpPr>
-        <p:spPr>
-          <a:xfrm>
-            <a:off x="4608576" y="2606040"/>
-            <a:ext cx="3017520" cy="457200"/>
-          </a:xfrm>
-          <a:prstGeom prst="rect">
-            <a:avLst/>
-          </a:prstGeom>
-          <a:noFill/>
-        </p:spPr>
-        <p:txBody>
-          <a:bodyPr wrap="square" lIns="0" rIns="0" tIns="0" bIns="0" anchor="t">
-            <a:spAutoFit/>
-          </a:bodyPr>
-          <a:lstStyle/>
-          <a:p>
-            <a:pPr algn="l"/>
-            <a:r>
-              <a:rPr sz="1600" b="0" i="0">
-                <a:solidFill>
-                  <a:srgbClr val="4F5F74"/>
-                </a:solidFill>
-                <a:latin typeface="Calibri"/>
-              </a:rPr>
-              <a:t>fixed cost of the stages</a:t>
-            </a:r>
-          </a:p>
-        </p:txBody>
-      </p:sp>
-      <p:sp>
-        <p:nvSpPr>
-          <p:cNvPr id="9" name="Rounded Rectangle 8"/>
-          <p:cNvSpPr/>
-          <p:nvPr/>
-        </p:nvSpPr>
-        <p:spPr>
-          <a:xfrm>
-            <a:off x="8028432" y="1417320"/>
-            <a:ext cx="3493008" cy="1920240"/>
-          </a:xfrm>
-          <a:prstGeom prst="roundRect">
-            <a:avLst>
-              <a:gd name="adj" fmla="val 6000"/>
-            </a:avLst>
-          </a:prstGeom>
-          <a:solidFill>
-            <a:srgbClr val="D6E6FF"/>
-          </a:solidFill>
-          <a:ln>
-            <a:noFill/>
-          </a:ln>
-          <a:effectLst/>
-        </p:spPr>
-        <p:style>
-          <a:lnRef idx="1">
-            <a:schemeClr val="accent1"/>
-          </a:lnRef>
-          <a:fillRef idx="3">
-            <a:schemeClr val="accent1"/>
-          </a:fillRef>
-          <a:effectRef idx="2">
-            <a:schemeClr val="accent1"/>
-          </a:effectRef>
-          <a:fontRef idx="minor">
-            <a:schemeClr val="lt1"/>
-          </a:fontRef>
-        </p:style>
-        <p:txBody>
-          <a:bodyPr rtlCol="0" anchor="ctr"/>
-          <a:lstStyle/>
-          <a:p/>
-        </p:txBody>
-      </p:sp>
-      <p:sp>
-        <p:nvSpPr>
           <p:cNvPr id="10" name="TextBox 9"/>
           <p:cNvSpPr txBox="1"/>
           <p:nvPr/>
@@ -7172,7 +7712,7 @@
                 </a:solidFill>
                 <a:latin typeface="Cambria"/>
               </a:rPr>
-              <a:t>1 beat / clock</a:t>
+              <a:t>35 cycles</a:t>
             </a:r>
           </a:p>
         </p:txBody>
@@ -7207,7 +7747,7 @@
                 </a:solidFill>
                 <a:latin typeface="Calibri"/>
               </a:rPr>
-              <a:t>sustained throughput</a:t>
+              <a:t>a 32-beat write</a:t>
             </a:r>
           </a:p>
         </p:txBody>
@@ -7271,7 +7811,7 @@
                           </a:solidFill>
                           <a:latin typeface="Calibri"/>
                         </a:rPr>
-                        <a:t>With flip-flop stages</a:t>
+                        <a:t>Cycles, start to done</a:t>
                       </a:r>
                     </a:p>
                   </a:txBody>
@@ -7293,7 +7833,7 @@
                           </a:solidFill>
                           <a:latin typeface="Calibri"/>
                         </a:rPr>
-                        <a:t>Wired directly</a:t>
+                        <a:t>Beats</a:t>
                       </a:r>
                     </a:p>
                   </a:txBody>
@@ -7315,7 +7855,7 @@
                           </a:solidFill>
                           <a:latin typeface="Calibri"/>
                         </a:rPr>
-                        <a:t>Difference</a:t>
+                        <a:t>Fixed overhead</a:t>
                       </a:r>
                     </a:p>
                   </a:txBody>
@@ -7361,7 +7901,7 @@
                           </a:solidFill>
                           <a:latin typeface="Calibri"/>
                         </a:rPr>
-                        <a:t>37 cycles</a:t>
+                        <a:t>35</a:t>
                       </a:r>
                     </a:p>
                   </a:txBody>
@@ -7383,7 +7923,7 @@
                           </a:solidFill>
                           <a:latin typeface="Calibri"/>
                         </a:rPr>
-                        <a:t>35 cycles</a:t>
+                        <a:t>32</a:t>
                       </a:r>
                     </a:p>
                   </a:txBody>
@@ -7405,7 +7945,7 @@
                           </a:solidFill>
                           <a:latin typeface="Calibri"/>
                         </a:rPr>
-                        <a:t>+2</a:t>
+                        <a:t>3 cycles</a:t>
                       </a:r>
                     </a:p>
                   </a:txBody>
@@ -7451,7 +7991,7 @@
                           </a:solidFill>
                           <a:latin typeface="Calibri"/>
                         </a:rPr>
-                        <a:t>36 cycles</a:t>
+                        <a:t>34</a:t>
                       </a:r>
                     </a:p>
                   </a:txBody>
@@ -7473,7 +8013,7 @@
                           </a:solidFill>
                           <a:latin typeface="Calibri"/>
                         </a:rPr>
-                        <a:t>34 cycles</a:t>
+                        <a:t>32</a:t>
                       </a:r>
                     </a:p>
                   </a:txBody>
@@ -7495,7 +8035,7 @@
                           </a:solidFill>
                           <a:latin typeface="Calibri"/>
                         </a:rPr>
-                        <a:t>+2</a:t>
+                        <a:t>2 cycles</a:t>
                       </a:r>
                     </a:p>
                   </a:txBody>
@@ -7540,7 +8080,7 @@
                 </a:solidFill>
                 <a:latin typeface="Calibri"/>
               </a:rPr>
-              <a:t>32 beats cannot take fewer than 32 cycles, so the extra cycles are the entire cost of the stages. It does not grow with burst length.</a:t>
+              <a:t>The overhead is the address and response handshakes. It does not grow with burst length.</a:t>
             </a:r>
           </a:p>
         </p:txBody>
@@ -7575,7 +8115,7 @@
                 </a:solidFill>
                 <a:latin typeface="Calibri"/>
               </a:rPr>
-              <a:t>AXI4 manager, subordinate and registered channels</a:t>
+              <a:t>AXI4 manager and subordinate in Verilog</a:t>
             </a:r>
           </a:p>
         </p:txBody>
@@ -7864,7 +8404,7 @@
                 </a:solidFill>
                 <a:latin typeface="Cambria"/>
               </a:rPr>
-              <a:t>No exclusive access</a:t>
+              <a:t>No error responses</a:t>
             </a:r>
           </a:p>
         </p:txBody>
@@ -7899,7 +8439,7 @@
                 </a:solidFill>
                 <a:latin typeface="Calibri"/>
               </a:rPr>
-              <a:t>AxLOCK is 0, EXOKAY never returned. CACHE, PROT and QOS are carried, not used.</a:t>
+              <a:t>Every response is OKAY. A bad address wraps inside the 4 KiB.</a:t>
             </a:r>
           </a:p>
         </p:txBody>
@@ -7978,7 +8518,7 @@
                 </a:solidFill>
                 <a:latin typeface="Cambria"/>
               </a:rPr>
-              <a:t>Narrow reads return the word</a:t>
+              <a:t>No exclusive access</a:t>
             </a:r>
           </a:p>
         </p:txBody>
@@ -8013,7 +8553,7 @@
                 </a:solidFill>
                 <a:latin typeface="Calibri"/>
               </a:rPr>
-              <a:t>The subordinate does not mask other byte lanes. Legal: the manager picks its lanes.</a:t>
+              <a:t>AxLOCK is 0, EXOKAY never returned. CACHE, PROT and QOS are carried, not used.</a:t>
             </a:r>
           </a:p>
         </p:txBody>
@@ -8092,7 +8632,7 @@
                 </a:solidFill>
                 <a:latin typeface="Cambria"/>
               </a:rPr>
-              <a:t>Start address is range-checked</a:t>
+              <a:t>Narrow reads return the word</a:t>
             </a:r>
           </a:p>
         </p:txBody>
@@ -8127,7 +8667,7 @@
                 </a:solidFill>
                 <a:latin typeface="Calibri"/>
               </a:rPr>
-              <a:t>Safe for legal bursts, which cannot cross a 4 KiB boundary.</a:t>
+              <a:t>The subordinate does not mask other byte lanes. Legal: the manager picks its lanes.</a:t>
             </a:r>
           </a:p>
         </p:txBody>
@@ -8206,7 +8746,7 @@
                 </a:solidFill>
                 <a:latin typeface="Cambria"/>
               </a:rPr>
-              <a:t>Host streams are not registered</a:t>
+              <a:t>Host streams pass straight through</a:t>
             </a:r>
           </a:p>
         </p:txBody>
@@ -8241,7 +8781,7 @@
                 </a:solidFill>
                 <a:latin typeface="Calibri"/>
               </a:rPr>
-              <a:t>A state-gated pass-through inside the manager. The stages follow immediately.</a:t>
+              <a:t>A state-gated pass-through inside the manager, not registered.</a:t>
             </a:r>
           </a:p>
         </p:txBody>
@@ -8355,7 +8895,7 @@
                 </a:solidFill>
                 <a:latin typeface="Calibri"/>
               </a:rPr>
-              <a:t>Beats still in the stages are discarded. The outcome is undefined, so it is not asserted.</a:t>
+              <a:t>The memory is not cleared by reset. Which beats landed is undefined, so it is not asserted.</a:t>
             </a:r>
           </a:p>
         </p:txBody>
@@ -8390,7 +8930,7 @@
                 </a:solidFill>
                 <a:latin typeface="Calibri"/>
               </a:rPr>
-              <a:t>AXI4 manager, subordinate and registered channels</a:t>
+              <a:t>AXI4 manager and subordinate in Verilog</a:t>
             </a:r>
           </a:p>
         </p:txBody>
@@ -8675,7 +9215,7 @@
                 </a:solidFill>
                 <a:latin typeface="Calibri"/>
               </a:rPr>
-              <a:t>Four suites, each ending TEST PASSED</a:t>
+              <a:t>Three suites, each ending TEST PASSED</a:t>
             </a:r>
           </a:p>
           <a:p>
@@ -8691,7 +9231,7 @@
                 </a:solidFill>
                 <a:latin typeface="Calibri"/>
               </a:rPr>
-              <a:t>Check counts: 45, 52, 77 and 77</a:t>
+              <a:t>Check counts: 38, 46 and 72</a:t>
             </a:r>
           </a:p>
           <a:p>
@@ -8707,7 +9247,7 @@
                 </a:solidFill>
                 <a:latin typeface="Calibri"/>
               </a:rPr>
-              <a:t>In the waveform: slave side lags master side by one cycle</a:t>
+              <a:t>In the waveform: WREADY waits for the address</a:t>
             </a:r>
           </a:p>
         </p:txBody>
@@ -8837,7 +9377,7 @@
                 </a:solidFill>
                 <a:latin typeface="Calibri"/>
               </a:rPr>
-              <a:t>AXI4 manager, subordinate and registered channels</a:t>
+              <a:t>AXI4 manager and subordinate in Verilog</a:t>
             </a:r>
           </a:p>
         </p:txBody>
@@ -9126,7 +9666,7 @@
                 </a:solidFill>
                 <a:latin typeface="Cambria"/>
               </a:rPr>
-              <a:t>Why not a single flip-flop per wire?</a:t>
+              <a:t>How does it know a burst ended?</a:t>
             </a:r>
           </a:p>
         </p:txBody>
@@ -9161,7 +9701,7 @@
                 </a:solidFill>
                 <a:latin typeface="Calibri"/>
               </a:rPr>
-              <a:t>READY arrives one cycle late and a beat is lost. The spare slot catches that one beat.</a:t>
+              <a:t>On writes, from WLAST. On reads, by counting ARLEN + 1 beats.</a:t>
             </a:r>
           </a:p>
         </p:txBody>
@@ -9240,7 +9780,7 @@
                 </a:solidFill>
                 <a:latin typeface="Cambria"/>
               </a:rPr>
-              <a:t>Why check WLAST if the length is known?</a:t>
+              <a:t>What happens on a bad address?</a:t>
             </a:r>
           </a:p>
         </p:txBody>
@@ -9275,7 +9815,7 @@
                 </a:solidFill>
                 <a:latin typeface="Calibri"/>
               </a:rPr>
-              <a:t>It is a cross-check. A mismatch ends the burst safely and returns SLVERR.</a:t>
+              <a:t>Nothing is checked. The address wraps inside the 4 KiB and the response is OKAY.</a:t>
             </a:r>
           </a:p>
         </p:txBody>
@@ -9468,7 +10008,7 @@
                 </a:solidFill>
                 <a:latin typeface="Cambria"/>
               </a:rPr>
-              <a:t>What if the address is bad mid-burst?</a:t>
+              <a:t>Why does WREADY wait for the address?</a:t>
             </a:r>
           </a:p>
         </p:txBody>
@@ -9503,7 +10043,7 @@
                 </a:solidFill>
                 <a:latin typeface="Calibri"/>
               </a:rPr>
-              <a:t>The subordinate still accepts every beat, skips the write, and returns DECERR once.</a:t>
+              <a:t>The subordinate takes the address first, then the data. The standard allows it.</a:t>
             </a:r>
           </a:p>
         </p:txBody>
@@ -9582,7 +10122,7 @@
                 </a:solidFill>
                 <a:latin typeface="Cambria"/>
               </a:rPr>
-              <a:t>What does the stage cost?</a:t>
+              <a:t>What limits throughput?</a:t>
             </a:r>
           </a:p>
         </p:txBody>
@@ -9617,7 +10157,7 @@
                 </a:solidFill>
                 <a:latin typeface="Calibri"/>
               </a:rPr>
-              <a:t>Two cycles per transaction, fixed. Throughput stays at one beat per clock.</a:t>
+              <a:t>One beat per clock, plus a few cycles of address and response overhead: 35 cycles for 32 beats.</a:t>
             </a:r>
           </a:p>
         </p:txBody>
@@ -9652,7 +10192,7 @@
                 </a:solidFill>
                 <a:latin typeface="Calibri"/>
               </a:rPr>
-              <a:t>AXI4 manager, subordinate and registered channels</a:t>
+              <a:t>AXI4 manager and subordinate in Verilog</a:t>
             </a:r>
           </a:p>
         </p:txBody>
@@ -9783,7 +10323,7 @@
                 </a:solidFill>
                 <a:latin typeface="Calibri"/>
               </a:rPr>
-              <a:t>Both ends of an AXI4 connection, and the registers between them.</a:t>
+              <a:t>Both ends of an AXI4 connection, wired together.</a:t>
             </a:r>
           </a:p>
         </p:txBody>
@@ -10081,7 +10621,7 @@
                 </a:solidFill>
                 <a:latin typeface="Calibri"/>
               </a:rPr>
-              <a:t>A 4 KiB memory. Accepts bursts of 1 to 256 beats in FIXED, INCR or WRAP order, and answers OKAY or an error.</a:t>
+              <a:t>A 4 KiB memory. Accepts bursts of 1 to 256 beats in FIXED, INCR or WRAP order and answers OKAY.</a:t>
             </a:r>
           </a:p>
         </p:txBody>
@@ -10103,7 +10643,7 @@
             </a:avLst>
           </a:prstGeom>
           <a:solidFill>
-            <a:srgbClr val="FFE9A8"/>
+            <a:srgbClr val="D9F0E3"/>
           </a:solidFill>
           <a:ln>
             <a:noFill/>
@@ -10160,7 +10700,7 @@
                 </a:solidFill>
                 <a:latin typeface="Cambria"/>
               </a:rPr>
-              <a:t>Flip-flop stages</a:t>
+              <a:t>Top level</a:t>
             </a:r>
           </a:p>
         </p:txBody>
@@ -10195,7 +10735,7 @@
                 </a:solidFill>
                 <a:latin typeface="Consolas"/>
               </a:rPr>
-              <a:t>axi4_skid_buffer.v</a:t>
+              <a:t>axi4_top.v</a:t>
             </a:r>
           </a:p>
         </p:txBody>
@@ -10230,7 +10770,7 @@
                 </a:solidFill>
                 <a:latin typeface="Calibri"/>
               </a:rPr>
-              <a:t>One registered stage per channel, so nothing crosses between the two modules combinationally.</a:t>
+              <a:t>Wires the manager directly to the subordinate over the five AXI channels. Nothing sits between them.</a:t>
             </a:r>
           </a:p>
         </p:txBody>
@@ -10300,7 +10840,7 @@
                 </a:solidFill>
                 <a:latin typeface="Calibri"/>
               </a:rPr>
-              <a:t>AXI4 manager, subordinate and registered channels</a:t>
+              <a:t>AXI4 manager and subordinate in Verilog</a:t>
             </a:r>
           </a:p>
         </p:txBody>
@@ -11142,7 +11682,7 @@
                 </a:solidFill>
                 <a:latin typeface="Calibri"/>
               </a:rPr>
-              <a:t>AXI4 manager, subordinate and registered channels</a:t>
+              <a:t>AXI4 manager and subordinate in Verilog</a:t>
             </a:r>
           </a:p>
         </p:txBody>
@@ -13567,7 +14107,7 @@
                 </a:solidFill>
                 <a:latin typeface="Calibri"/>
               </a:rPr>
-              <a:t>AXI4 manager, subordinate and registered channels</a:t>
+              <a:t>AXI4 manager and subordinate in Verilog</a:t>
             </a:r>
           </a:p>
         </p:txBody>
@@ -14684,7 +15224,7 @@
                 </a:solidFill>
                 <a:latin typeface="Calibri"/>
               </a:rPr>
-              <a:t>AXI4 manager, subordinate and registered channels</a:t>
+              <a:t>AXI4 manager and subordinate in Verilog</a:t>
             </a:r>
           </a:p>
         </p:txBody>
@@ -14787,7 +15327,7 @@
       </p:sp>
       <p:pic>
         <p:nvPicPr>
-          <p:cNvPr id="3" name="Picture 2" descr="Block diagram: your logic, axi4_master, five flip-flop stages, axi4_slave with write engine, read engine and 4 KiB memory."/>
+          <p:cNvPr id="3" name="Picture 2" descr="Block diagram: your logic, axi4_master, five AXI4 channels with signal names, axi4_slave with write engine, read engine and 4 KiB memory."/>
           <p:cNvPicPr>
             <a:picLocks noChangeAspect="1"/>
           </p:cNvPicPr>
@@ -14801,8 +15341,8 @@
         </p:blipFill>
         <p:spPr>
           <a:xfrm>
-            <a:off x="822960" y="1280160"/>
-            <a:ext cx="10515600" cy="4282126"/>
+            <a:off x="822960" y="1325880"/>
+            <a:ext cx="10515600" cy="4673600"/>
           </a:xfrm>
           <a:prstGeom prst="rect">
             <a:avLst/>
@@ -14811,58 +15351,14 @@
       </p:pic>
       <p:sp>
         <p:nvSpPr>
-          <p:cNvPr id="4" name="Rounded Rectangle 3"/>
-          <p:cNvSpPr/>
-          <p:nvPr/>
-        </p:nvSpPr>
-        <p:spPr>
-          <a:xfrm>
-            <a:off x="640080" y="5577840"/>
-            <a:ext cx="3493008" cy="713232"/>
-          </a:xfrm>
-          <a:prstGeom prst="roundRect">
-            <a:avLst>
-              <a:gd name="adj" fmla="val 6000"/>
-            </a:avLst>
-          </a:prstGeom>
-          <a:solidFill>
-            <a:srgbClr val="FFFFFF"/>
-          </a:solidFill>
-          <a:ln>
-            <a:noFill/>
-          </a:ln>
-          <a:effectLst/>
-        </p:spPr>
-        <p:style>
-          <a:lnRef idx="1">
-            <a:schemeClr val="accent1"/>
-          </a:lnRef>
-          <a:fillRef idx="3">
-            <a:schemeClr val="accent1"/>
-          </a:fillRef>
-          <a:effectRef idx="2">
-            <a:schemeClr val="accent1"/>
-          </a:effectRef>
-          <a:fontRef idx="minor">
-            <a:schemeClr val="lt1"/>
-          </a:fontRef>
-        </p:style>
-        <p:txBody>
-          <a:bodyPr rtlCol="0" anchor="ctr"/>
-          <a:lstStyle/>
-          <a:p/>
-        </p:txBody>
-      </p:sp>
-      <p:sp>
-        <p:nvSpPr>
-          <p:cNvPr id="5" name="TextBox 4"/>
-          <p:cNvSpPr txBox="1"/>
-          <p:nvPr/>
-        </p:nvSpPr>
-        <p:spPr>
-          <a:xfrm>
-            <a:off x="822959" y="5623560"/>
-            <a:ext cx="3154680" cy="274320"/>
+          <p:cNvPr id="4" name="TextBox 3"/>
+          <p:cNvSpPr txBox="1"/>
+          <p:nvPr/>
+        </p:nvSpPr>
+        <p:spPr>
+          <a:xfrm>
+            <a:off x="640080" y="6080760"/>
+            <a:ext cx="10881360" cy="274320"/>
           </a:xfrm>
           <a:prstGeom prst="rect">
             <a:avLst/>
@@ -14877,283 +15373,20 @@
           <a:p>
             <a:pPr algn="l"/>
             <a:r>
-              <a:rPr sz="1400" b="1" i="0">
-                <a:solidFill>
-                  <a:srgbClr val="1E2A3B"/>
+              <a:rPr sz="1400" b="0" i="1">
+                <a:solidFill>
+                  <a:srgbClr val="4F5F74"/>
                 </a:solidFill>
                 <a:latin typeface="Calibri"/>
               </a:rPr>
-              <a:t>Latched once at start</a:t>
-            </a:r>
-          </a:p>
-        </p:txBody>
-      </p:sp>
-      <p:sp>
-        <p:nvSpPr>
-          <p:cNvPr id="6" name="TextBox 5"/>
-          <p:cNvSpPr txBox="1"/>
-          <p:nvPr/>
-        </p:nvSpPr>
-        <p:spPr>
-          <a:xfrm>
-            <a:off x="822959" y="5916168"/>
-            <a:ext cx="3154680" cy="274320"/>
-          </a:xfrm>
-          <a:prstGeom prst="rect">
-            <a:avLst/>
-          </a:prstGeom>
-          <a:noFill/>
-        </p:spPr>
-        <p:txBody>
-          <a:bodyPr wrap="square" lIns="0" rIns="0" tIns="0" bIns="0" anchor="t">
-            <a:spAutoFit/>
-          </a:bodyPr>
-          <a:lstStyle/>
-          <a:p>
-            <a:pPr algn="l"/>
-            <a:r>
-              <a:rPr sz="1300" b="0" i="0">
-                <a:solidFill>
-                  <a:srgbClr val="4F5F74"/>
-                </a:solidFill>
-                <a:latin typeface="Calibri"/>
-              </a:rPr>
-              <a:t>The bus payload never moves mid-burst.</a:t>
-            </a:r>
-          </a:p>
-        </p:txBody>
-      </p:sp>
-      <p:sp>
-        <p:nvSpPr>
-          <p:cNvPr id="7" name="Rounded Rectangle 6"/>
-          <p:cNvSpPr/>
-          <p:nvPr/>
-        </p:nvSpPr>
-        <p:spPr>
-          <a:xfrm>
-            <a:off x="4334256" y="5577840"/>
-            <a:ext cx="3493008" cy="713232"/>
-          </a:xfrm>
-          <a:prstGeom prst="roundRect">
-            <a:avLst>
-              <a:gd name="adj" fmla="val 6000"/>
-            </a:avLst>
-          </a:prstGeom>
-          <a:solidFill>
-            <a:srgbClr val="FFFFFF"/>
-          </a:solidFill>
-          <a:ln>
-            <a:noFill/>
-          </a:ln>
-          <a:effectLst/>
-        </p:spPr>
-        <p:style>
-          <a:lnRef idx="1">
-            <a:schemeClr val="accent1"/>
-          </a:lnRef>
-          <a:fillRef idx="3">
-            <a:schemeClr val="accent1"/>
-          </a:fillRef>
-          <a:effectRef idx="2">
-            <a:schemeClr val="accent1"/>
-          </a:effectRef>
-          <a:fontRef idx="minor">
-            <a:schemeClr val="lt1"/>
-          </a:fontRef>
-        </p:style>
-        <p:txBody>
-          <a:bodyPr rtlCol="0" anchor="ctr"/>
-          <a:lstStyle/>
-          <a:p/>
-        </p:txBody>
-      </p:sp>
-      <p:sp>
-        <p:nvSpPr>
-          <p:cNvPr id="8" name="TextBox 7"/>
-          <p:cNvSpPr txBox="1"/>
-          <p:nvPr/>
-        </p:nvSpPr>
-        <p:spPr>
-          <a:xfrm>
-            <a:off x="4517136" y="5623560"/>
-            <a:ext cx="3154680" cy="274320"/>
-          </a:xfrm>
-          <a:prstGeom prst="rect">
-            <a:avLst/>
-          </a:prstGeom>
-          <a:noFill/>
-        </p:spPr>
-        <p:txBody>
-          <a:bodyPr wrap="square" lIns="0" rIns="0" tIns="0" bIns="0" anchor="t">
-            <a:spAutoFit/>
-          </a:bodyPr>
-          <a:lstStyle/>
-          <a:p>
-            <a:pPr algn="l"/>
-            <a:r>
-              <a:rPr sz="1400" b="1" i="0">
-                <a:solidFill>
-                  <a:srgbClr val="1E2A3B"/>
-                </a:solidFill>
-                <a:latin typeface="Calibri"/>
-              </a:rPr>
-              <a:t>Every wire is a flip-flop</a:t>
-            </a:r>
-          </a:p>
-        </p:txBody>
-      </p:sp>
-      <p:sp>
-        <p:nvSpPr>
-          <p:cNvPr id="9" name="TextBox 8"/>
-          <p:cNvSpPr txBox="1"/>
-          <p:nvPr/>
-        </p:nvSpPr>
-        <p:spPr>
-          <a:xfrm>
-            <a:off x="4517136" y="5916168"/>
-            <a:ext cx="3154680" cy="274320"/>
-          </a:xfrm>
-          <a:prstGeom prst="rect">
-            <a:avLst/>
-          </a:prstGeom>
-          <a:noFill/>
-        </p:spPr>
-        <p:txBody>
-          <a:bodyPr wrap="square" lIns="0" rIns="0" tIns="0" bIns="0" anchor="t">
-            <a:spAutoFit/>
-          </a:bodyPr>
-          <a:lstStyle/>
-          <a:p>
-            <a:pPr algn="l"/>
-            <a:r>
-              <a:rPr sz="1300" b="0" i="0">
-                <a:solidFill>
-                  <a:srgbClr val="4F5F74"/>
-                </a:solidFill>
-                <a:latin typeface="Calibri"/>
-              </a:rPr>
-              <a:t>+2 cycles, same throughput.</a:t>
-            </a:r>
-          </a:p>
-        </p:txBody>
-      </p:sp>
-      <p:sp>
-        <p:nvSpPr>
-          <p:cNvPr id="10" name="Rounded Rectangle 9"/>
-          <p:cNvSpPr/>
-          <p:nvPr/>
-        </p:nvSpPr>
-        <p:spPr>
-          <a:xfrm>
-            <a:off x="8028432" y="5577840"/>
-            <a:ext cx="3493008" cy="713232"/>
-          </a:xfrm>
-          <a:prstGeom prst="roundRect">
-            <a:avLst>
-              <a:gd name="adj" fmla="val 6000"/>
-            </a:avLst>
-          </a:prstGeom>
-          <a:solidFill>
-            <a:srgbClr val="FFFFFF"/>
-          </a:solidFill>
-          <a:ln>
-            <a:noFill/>
-          </a:ln>
-          <a:effectLst/>
-        </p:spPr>
-        <p:style>
-          <a:lnRef idx="1">
-            <a:schemeClr val="accent1"/>
-          </a:lnRef>
-          <a:fillRef idx="3">
-            <a:schemeClr val="accent1"/>
-          </a:fillRef>
-          <a:effectRef idx="2">
-            <a:schemeClr val="accent1"/>
-          </a:effectRef>
-          <a:fontRef idx="minor">
-            <a:schemeClr val="lt1"/>
-          </a:fontRef>
-        </p:style>
-        <p:txBody>
-          <a:bodyPr rtlCol="0" anchor="ctr"/>
-          <a:lstStyle/>
-          <a:p/>
-        </p:txBody>
-      </p:sp>
-      <p:sp>
-        <p:nvSpPr>
-          <p:cNvPr id="11" name="TextBox 10"/>
-          <p:cNvSpPr txBox="1"/>
-          <p:nvPr/>
-        </p:nvSpPr>
-        <p:spPr>
-          <a:xfrm>
-            <a:off x="8211312" y="5623560"/>
-            <a:ext cx="3154680" cy="274320"/>
-          </a:xfrm>
-          <a:prstGeom prst="rect">
-            <a:avLst/>
-          </a:prstGeom>
-          <a:noFill/>
-        </p:spPr>
-        <p:txBody>
-          <a:bodyPr wrap="square" lIns="0" rIns="0" tIns="0" bIns="0" anchor="t">
-            <a:spAutoFit/>
-          </a:bodyPr>
-          <a:lstStyle/>
-          <a:p>
-            <a:pPr algn="l"/>
-            <a:r>
-              <a:rPr sz="1400" b="1" i="0">
-                <a:solidFill>
-                  <a:srgbClr val="1E2A3B"/>
-                </a:solidFill>
-                <a:latin typeface="Calibri"/>
-              </a:rPr>
-              <a:t>Errors still drain the burst</a:t>
-            </a:r>
-          </a:p>
-        </p:txBody>
-      </p:sp>
-      <p:sp>
-        <p:nvSpPr>
-          <p:cNvPr id="12" name="TextBox 11"/>
-          <p:cNvSpPr txBox="1"/>
-          <p:nvPr/>
-        </p:nvSpPr>
-        <p:spPr>
-          <a:xfrm>
-            <a:off x="8211312" y="5916168"/>
-            <a:ext cx="3154680" cy="274320"/>
-          </a:xfrm>
-          <a:prstGeom prst="rect">
-            <a:avLst/>
-          </a:prstGeom>
-          <a:noFill/>
-        </p:spPr>
-        <p:txBody>
-          <a:bodyPr wrap="square" lIns="0" rIns="0" tIns="0" bIns="0" anchor="t">
-            <a:spAutoFit/>
-          </a:bodyPr>
-          <a:lstStyle/>
-          <a:p>
-            <a:pPr algn="l"/>
-            <a:r>
-              <a:rPr sz="1300" b="0" i="0">
-                <a:solidFill>
-                  <a:srgbClr val="4F5F74"/>
-                </a:solidFill>
-                <a:latin typeface="Calibri"/>
-              </a:rPr>
-              <a:t>So the manager never hangs.</a:t>
-            </a:r>
-          </a:p>
-        </p:txBody>
-      </p:sp>
-      <p:sp>
-        <p:nvSpPr>
-          <p:cNvPr id="13" name="Footer"/>
+              <a:t>The master and slave are wired directly. The burst description is copied into registers once, at the start.</a:t>
+            </a:r>
+          </a:p>
+        </p:txBody>
+      </p:sp>
+      <p:sp>
+        <p:nvSpPr>
+          <p:cNvPr id="5" name="Footer"/>
           <p:cNvSpPr txBox="1"/>
           <p:nvPr/>
         </p:nvSpPr>
@@ -15181,14 +15414,14 @@
                 </a:solidFill>
                 <a:latin typeface="Calibri"/>
               </a:rPr>
-              <a:t>AXI4 manager, subordinate and registered channels</a:t>
-            </a:r>
-          </a:p>
-        </p:txBody>
-      </p:sp>
-      <p:sp>
-        <p:nvSpPr>
-          <p:cNvPr id="14" name="Page number"/>
+              <a:t>AXI4 manager and subordinate in Verilog</a:t>
+            </a:r>
+          </a:p>
+        </p:txBody>
+      </p:sp>
+      <p:sp>
+        <p:nvSpPr>
+          <p:cNvPr id="6" name="Page number"/>
           <p:cNvSpPr txBox="1"/>
           <p:nvPr/>
         </p:nvSpPr>
@@ -15405,7 +15638,7 @@
         <p:spPr>
           <a:xfrm>
             <a:off x="914400" y="2103120"/>
-            <a:ext cx="2468880" cy="1371600"/>
+            <a:ext cx="2651760" cy="1371600"/>
           </a:xfrm>
           <a:prstGeom prst="rect">
             <a:avLst/>
@@ -15491,8 +15724,8 @@
         </p:nvSpPr>
         <p:spPr>
           <a:xfrm>
-            <a:off x="3383280" y="2103120"/>
-            <a:ext cx="2468880" cy="1371600"/>
+            <a:off x="3566160" y="2103120"/>
+            <a:ext cx="2286000" cy="1371600"/>
           </a:xfrm>
           <a:prstGeom prst="rect">
             <a:avLst/>
@@ -15677,7 +15910,7 @@
         <p:spPr>
           <a:xfrm>
             <a:off x="6446520" y="2103120"/>
-            <a:ext cx="2468880" cy="1371600"/>
+            <a:ext cx="2651760" cy="1371600"/>
           </a:xfrm>
           <a:prstGeom prst="rect">
             <a:avLst/>
@@ -15702,7 +15935,7 @@
                 </a:solidFill>
                 <a:latin typeface="Consolas"/>
               </a:rPr>
-              <a:t>cmd_busy</a:t>
+              <a:t>cmd_done  (1-cycle pulse)</a:t>
             </a:r>
           </a:p>
           <a:p>
@@ -15718,22 +15951,6 @@
                 </a:solidFill>
                 <a:latin typeface="Consolas"/>
               </a:rPr>
-              <a:t>cmd_done  (1-cycle pulse)</a:t>
-            </a:r>
-          </a:p>
-          <a:p>
-            <a:pPr algn="l">
-              <a:spcAft>
-                <a:spcPts val="300"/>
-              </a:spcAft>
-            </a:pPr>
-            <a:r>
-              <a:rPr sz="1300" b="0" i="0">
-                <a:solidFill>
-                  <a:srgbClr val="1E2A3B"/>
-                </a:solidFill>
-                <a:latin typeface="Consolas"/>
-              </a:rPr>
               <a:t>cmd_resp[1:0]</a:t>
             </a:r>
           </a:p>
@@ -15747,8 +15964,8 @@
         </p:nvSpPr>
         <p:spPr>
           <a:xfrm>
-            <a:off x="8915400" y="2103120"/>
-            <a:ext cx="2468880" cy="1371600"/>
+            <a:off x="9098280" y="2103120"/>
+            <a:ext cx="2286000" cy="1371600"/>
           </a:xfrm>
           <a:prstGeom prst="rect">
             <a:avLst/>
@@ -15760,38 +15977,7 @@
             <a:spAutoFit/>
           </a:bodyPr>
           <a:lstStyle/>
-          <a:p>
-            <a:pPr algn="l">
-              <a:spcAft>
-                <a:spcPts val="300"/>
-              </a:spcAft>
-            </a:pPr>
-            <a:r>
-              <a:rPr sz="1300" b="0" i="0">
-                <a:solidFill>
-                  <a:srgbClr val="1E2A3B"/>
-                </a:solidFill>
-                <a:latin typeface="Consolas"/>
-              </a:rPr>
-              <a:t>cmd_resp_id[3:0]</a:t>
-            </a:r>
-          </a:p>
-          <a:p>
-            <a:pPr algn="l">
-              <a:spcAft>
-                <a:spcPts val="300"/>
-              </a:spcAft>
-            </a:pPr>
-            <a:r>
-              <a:rPr sz="1300" b="0" i="0">
-                <a:solidFill>
-                  <a:srgbClr val="1E2A3B"/>
-                </a:solidFill>
-                <a:latin typeface="Consolas"/>
-              </a:rPr>
-              <a:t>cmd_last_err</a:t>
-            </a:r>
-          </a:p>
+          <a:p/>
         </p:txBody>
       </p:sp>
       <p:sp>
@@ -15917,7 +16103,7 @@
         <p:spPr>
           <a:xfrm>
             <a:off x="914400" y="4343400"/>
-            <a:ext cx="2468880" cy="1371600"/>
+            <a:ext cx="2651760" cy="1371600"/>
           </a:xfrm>
           <a:prstGeom prst="rect">
             <a:avLst/>
@@ -15971,8 +16157,8 @@
         </p:nvSpPr>
         <p:spPr>
           <a:xfrm>
-            <a:off x="3383280" y="4343400"/>
-            <a:ext cx="2468880" cy="1371600"/>
+            <a:off x="3566160" y="4343400"/>
+            <a:ext cx="2286000" cy="1371600"/>
           </a:xfrm>
           <a:prstGeom prst="rect">
             <a:avLst/>
@@ -16127,7 +16313,7 @@
                 </a:solidFill>
                 <a:latin typeface="Calibri"/>
               </a:rPr>
-              <a:t>you pull beats</a:t>
+              <a:t>you take beats</a:t>
             </a:r>
           </a:p>
         </p:txBody>
@@ -16141,7 +16327,7 @@
         <p:spPr>
           <a:xfrm>
             <a:off x="6446520" y="4343400"/>
-            <a:ext cx="2468880" cy="1371600"/>
+            <a:ext cx="2651760" cy="1371600"/>
           </a:xfrm>
           <a:prstGeom prst="rect">
             <a:avLst/>
@@ -16182,7 +16368,7 @@
                 </a:solidFill>
                 <a:latin typeface="Consolas"/>
               </a:rPr>
-              <a:t>hr_resp[1:0]</a:t>
+              <a:t>hr_valid</a:t>
             </a:r>
           </a:p>
           <a:p>
@@ -16198,7 +16384,7 @@
                 </a:solidFill>
                 <a:latin typeface="Consolas"/>
               </a:rPr>
-              <a:t>hr_last</a:t>
+              <a:t>hr_ready</a:t>
             </a:r>
           </a:p>
         </p:txBody>
@@ -16211,8 +16397,8 @@
         </p:nvSpPr>
         <p:spPr>
           <a:xfrm>
-            <a:off x="8915400" y="4343400"/>
-            <a:ext cx="2468880" cy="1371600"/>
+            <a:off x="9098280" y="4343400"/>
+            <a:ext cx="2286000" cy="1371600"/>
           </a:xfrm>
           <a:prstGeom prst="rect">
             <a:avLst/>
@@ -16224,38 +16410,7 @@
             <a:spAutoFit/>
           </a:bodyPr>
           <a:lstStyle/>
-          <a:p>
-            <a:pPr algn="l">
-              <a:spcAft>
-                <a:spcPts val="300"/>
-              </a:spcAft>
-            </a:pPr>
-            <a:r>
-              <a:rPr sz="1300" b="0" i="0">
-                <a:solidFill>
-                  <a:srgbClr val="1E2A3B"/>
-                </a:solidFill>
-                <a:latin typeface="Consolas"/>
-              </a:rPr>
-              <a:t>hr_valid</a:t>
-            </a:r>
-          </a:p>
-          <a:p>
-            <a:pPr algn="l">
-              <a:spcAft>
-                <a:spcPts val="300"/>
-              </a:spcAft>
-            </a:pPr>
-            <a:r>
-              <a:rPr sz="1300" b="0" i="0">
-                <a:solidFill>
-                  <a:srgbClr val="1E2A3B"/>
-                </a:solidFill>
-                <a:latin typeface="Consolas"/>
-              </a:rPr>
-              <a:t>hr_ready</a:t>
-            </a:r>
-          </a:p>
+          <a:p/>
         </p:txBody>
       </p:sp>
       <p:sp>
@@ -16288,7 +16443,7 @@
                 </a:solidFill>
                 <a:latin typeface="Calibri"/>
               </a:rPr>
-              <a:t>A start is ignored while cmd_busy is high. If both starts arrive together, the write wins.</a:t>
+              <a:t>A start is taken only when the manager is idle. If both starts arrive together, the write wins.</a:t>
             </a:r>
           </a:p>
         </p:txBody>
@@ -16323,7 +16478,7 @@
                 </a:solidFill>
                 <a:latin typeface="Calibri"/>
               </a:rPr>
-              <a:t>AXI4 manager, subordinate and registered channels</a:t>
+              <a:t>AXI4 manager and subordinate in Verilog</a:t>
             </a:r>
           </a:p>
         </p:txBody>
@@ -17133,7 +17288,7 @@
                 </a:solidFill>
                 <a:latin typeface="Calibri"/>
               </a:rPr>
-              <a:t>Passes beats to the host until RLAST. Flags a RLAST on the wrong beat.</a:t>
+              <a:t>Passes each beat to the host and finishes when RLAST arrives.</a:t>
             </a:r>
           </a:p>
         </p:txBody>
@@ -17396,7 +17551,7 @@
                 </a:solidFill>
                 <a:latin typeface="Calibri"/>
               </a:rPr>
-              <a:t>AXI4 manager, subordinate and registered channels</a:t>
+              <a:t>AXI4 manager and subordinate in Verilog</a:t>
             </a:r>
           </a:p>
         </p:txBody>
@@ -17935,7 +18090,7 @@
                 </a:solidFill>
                 <a:latin typeface="Cambria"/>
               </a:rPr>
-              <a:t>Errors</a:t>
+              <a:t>Responses</a:t>
             </a:r>
           </a:p>
         </p:txBody>
@@ -17962,49 +18117,25 @@
           </a:bodyPr>
           <a:lstStyle/>
           <a:p>
-            <a:pPr algn="l"/>
-            <a:r>
-              <a:rPr sz="1500" b="1" i="0">
-                <a:solidFill>
-                  <a:srgbClr val="8F5C00"/>
-                </a:solidFill>
-                <a:latin typeface="Consolas"/>
-              </a:rPr>
-              <a:t>DECERR</a:t>
-            </a:r>
-          </a:p>
-          <a:p>
             <a:pPr algn="l">
               <a:spcAft>
-                <a:spcPts val="1000"/>
+                <a:spcPts val="400"/>
               </a:spcAft>
             </a:pPr>
             <a:r>
-              <a:rPr sz="1600" b="0" i="0">
-                <a:solidFill>
-                  <a:srgbClr val="1E2A3B"/>
-                </a:solidFill>
-                <a:latin typeface="Calibri"/>
-              </a:rPr>
-              <a:t>Address outside the 4 KiB region.</a:t>
-            </a:r>
-          </a:p>
-          <a:p>
-            <a:pPr algn="l"/>
-            <a:r>
               <a:rPr sz="1500" b="1" i="0">
                 <a:solidFill>
                   <a:srgbClr val="8F5C00"/>
                 </a:solidFill>
                 <a:latin typeface="Consolas"/>
               </a:rPr>
-              <a:t>SLVERR</a:t>
+              <a:t>OKAY on every transfer</a:t>
             </a:r>
           </a:p>
           <a:p>
             <a:pPr algn="l">
               <a:spcAft>
-                <a:spcPts val="1000"/>
+                <a:spcPts val="1200"/>
               </a:spcAft>
             </a:pPr>
             <a:r>
@@ -18014,19 +18145,39 @@
                 </a:solidFill>
                 <a:latin typeface="Calibri"/>
               </a:rPr>
-              <a:t>Reserved burst code, beat wider than the bus, bad WRAP length, or WLAST on the wrong beat.</a:t>
-            </a:r>
-          </a:p>
-          <a:p>
-            <a:pPr algn="l"/>
-            <a:r>
-              <a:rPr sz="1600" b="0" i="1">
-                <a:solidFill>
-                  <a:srgbClr val="4F5F74"/>
+              <a:t>BRESP and RRESP are tied to 00.</a:t>
+            </a:r>
+          </a:p>
+          <a:p>
+            <a:pPr algn="l">
+              <a:spcAft>
+                <a:spcPts val="400"/>
+              </a:spcAft>
+            </a:pPr>
+            <a:r>
+              <a:rPr sz="1500" b="1" i="0">
+                <a:solidFill>
+                  <a:srgbClr val="8F5C00"/>
+                </a:solidFill>
+                <a:latin typeface="Consolas"/>
+              </a:rPr>
+              <a:t>No request checking</a:t>
+            </a:r>
+          </a:p>
+          <a:p>
+            <a:pPr algn="l">
+              <a:spcAft>
+                <a:spcPts val="0"/>
+              </a:spcAft>
+            </a:pPr>
+            <a:r>
+              <a:rPr sz="1600" b="0" i="0">
+                <a:solidFill>
+                  <a:srgbClr val="1E2A3B"/>
                 </a:solidFill>
                 <a:latin typeface="Calibri"/>
               </a:rPr>
-              <a:t>A failing write is still fully accepted. A failing read still returns every beat. The manager never hangs.</a:t>
+              <a:t>A write ends on WLAST. A read ends after ARLEN + 1 beats. An address beyond the memory wraps inside it.</a:t>
             </a:r>
           </a:p>
         </p:txBody>
@@ -18061,7 +18212,7 @@
                 </a:solidFill>
                 <a:latin typeface="Calibri"/>
               </a:rPr>
-              <a:t>AXI4 manager, subordinate and registered channels</a:t>
+              <a:t>AXI4 manager and subordinate in Verilog</a:t>
             </a:r>
           </a:p>
         </p:txBody>

</xml_diff>

<commit_message>
Regenerate diagram, waveforms, presentation and README for in DFF -> master -> slave -> out DFF (76 checks, 13-cycle sequence)
Co-Authored-By: Claude Sonnet 5.5 <noreply@anthropic.com>
Claude-Session: https://claude.ai/code/session_016pqX9TCTAADxGLGn1sy3YA
</commit_message>
<xml_diff>
--- a/docs/AXI4_Viva_Presentation.pptx
+++ b/docs/AXI4_Viva_Presentation.pptx
@@ -517,7 +517,7 @@
           <a:lstStyle/>
           <a:p>
             <a:r>
-              <a:t>Open with the one-sentence summary: we built an AXI4 master and an AXI4 memory in Verilog. The master holds its data in D flip-flop registers and starts the transfers by itself. Every one of the five channels passes through a D flip-flop stage at the master side and another at the slave side. Everything shown comes from the simulation in the project folder, so every number can be reproduced live. The five amber pills are the five AXI channels; we come back to each one.</a:t>
+              <a:t>Open with the one-sentence summary: we built an AXI4 master and an AXI4 memory in Verilog. The testbench loads an address and four words into input D flip-flops. The master takes them from there, writes them to the slave over the five AXI channels, then reads them back into output D flip-flops. The master and the slave are connected directly. Everything shown comes from the simulation in the project folder, so every number can be reproduced live. The five amber pills are the five AXI channels; we come back to each one.</a:t>
             </a:r>
           </a:p>
         </p:txBody>
@@ -587,7 +587,7 @@
           <a:lstStyle/>
           <a:p>
             <a:r>
-              <a:t>The whole sequence, with the real cycle numbers from the simulation. The master puts the write address out and it is taken at cycle 1 and reaches the slave at cycle 3, because it crosses two stages. The four data beats are taken at cycles 2, 4, 6 and 8: one every two clocks. The response comes back through two stages and is taken at cycle 13. Then the master reads the four words back: the address is taken one cycle after, the four beats arrive every two clocks, and done goes high. The whole sequence takes 27 clock cycles from reset.</a:t>
+              <a:t>The whole sequence, with the real cycle numbers from the simulation. Cycle 0 is the first cycle with start high. The write address is taken at cycle 1: the slave was already ready, so there is no wait. The four data beats are taken at cycles 2, 3, 4 and 5, one every clock, and WLAST is on the fourth. The response is taken at cycle 6. The read address is taken at cycle 7, the four beats arrive at cycles 8 to 11, and done goes high at cycle 12. That is 13 clock cycles from start.</a:t>
             </a:r>
           </a:p>
         </p:txBody>
@@ -657,7 +657,7 @@
           <a:lstStyle/>
           <a:p>
             <a:r>
-              <a:t>This waveform was recorded from our simulation. Amber dots are handshakes. The master raises AWVALID at cycle 1 and the master-side stage takes it straight away. At cycle 3 the address reaches the slave, one stage later. The four data beats are taken at cycles 2, 4, 6 and 8: WREADY goes high every other cycle, because a stage can only hold one beat at a time. WLAST rides on the fourth. The response is taken at cycle 13 after crossing two stages on the way back.</a:t>
+              <a:t>This waveform was recorded from our simulation. Amber dots are handshakes. The master raises AWVALID at cycle 1 and AWREADY is already high, so the address is taken at once. The four data beats are taken at cycles 2, 3, 4 and 5: WREADY stays high, so one beat moves every clock. WLAST is high on the fourth. BVALID comes at cycle 6 and BREADY is already high, so the response is taken immediately.</a:t>
             </a:r>
           </a:p>
         </p:txBody>
@@ -727,7 +727,7 @@
           <a:lstStyle/>
           <a:p>
             <a:r>
-              <a:t>Same address read back. The read address is taken at cycle 1 of this window and reaches the slave at cycle 3. The four beats come back at cycles 6, 8, 10 and 12, again one every two clocks, with RLAST on the fourth. Then done goes high. The master compares what it read with what it wrote and sets pass.</a:t>
+              <a:t>Same four words read back. The read address is taken at cycle 1 of this window, which is cycle 7 of the whole run. The four beats come back at cycles 2, 3, 4 and 5 of the window, one every clock, with RLAST on the fourth. Then done goes high at cycle 6. Each beat is stored in the output D flip-flops as it arrives, and pass says they equal what was written.</a:t>
             </a:r>
           </a:p>
         </p:txBody>
@@ -797,7 +797,7 @@
           <a:lstStyle/>
           <a:p>
             <a:r>
-              <a:t>We test two things. First the slave on its own: the testbench plays the master and drives each channel by hand, so it can force awkward cases such as data before address, held-off responses, byte strobes, the longest burst of 256 beats, and a reset in the middle of a burst. Second the whole system, where the master runs by itself: the testbench only supplies clock and reset, then checks that it finishes, passes, that the four words really are in the slave's memory, that every response is OKAY with the right ID, and that VALID and the payload hold steady until READY. It also resets mid-sequence and checks it runs again.</a:t>
+              <a:t>We test two things. First the slave on its own: the testbench plays the master and drives each channel by hand, so it can force awkward cases such as data before address, held-off responses, byte strobes, the longest burst of 256 beats, and a reset in the middle of a burst. Second the whole system: the testbench loads the input flip-flops, raises start, and checks that the master finishes, that pass is set, that the output flip-flops and the slave's memory hold the four words, that every response is OKAY with the right ID, and that VALID and the payload hold steady until READY. It also runs a second set of values at another address, and resets mid-sequence.</a:t>
             </a:r>
           </a:p>
         </p:txBody>
@@ -867,7 +867,7 @@
           <a:lstStyle/>
           <a:p>
             <a:r>
-              <a:t>Say these before you are asked. The throughput is half rate: one beat every two clocks, because each stage holds one beat. The master's data is fixed in its registers; changing it means editing the file. Only counting-up bursts, so no FIXED or WRAP and no narrow beats. Every response is OKAY and an out-of-range address wraps. One burst at a time. And the lock, cache, protection and QoS signals are not included.</a:t>
+              <a:t>Say these before you are asked. The burst shape is fixed: the master always writes and reads four words with all bytes enabled. The input flip-flops must not change while a sequence runs, because the master reads them live. Only counting-up bursts, so no FIXED or WRAP and no narrow beats. Every response is OKAY and an out-of-range address wraps. One burst at a time. And the lock, cache, protection and QoS signals are not included.</a:t>
             </a:r>
           </a:p>
         </p:txBody>
@@ -937,7 +937,7 @@
           <a:lstStyle/>
           <a:p>
             <a:r>
-              <a:t>Live demo, about two minutes. Open PowerShell in E:\FPGA_Project and run .\run_tests.ps1. It compiles and runs two suites. Point at the two TEST PASSED lines and the check counts, 33 and 13, and the line that says the whole sequence took 27 clock cycles. Then run the top suite with -Wave to open the waveform in GTKWave and show the same shape as the recorded slides: the handshakes and the WREADY going high every other cycle. If the live run fails for any reason, slides 11 and 12 are recorded from this exact simulation.</a:t>
+              <a:t>Live demo, about two minutes. Open PowerShell in E:\FPGA_Project and run .\run_tests.ps1. It compiles and runs two suites. Point at the two TEST PASSED lines and the check counts, 33 and 43, and the line that says the whole sequence took 13 clock cycles. Then run the top suite with -Wave to open the waveform in GTKWave and show the same shape as the recorded slides: the handshakes, with WREADY high so a beat moves every clock. If the live run fails for any reason, slides 11 and 12 are recorded from this exact simulation.</a:t>
             </a:r>
           </a:p>
         </p:txBody>
@@ -1007,7 +1007,7 @@
           <a:lstStyle/>
           <a:p>
             <a:r>
-              <a:t>Likely questions with short answers. Why five channels: address, data and response move independently. Why not a bare flip-flop: READY arrives late and a beat could be sent twice; the stage reports full from a flip-flop. What does it cost: one beat every two clocks. Where does the data come from: D flip-flop registers inside the master. How do we know it worked: it reads back and compares, and the testbench checks the slave's memory. How does the slave know the burst ended: WLAST on writes, a beat count on reads.</a:t>
+              <a:t>Likely questions with short answers. Why five channels: address, data and response move independently. Is there an interconnect: no, one master and one slave are wired directly. Where does the data come from: the input D flip-flops, loaded by the testbench. Where does the read data go: the output D flip-flops, one register per beat. How do we know it worked: the master's pass compares them, and the testbench checks the slave's memory. How does the slave know the burst ended: WLAST on writes, a beat count on reads.</a:t>
             </a:r>
           </a:p>
         </p:txBody>
@@ -1077,7 +1077,7 @@
           <a:lstStyle/>
           <a:p>
             <a:r>
-              <a:t>Four small files. The master is the active side: it holds the address and four words in D flip-flop registers and starts the transfers itself. The stage is the small block that holds one beat; there are ten of them, two on each channel. The slave is a 4 KiB memory that answers the five channels. The top level only wires them together.</a:t>
+              <a:t>Five small files, and the top level that wires them. The input D flip-flops hold the address and four words the testbench loads. The master is the active side: it takes them from there and starts the AXI transfers when start goes high. The slave is a 4 KiB memory that answers the five channels. The output D flip-flops catch the words that come back. The top level only wires them together; the master and slave are connected directly.</a:t>
             </a:r>
           </a:p>
         </p:txBody>
@@ -1357,7 +1357,7 @@
           <a:lstStyle/>
           <a:p>
             <a:r>
-              <a:t>Walk left to right. On the left the master, with its D flip-flop registers. It starts the transfers by itself. Each of the five channels goes through a D flip-flop stage at the master side and another at the slave side, shown in amber, with the real signal names above each wire. On the right the slave has a write engine, a read engine and a 4 KiB memory. B and R run the other way.</a:t>
+              <a:t>Walk left to right. The yellow box on the left is the input D flip-flops, loaded by the testbench. The master takes its data from them and starts the transfers when start goes high. The five channels, with the real signal names above each wire, go straight across to the slave: there is no interconnect and nothing in between. On the right the slave has a write engine, a read engine and a 4 KiB memory. Each read beat is stored in the output D flip-flops, the yellow box on the far right. B and R run the other way.</a:t>
             </a:r>
           </a:p>
         </p:txBody>
@@ -1427,7 +1427,7 @@
           <a:lstStyle/>
           <a:p>
             <a:r>
-              <a:t>The master is one small state machine. After reset it goes by itself. S_AW sends the write address. S_W sends the four words, one per beat, taking each from the data registers, and raises WLAST on the fourth. S_B waits for the one response. S_AR sends the read address. S_R takes four beats into the read registers. S_DONE raises done, and pass says whether what came back equals what was written. There is no host interface at all: the data comes from D flip-flop registers inside the master.</a:t>
+              <a:t>The master is one small state machine. It sits in S_IDLE until start goes high. S_AW sends the write address. S_W sends the four words, one per beat, taken from the input flip-flops, and raises WLAST on the fourth. S_B waits for the one response. S_AR sends the read address. S_R takes four beats and hands each one to the output flip-flops. S_DONE raises done and waits for start to drop, so the sequence can run again. The master itself holds no data.</a:t>
             </a:r>
           </a:p>
         </p:txBody>
@@ -1497,7 +1497,7 @@
           <a:lstStyle/>
           <a:p>
             <a:r>
-              <a:t>This is the block you asked for: a D flip-flop stage. It holds one beat. When it is empty it says in_ready = 1 and takes a beat. When it is full it says in_ready = 0 and offers the beat until the next side takes it. The important point is that in_ready comes straight from a flip-flop. A bare flip-flop on VALID and READY would see READY one cycle late, so the sender could send the same beat twice. This design cannot. The cost is that a beat sits in the stage for a clock, so one beat moves every two clocks.</a:t>
+              <a:t>These are the D flip-flops you asked for, one bank at each end. The input bank is five 32-bit registers: an address and four words. The testbench writes one register per clock edge using load, load_sel and load_data. The master reads their outputs directly and does not change them. The output bank is four registers. Each read beat is stored in the register for its position, using rd_valid and rd_idx. pass is done AND all four output registers equal the four input registers. Reset clears both banks.</a:t>
             </a:r>
           </a:p>
         </p:txBody>
@@ -4681,7 +4681,7 @@
                 </a:solidFill>
                 <a:latin typeface="Calibri"/>
               </a:rPr>
-              <a:t>The master starts the transfers itself, every channel passes through D flip-flop stages, and 46 checks pass in simulation.</a:t>
+              <a:t>Input D flip-flops, master, slave, output D flip-flops: a write and a read, and 76 checks pass in simulation.</a:t>
             </a:r>
           </a:p>
         </p:txBody>
@@ -5087,7 +5087,7 @@
                 </a:solidFill>
                 <a:latin typeface="Calibri"/>
               </a:rPr>
-              <a:t>The master writes four words to 0x10, then reads them back.</a:t>
+              <a:t>The master writes four words, then reads them back.</a:t>
             </a:r>
           </a:p>
         </p:txBody>
@@ -5201,7 +5201,7 @@
                 </a:solidFill>
                 <a:latin typeface="Calibri"/>
               </a:rPr>
-              <a:t>AW taken at cycle 1. It reaches the slave at cycle 3.</a:t>
+              <a:t>AW taken at cycle 1. The slave is ready, so no wait.</a:t>
             </a:r>
           </a:p>
         </p:txBody>
@@ -5351,7 +5351,7 @@
                 </a:solidFill>
                 <a:latin typeface="Calibri"/>
               </a:rPr>
-              <a:t>Four beats taken at cycles 2, 4, 6, 8. WLAST on the fourth.</a:t>
+              <a:t>Four beats taken at cycles 2, 3, 4, 5. WLAST on the fourth.</a:t>
             </a:r>
           </a:p>
         </p:txBody>
@@ -5501,7 +5501,7 @@
                 </a:solidFill>
                 <a:latin typeface="Calibri"/>
               </a:rPr>
-              <a:t>B comes back through two stages and is taken at cycle 13.</a:t>
+              <a:t>B taken at cycle 6, right after the last beat.</a:t>
             </a:r>
           </a:p>
         </p:txBody>
@@ -5651,7 +5651,7 @@
                 </a:solidFill>
                 <a:latin typeface="Calibri"/>
               </a:rPr>
-              <a:t>AR, then four beats every two clocks. RLAST on the fourth.</a:t>
+              <a:t>AR taken at cycle 7, then four beats at cycles 8 to 11. RLAST on the fourth.</a:t>
             </a:r>
           </a:p>
         </p:txBody>
@@ -5801,7 +5801,7 @@
                 </a:solidFill>
                 <a:latin typeface="Calibri"/>
               </a:rPr>
-              <a:t>done = 1, pass = 1. The whole sequence took 27 cycles.</a:t>
+              <a:t>done = 1 at cycle 12, pass = 1. 13 cycles from start.</a:t>
             </a:r>
           </a:p>
         </p:txBody>
@@ -5850,7 +5850,7 @@
         <p:spPr>
           <a:xfrm>
             <a:off x="640080" y="6400800"/>
-            <a:ext cx="7315200" cy="274320"/>
+            <a:ext cx="9144000" cy="274320"/>
           </a:xfrm>
           <a:prstGeom prst="rect">
             <a:avLst/>
@@ -5871,7 +5871,7 @@
                 </a:solidFill>
                 <a:latin typeface="Calibri"/>
               </a:rPr>
-              <a:t>AXI4: a master, D flip-flop stages and a memory, in Verilog</a:t>
+              <a:t>AXI4: input D flip-flops, a master, a slave and output D flip-flops, in Verilog</a:t>
             </a:r>
           </a:p>
         </p:txBody>
@@ -5974,7 +5974,7 @@
       </p:sp>
       <p:pic>
         <p:nvPicPr>
-          <p:cNvPr id="3" name="Picture 2" descr="Waveform of the master writing four words through the flip-flop stages."/>
+          <p:cNvPr id="3" name="Picture 2" descr="Waveform of the master writing four words straight to the slave."/>
           <p:cNvPicPr>
             <a:picLocks noChangeAspect="1"/>
           </p:cNvPicPr>
@@ -5988,8 +5988,8 @@
         </p:blipFill>
         <p:spPr>
           <a:xfrm>
-            <a:off x="640080" y="1325880"/>
-            <a:ext cx="10881360" cy="3881392"/>
+            <a:off x="1578322" y="1325880"/>
+            <a:ext cx="9035050" cy="3931920"/>
           </a:xfrm>
           <a:prstGeom prst="rect">
             <a:avLst/>
@@ -6181,7 +6181,7 @@
                 </a:solidFill>
                 <a:latin typeface="Calibri"/>
               </a:rPr>
-              <a:t>taken at 1, reaches the slave at 3: two stages.</a:t>
+              <a:t>taken at 1: the slave was already ready.</a:t>
             </a:r>
           </a:p>
         </p:txBody>
@@ -6276,7 +6276,7 @@
                 </a:solidFill>
                 <a:latin typeface="Calibri"/>
               </a:rPr>
-              <a:t>taken at 2, 4, 6, 8: one every two clocks.</a:t>
+              <a:t>taken at 2, 3, 4, 5: one every clock.</a:t>
             </a:r>
           </a:p>
         </p:txBody>
@@ -6371,7 +6371,7 @@
                 </a:solidFill>
                 <a:latin typeface="Calibri"/>
               </a:rPr>
-              <a:t>taken at 13, after two stages back.</a:t>
+              <a:t>taken at 6, right after WLAST.</a:t>
             </a:r>
           </a:p>
         </p:txBody>
@@ -6385,7 +6385,7 @@
         <p:spPr>
           <a:xfrm>
             <a:off x="640080" y="6400800"/>
-            <a:ext cx="7315200" cy="274320"/>
+            <a:ext cx="9144000" cy="274320"/>
           </a:xfrm>
           <a:prstGeom prst="rect">
             <a:avLst/>
@@ -6406,7 +6406,7 @@
                 </a:solidFill>
                 <a:latin typeface="Calibri"/>
               </a:rPr>
-              <a:t>AXI4: a master, D flip-flop stages and a memory, in Verilog</a:t>
+              <a:t>AXI4: input D flip-flops, a master, a slave and output D flip-flops, in Verilog</a:t>
             </a:r>
           </a:p>
         </p:txBody>
@@ -6509,7 +6509,7 @@
       </p:sp>
       <p:pic>
         <p:nvPicPr>
-          <p:cNvPr id="3" name="Picture 2" descr="Waveform of the master reading four words back through the flip-flop stages."/>
+          <p:cNvPr id="3" name="Picture 2" descr="Waveform of the master reading four words back from the slave."/>
           <p:cNvPicPr>
             <a:picLocks noChangeAspect="1"/>
           </p:cNvPicPr>
@@ -6523,8 +6523,8 @@
         </p:blipFill>
         <p:spPr>
           <a:xfrm>
-            <a:off x="640080" y="1463040"/>
-            <a:ext cx="10881360" cy="3163447"/>
+            <a:off x="1592610" y="1463040"/>
+            <a:ext cx="9006474" cy="3474720"/>
           </a:xfrm>
           <a:prstGeom prst="rect">
             <a:avLst/>
@@ -6539,7 +6539,7 @@
         </p:nvSpPr>
         <p:spPr>
           <a:xfrm>
-            <a:off x="640080" y="5029200"/>
+            <a:off x="640080" y="5074920"/>
             <a:ext cx="2590723" cy="1097280"/>
           </a:xfrm>
           <a:prstGeom prst="roundRect">
@@ -6583,7 +6583,7 @@
         </p:nvSpPr>
         <p:spPr>
           <a:xfrm>
-            <a:off x="822959" y="5138928"/>
+            <a:off x="822959" y="5184648"/>
             <a:ext cx="2224963" cy="914400"/>
           </a:xfrm>
           <a:prstGeom prst="rect">
@@ -6621,7 +6621,7 @@
                 </a:solidFill>
                 <a:latin typeface="Calibri"/>
               </a:rPr>
-              <a:t>taken at 1, reaches the slave at 3.</a:t>
+              <a:t>taken at 1: the slave was already ready.</a:t>
             </a:r>
           </a:p>
         </p:txBody>
@@ -6634,7 +6634,7 @@
         </p:nvSpPr>
         <p:spPr>
           <a:xfrm>
-            <a:off x="3413683" y="5029200"/>
+            <a:off x="3413683" y="5074920"/>
             <a:ext cx="2590723" cy="1097280"/>
           </a:xfrm>
           <a:prstGeom prst="roundRect">
@@ -6678,7 +6678,7 @@
         </p:nvSpPr>
         <p:spPr>
           <a:xfrm>
-            <a:off x="3596563" y="5138928"/>
+            <a:off x="3596563" y="5184648"/>
             <a:ext cx="2224963" cy="914400"/>
           </a:xfrm>
           <a:prstGeom prst="rect">
@@ -6716,7 +6716,7 @@
                 </a:solidFill>
                 <a:latin typeface="Calibri"/>
               </a:rPr>
-              <a:t>taken at 6, 8, 10, 12: one every two clocks.</a:t>
+              <a:t>taken at 2, 3, 4, 5: one every clock.</a:t>
             </a:r>
           </a:p>
         </p:txBody>
@@ -6729,7 +6729,7 @@
         </p:nvSpPr>
         <p:spPr>
           <a:xfrm>
-            <a:off x="6187287" y="5029200"/>
+            <a:off x="6187287" y="5074920"/>
             <a:ext cx="2590723" cy="1097280"/>
           </a:xfrm>
           <a:prstGeom prst="roundRect">
@@ -6773,7 +6773,7 @@
         </p:nvSpPr>
         <p:spPr>
           <a:xfrm>
-            <a:off x="6370167" y="5138928"/>
+            <a:off x="6370167" y="5184648"/>
             <a:ext cx="2224963" cy="914400"/>
           </a:xfrm>
           <a:prstGeom prst="rect">
@@ -6811,7 +6811,7 @@
                 </a:solidFill>
                 <a:latin typeface="Calibri"/>
               </a:rPr>
-              <a:t>rides on the fourth beat, at cycle 12.</a:t>
+              <a:t>rides on the fourth beat, at cycle 5.</a:t>
             </a:r>
           </a:p>
         </p:txBody>
@@ -6824,7 +6824,7 @@
         </p:nvSpPr>
         <p:spPr>
           <a:xfrm>
-            <a:off x="8960891" y="5029200"/>
+            <a:off x="8960891" y="5074920"/>
             <a:ext cx="2590723" cy="1097280"/>
           </a:xfrm>
           <a:prstGeom prst="roundRect">
@@ -6868,7 +6868,7 @@
         </p:nvSpPr>
         <p:spPr>
           <a:xfrm>
-            <a:off x="9143771" y="5138928"/>
+            <a:off x="9143771" y="5184648"/>
             <a:ext cx="2224963" cy="914400"/>
           </a:xfrm>
           <a:prstGeom prst="rect">
@@ -6906,7 +6906,7 @@
                 </a:solidFill>
                 <a:latin typeface="Calibri"/>
               </a:rPr>
-              <a:t>goes high at 13. The sequence took 27 cycles.</a:t>
+              <a:t>goes high at 6. The sequence took 13 cycles.</a:t>
             </a:r>
           </a:p>
         </p:txBody>
@@ -6920,7 +6920,7 @@
         <p:spPr>
           <a:xfrm>
             <a:off x="640080" y="6400800"/>
-            <a:ext cx="7315200" cy="274320"/>
+            <a:ext cx="9144000" cy="274320"/>
           </a:xfrm>
           <a:prstGeom prst="rect">
             <a:avLst/>
@@ -6941,7 +6941,7 @@
                 </a:solidFill>
                 <a:latin typeface="Calibri"/>
               </a:rPr>
-              <a:t>AXI4: a master, D flip-flop stages and a memory, in Verilog</a:t>
+              <a:t>AXI4: input D flip-flops, a master, a slave and output D flip-flops, in Verilog</a:t>
             </a:r>
           </a:p>
         </p:txBody>
@@ -7335,7 +7335,7 @@
                 </a:solidFill>
                 <a:latin typeface="Calibri"/>
               </a:rPr>
-              <a:t>The master runs by itself. 13 checks: it finishes and passes, the words are in memory, responses are OKAY, VALID and data hold steady, reset mid-sequence then runs again.</a:t>
+              <a:t>Input DFFs, master, slave, output DFFs. 43 checks: idle until start, words in memory and in the output DFFs, pass, OKAY responses, VALID holds, a second run with other values, reset mid-sequence.</a:t>
             </a:r>
           </a:p>
         </p:txBody>
@@ -7414,7 +7414,7 @@
                 </a:solidFill>
                 <a:latin typeface="Calibri"/>
               </a:rPr>
-              <a:t>Total: 33 + 13 = 46 checks, 0 failing.   Run it:  .\run_tests.ps1</a:t>
+              <a:t>Total: 33 + 43 = 76 checks, 0 failing.   Run it:  .\run_tests.ps1</a:t>
             </a:r>
           </a:p>
         </p:txBody>
@@ -7428,7 +7428,7 @@
         <p:spPr>
           <a:xfrm>
             <a:off x="640080" y="6400800"/>
-            <a:ext cx="7315200" cy="274320"/>
+            <a:ext cx="9144000" cy="274320"/>
           </a:xfrm>
           <a:prstGeom prst="rect">
             <a:avLst/>
@@ -7449,7 +7449,7 @@
                 </a:solidFill>
                 <a:latin typeface="Calibri"/>
               </a:rPr>
-              <a:t>AXI4: a master, D flip-flop stages and a memory, in Verilog</a:t>
+              <a:t>AXI4: input D flip-flops, a master, a slave and output D flip-flops, in Verilog</a:t>
             </a:r>
           </a:p>
         </p:txBody>
@@ -7624,7 +7624,7 @@
                 </a:solidFill>
                 <a:latin typeface="Cambria"/>
               </a:rPr>
-              <a:t>Half rate</a:t>
+              <a:t>Fixed burst shape</a:t>
             </a:r>
           </a:p>
         </p:txBody>
@@ -7659,7 +7659,7 @@
                 </a:solidFill>
                 <a:latin typeface="Calibri"/>
               </a:rPr>
-              <a:t>One beat every two clocks, because each stage holds one beat at a time.</a:t>
+              <a:t>The master always writes and reads four words, with all four bytes enabled.</a:t>
             </a:r>
           </a:p>
         </p:txBody>
@@ -7738,7 +7738,7 @@
                 </a:solidFill>
                 <a:latin typeface="Cambria"/>
               </a:rPr>
-              <a:t>Fixed data</a:t>
+              <a:t>Load, then start</a:t>
             </a:r>
           </a:p>
         </p:txBody>
@@ -7773,7 +7773,7 @@
                 </a:solidFill>
                 <a:latin typeface="Calibri"/>
               </a:rPr>
-              <a:t>The master sends four built-in words to 0x10. Changing them means editing the file.</a:t>
+              <a:t>The input DFFs must not change while a sequence runs. The master reads them live.</a:t>
             </a:r>
           </a:p>
         </p:txBody>
@@ -8243,7 +8243,7 @@
         <p:spPr>
           <a:xfrm>
             <a:off x="640080" y="6400800"/>
-            <a:ext cx="7315200" cy="274320"/>
+            <a:ext cx="9144000" cy="274320"/>
           </a:xfrm>
           <a:prstGeom prst="rect">
             <a:avLst/>
@@ -8264,7 +8264,7 @@
                 </a:solidFill>
                 <a:latin typeface="Calibri"/>
               </a:rPr>
-              <a:t>AXI4: a master, D flip-flop stages and a memory, in Verilog</a:t>
+              <a:t>AXI4: input D flip-flops, a master, a slave and output D flip-flops, in Verilog</a:t>
             </a:r>
           </a:p>
         </p:txBody>
@@ -8565,7 +8565,7 @@
                 </a:solidFill>
                 <a:latin typeface="Calibri"/>
               </a:rPr>
-              <a:t>Check counts: 33 and 13</a:t>
+              <a:t>Check counts: 33 and 43</a:t>
             </a:r>
           </a:p>
           <a:p>
@@ -8581,7 +8581,7 @@
                 </a:solidFill>
                 <a:latin typeface="Calibri"/>
               </a:rPr>
-              <a:t>"the whole sequence took 27 clock cycles"</a:t>
+              <a:t>"the whole sequence took 13 clock cycles"</a:t>
             </a:r>
           </a:p>
         </p:txBody>
@@ -8690,7 +8690,7 @@
         <p:spPr>
           <a:xfrm>
             <a:off x="640080" y="6400800"/>
-            <a:ext cx="7315200" cy="274320"/>
+            <a:ext cx="9144000" cy="274320"/>
           </a:xfrm>
           <a:prstGeom prst="rect">
             <a:avLst/>
@@ -8711,7 +8711,7 @@
                 </a:solidFill>
                 <a:latin typeface="Calibri"/>
               </a:rPr>
-              <a:t>AXI4: a master, D flip-flop stages and a memory, in Verilog</a:t>
+              <a:t>AXI4: input D flip-flops, a master, a slave and output D flip-flops, in Verilog</a:t>
             </a:r>
           </a:p>
         </p:txBody>
@@ -9000,7 +9000,7 @@
                 </a:solidFill>
                 <a:latin typeface="Cambria"/>
               </a:rPr>
-              <a:t>Why not a bare flip-flop?</a:t>
+              <a:t>Is there an interconnect?</a:t>
             </a:r>
           </a:p>
         </p:txBody>
@@ -9035,7 +9035,7 @@
                 </a:solidFill>
                 <a:latin typeface="Calibri"/>
               </a:rPr>
-              <a:t>READY would arrive late and a beat could be sent twice. The stage reports full from a flip-flop.</a:t>
+              <a:t>No. One master and one slave are wired directly. An interconnect is for more of either.</a:t>
             </a:r>
           </a:p>
         </p:txBody>
@@ -9114,7 +9114,7 @@
                 </a:solidFill>
                 <a:latin typeface="Cambria"/>
               </a:rPr>
-              <a:t>What does the stage cost?</a:t>
+              <a:t>Where does the data come from?</a:t>
             </a:r>
           </a:p>
         </p:txBody>
@@ -9149,7 +9149,7 @@
                 </a:solidFill>
                 <a:latin typeface="Calibri"/>
               </a:rPr>
-              <a:t>One beat moves every two clocks, because a stage holds one beat at a time.</a:t>
+              <a:t>From the input D flip-flops, loaded by the testbench. The master reads them and writes to the slave.</a:t>
             </a:r>
           </a:p>
         </p:txBody>
@@ -9228,7 +9228,7 @@
                 </a:solidFill>
                 <a:latin typeface="Cambria"/>
               </a:rPr>
-              <a:t>Where does the data come from?</a:t>
+              <a:t>Where does the read data go?</a:t>
             </a:r>
           </a:p>
         </p:txBody>
@@ -9263,7 +9263,7 @@
                 </a:solidFill>
                 <a:latin typeface="Calibri"/>
               </a:rPr>
-              <a:t>D flip-flop registers inside the master, set at reset and sent beat by beat.</a:t>
+              <a:t>Into the output D flip-flops, one register per beat. pass compares them with the input.</a:t>
             </a:r>
           </a:p>
         </p:txBody>
@@ -9377,7 +9377,7 @@
                 </a:solidFill>
                 <a:latin typeface="Calibri"/>
               </a:rPr>
-              <a:t>The master reads the words back and compares. The testbench also checks the slave's memory.</a:t>
+              <a:t>pass compares read-back with what was written. The testbench also checks the slave's memory.</a:t>
             </a:r>
           </a:p>
         </p:txBody>
@@ -9505,7 +9505,7 @@
         <p:spPr>
           <a:xfrm>
             <a:off x="640080" y="6400800"/>
-            <a:ext cx="7315200" cy="274320"/>
+            <a:ext cx="9144000" cy="274320"/>
           </a:xfrm>
           <a:prstGeom prst="rect">
             <a:avLst/>
@@ -9526,7 +9526,7 @@
                 </a:solidFill>
                 <a:latin typeface="Calibri"/>
               </a:rPr>
-              <a:t>AXI4: a master, D flip-flop stages and a memory, in Verilog</a:t>
+              <a:t>AXI4: input D flip-flops, a master, a slave and output D flip-flops, in Verilog</a:t>
             </a:r>
           </a:p>
         </p:txBody>
@@ -9657,7 +9657,7 @@
                 </a:solidFill>
                 <a:latin typeface="Calibri"/>
               </a:rPr>
-              <a:t>Four files, each with one job.</a:t>
+              <a:t>Five files, each with one job.</a:t>
             </a:r>
           </a:p>
         </p:txBody>
@@ -9671,7 +9671,156 @@
         <p:spPr>
           <a:xfrm>
             <a:off x="640080" y="2011680"/>
-            <a:ext cx="2577007" cy="3566160"/>
+            <a:ext cx="2050633" cy="3566160"/>
+          </a:xfrm>
+          <a:prstGeom prst="roundRect">
+            <a:avLst>
+              <a:gd name="adj" fmla="val 6000"/>
+            </a:avLst>
+          </a:prstGeom>
+          <a:solidFill>
+            <a:srgbClr val="FFE9A8"/>
+          </a:solidFill>
+          <a:ln>
+            <a:noFill/>
+          </a:ln>
+          <a:effectLst/>
+        </p:spPr>
+        <p:style>
+          <a:lnRef idx="1">
+            <a:schemeClr val="accent1"/>
+          </a:lnRef>
+          <a:fillRef idx="3">
+            <a:schemeClr val="accent1"/>
+          </a:fillRef>
+          <a:effectRef idx="2">
+            <a:schemeClr val="accent1"/>
+          </a:effectRef>
+          <a:fontRef idx="minor">
+            <a:schemeClr val="lt1"/>
+          </a:fontRef>
+        </p:style>
+        <p:txBody>
+          <a:bodyPr rtlCol="0" anchor="ctr"/>
+          <a:lstStyle/>
+          <a:p/>
+        </p:txBody>
+      </p:sp>
+      <p:sp>
+        <p:nvSpPr>
+          <p:cNvPr id="5" name="TextBox 4"/>
+          <p:cNvSpPr txBox="1"/>
+          <p:nvPr/>
+        </p:nvSpPr>
+        <p:spPr>
+          <a:xfrm>
+            <a:off x="896112" y="2240280"/>
+            <a:ext cx="1538569" cy="457200"/>
+          </a:xfrm>
+          <a:prstGeom prst="rect">
+            <a:avLst/>
+          </a:prstGeom>
+          <a:noFill/>
+        </p:spPr>
+        <p:txBody>
+          <a:bodyPr wrap="square" lIns="0" rIns="0" tIns="0" bIns="0" anchor="t">
+            <a:spAutoFit/>
+          </a:bodyPr>
+          <a:lstStyle/>
+          <a:p>
+            <a:pPr algn="l"/>
+            <a:r>
+              <a:rPr sz="2000" b="1" i="0">
+                <a:solidFill>
+                  <a:srgbClr val="1E2A3B"/>
+                </a:solidFill>
+                <a:latin typeface="Cambria"/>
+              </a:rPr>
+              <a:t>Input DFFs</a:t>
+            </a:r>
+          </a:p>
+        </p:txBody>
+      </p:sp>
+      <p:sp>
+        <p:nvSpPr>
+          <p:cNvPr id="6" name="TextBox 5"/>
+          <p:cNvSpPr txBox="1"/>
+          <p:nvPr/>
+        </p:nvSpPr>
+        <p:spPr>
+          <a:xfrm>
+            <a:off x="896112" y="2788920"/>
+            <a:ext cx="1538569" cy="320040"/>
+          </a:xfrm>
+          <a:prstGeom prst="rect">
+            <a:avLst/>
+          </a:prstGeom>
+          <a:noFill/>
+        </p:spPr>
+        <p:txBody>
+          <a:bodyPr wrap="square" lIns="0" rIns="0" tIns="0" bIns="0" anchor="t">
+            <a:spAutoFit/>
+          </a:bodyPr>
+          <a:lstStyle/>
+          <a:p>
+            <a:pPr algn="l"/>
+            <a:r>
+              <a:rPr sz="1300" b="0" i="0">
+                <a:solidFill>
+                  <a:srgbClr val="4F5F74"/>
+                </a:solidFill>
+                <a:latin typeface="Consolas"/>
+              </a:rPr>
+              <a:t>axi4_in_dff.v</a:t>
+            </a:r>
+          </a:p>
+        </p:txBody>
+      </p:sp>
+      <p:sp>
+        <p:nvSpPr>
+          <p:cNvPr id="7" name="TextBox 6"/>
+          <p:cNvSpPr txBox="1"/>
+          <p:nvPr/>
+        </p:nvSpPr>
+        <p:spPr>
+          <a:xfrm>
+            <a:off x="896112" y="3246120"/>
+            <a:ext cx="1538569" cy="2148839"/>
+          </a:xfrm>
+          <a:prstGeom prst="rect">
+            <a:avLst/>
+          </a:prstGeom>
+          <a:noFill/>
+        </p:spPr>
+        <p:txBody>
+          <a:bodyPr wrap="square" lIns="0" rIns="0" tIns="0" bIns="0" anchor="t">
+            <a:spAutoFit/>
+          </a:bodyPr>
+          <a:lstStyle/>
+          <a:p>
+            <a:pPr algn="l"/>
+            <a:r>
+              <a:rPr sz="1500" b="0" i="0">
+                <a:solidFill>
+                  <a:srgbClr val="1E2A3B"/>
+                </a:solidFill>
+                <a:latin typeface="Calibri"/>
+              </a:rPr>
+              <a:t>Five registers: an address and four words. The testbench loads them.</a:t>
+            </a:r>
+          </a:p>
+        </p:txBody>
+      </p:sp>
+      <p:sp>
+        <p:nvSpPr>
+          <p:cNvPr id="8" name="Rounded Rectangle 7"/>
+          <p:cNvSpPr/>
+          <p:nvPr/>
+        </p:nvSpPr>
+        <p:spPr>
+          <a:xfrm>
+            <a:off x="2855305" y="2011680"/>
+            <a:ext cx="2050633" cy="3566160"/>
           </a:xfrm>
           <a:prstGeom prst="roundRect">
             <a:avLst>
@@ -9708,14 +9857,14 @@
       </p:sp>
       <p:sp>
         <p:nvSpPr>
-          <p:cNvPr id="5" name="TextBox 4"/>
-          <p:cNvSpPr txBox="1"/>
-          <p:nvPr/>
-        </p:nvSpPr>
-        <p:spPr>
-          <a:xfrm>
-            <a:off x="896112" y="2240280"/>
-            <a:ext cx="2064943" cy="457200"/>
+          <p:cNvPr id="9" name="TextBox 8"/>
+          <p:cNvSpPr txBox="1"/>
+          <p:nvPr/>
+        </p:nvSpPr>
+        <p:spPr>
+          <a:xfrm>
+            <a:off x="3111337" y="2240280"/>
+            <a:ext cx="1538569" cy="457200"/>
           </a:xfrm>
           <a:prstGeom prst="rect">
             <a:avLst/>
@@ -9730,7 +9879,7 @@
           <a:p>
             <a:pPr algn="l"/>
             <a:r>
-              <a:rPr sz="2200" b="1" i="0">
+              <a:rPr sz="2000" b="1" i="0">
                 <a:solidFill>
                   <a:srgbClr val="1E2A3B"/>
                 </a:solidFill>
@@ -9743,14 +9892,14 @@
       </p:sp>
       <p:sp>
         <p:nvSpPr>
-          <p:cNvPr id="6" name="TextBox 5"/>
-          <p:cNvSpPr txBox="1"/>
-          <p:nvPr/>
-        </p:nvSpPr>
-        <p:spPr>
-          <a:xfrm>
-            <a:off x="896112" y="2788920"/>
-            <a:ext cx="2064943" cy="320040"/>
+          <p:cNvPr id="10" name="TextBox 9"/>
+          <p:cNvSpPr txBox="1"/>
+          <p:nvPr/>
+        </p:nvSpPr>
+        <p:spPr>
+          <a:xfrm>
+            <a:off x="3111337" y="2788920"/>
+            <a:ext cx="1538569" cy="320040"/>
           </a:xfrm>
           <a:prstGeom prst="rect">
             <a:avLst/>
@@ -9778,14 +9927,14 @@
       </p:sp>
       <p:sp>
         <p:nvSpPr>
-          <p:cNvPr id="7" name="TextBox 6"/>
-          <p:cNvSpPr txBox="1"/>
-          <p:nvPr/>
-        </p:nvSpPr>
-        <p:spPr>
-          <a:xfrm>
-            <a:off x="896112" y="3246120"/>
-            <a:ext cx="2064943" cy="2148839"/>
+          <p:cNvPr id="11" name="TextBox 10"/>
+          <p:cNvSpPr txBox="1"/>
+          <p:nvPr/>
+        </p:nvSpPr>
+        <p:spPr>
+          <a:xfrm>
+            <a:off x="3111337" y="3246120"/>
+            <a:ext cx="1538569" cy="2148839"/>
           </a:xfrm>
           <a:prstGeom prst="rect">
             <a:avLst/>
@@ -9800,27 +9949,176 @@
           <a:p>
             <a:pPr algn="l"/>
             <a:r>
-              <a:rPr sz="1600" b="0" i="0">
+              <a:rPr sz="1500" b="0" i="0">
                 <a:solidFill>
                   <a:srgbClr val="1E2A3B"/>
                 </a:solidFill>
                 <a:latin typeface="Calibri"/>
               </a:rPr>
-              <a:t>Holds an address and four words in D flip-flop registers. Writes them, reads them back, compares.</a:t>
-            </a:r>
-          </a:p>
-        </p:txBody>
-      </p:sp>
-      <p:sp>
-        <p:nvSpPr>
-          <p:cNvPr id="8" name="Rounded Rectangle 7"/>
+              <a:t>Takes the data from the input DFFs. Writes it, then reads it back.</a:t>
+            </a:r>
+          </a:p>
+        </p:txBody>
+      </p:sp>
+      <p:sp>
+        <p:nvSpPr>
+          <p:cNvPr id="12" name="Rounded Rectangle 11"/>
           <p:cNvSpPr/>
           <p:nvPr/>
         </p:nvSpPr>
         <p:spPr>
           <a:xfrm>
-            <a:off x="3418255" y="2011680"/>
-            <a:ext cx="2577007" cy="3566160"/>
+            <a:off x="5070530" y="2011680"/>
+            <a:ext cx="2050633" cy="3566160"/>
+          </a:xfrm>
+          <a:prstGeom prst="roundRect">
+            <a:avLst>
+              <a:gd name="adj" fmla="val 6000"/>
+            </a:avLst>
+          </a:prstGeom>
+          <a:solidFill>
+            <a:srgbClr val="E6DEFA"/>
+          </a:solidFill>
+          <a:ln>
+            <a:noFill/>
+          </a:ln>
+          <a:effectLst/>
+        </p:spPr>
+        <p:style>
+          <a:lnRef idx="1">
+            <a:schemeClr val="accent1"/>
+          </a:lnRef>
+          <a:fillRef idx="3">
+            <a:schemeClr val="accent1"/>
+          </a:fillRef>
+          <a:effectRef idx="2">
+            <a:schemeClr val="accent1"/>
+          </a:effectRef>
+          <a:fontRef idx="minor">
+            <a:schemeClr val="lt1"/>
+          </a:fontRef>
+        </p:style>
+        <p:txBody>
+          <a:bodyPr rtlCol="0" anchor="ctr"/>
+          <a:lstStyle/>
+          <a:p/>
+        </p:txBody>
+      </p:sp>
+      <p:sp>
+        <p:nvSpPr>
+          <p:cNvPr id="13" name="TextBox 12"/>
+          <p:cNvSpPr txBox="1"/>
+          <p:nvPr/>
+        </p:nvSpPr>
+        <p:spPr>
+          <a:xfrm>
+            <a:off x="5326562" y="2240280"/>
+            <a:ext cx="1538569" cy="457200"/>
+          </a:xfrm>
+          <a:prstGeom prst="rect">
+            <a:avLst/>
+          </a:prstGeom>
+          <a:noFill/>
+        </p:spPr>
+        <p:txBody>
+          <a:bodyPr wrap="square" lIns="0" rIns="0" tIns="0" bIns="0" anchor="t">
+            <a:spAutoFit/>
+          </a:bodyPr>
+          <a:lstStyle/>
+          <a:p>
+            <a:pPr algn="l"/>
+            <a:r>
+              <a:rPr sz="2000" b="1" i="0">
+                <a:solidFill>
+                  <a:srgbClr val="1E2A3B"/>
+                </a:solidFill>
+                <a:latin typeface="Cambria"/>
+              </a:rPr>
+              <a:t>Slave</a:t>
+            </a:r>
+          </a:p>
+        </p:txBody>
+      </p:sp>
+      <p:sp>
+        <p:nvSpPr>
+          <p:cNvPr id="14" name="TextBox 13"/>
+          <p:cNvSpPr txBox="1"/>
+          <p:nvPr/>
+        </p:nvSpPr>
+        <p:spPr>
+          <a:xfrm>
+            <a:off x="5326562" y="2788920"/>
+            <a:ext cx="1538569" cy="320040"/>
+          </a:xfrm>
+          <a:prstGeom prst="rect">
+            <a:avLst/>
+          </a:prstGeom>
+          <a:noFill/>
+        </p:spPr>
+        <p:txBody>
+          <a:bodyPr wrap="square" lIns="0" rIns="0" tIns="0" bIns="0" anchor="t">
+            <a:spAutoFit/>
+          </a:bodyPr>
+          <a:lstStyle/>
+          <a:p>
+            <a:pPr algn="l"/>
+            <a:r>
+              <a:rPr sz="1300" b="0" i="0">
+                <a:solidFill>
+                  <a:srgbClr val="4F5F74"/>
+                </a:solidFill>
+                <a:latin typeface="Consolas"/>
+              </a:rPr>
+              <a:t>axi4_slave.v</a:t>
+            </a:r>
+          </a:p>
+        </p:txBody>
+      </p:sp>
+      <p:sp>
+        <p:nvSpPr>
+          <p:cNvPr id="15" name="TextBox 14"/>
+          <p:cNvSpPr txBox="1"/>
+          <p:nvPr/>
+        </p:nvSpPr>
+        <p:spPr>
+          <a:xfrm>
+            <a:off x="5326562" y="3246120"/>
+            <a:ext cx="1538569" cy="2148839"/>
+          </a:xfrm>
+          <a:prstGeom prst="rect">
+            <a:avLst/>
+          </a:prstGeom>
+          <a:noFill/>
+        </p:spPr>
+        <p:txBody>
+          <a:bodyPr wrap="square" lIns="0" rIns="0" tIns="0" bIns="0" anchor="t">
+            <a:spAutoFit/>
+          </a:bodyPr>
+          <a:lstStyle/>
+          <a:p>
+            <a:pPr algn="l"/>
+            <a:r>
+              <a:rPr sz="1500" b="0" i="0">
+                <a:solidFill>
+                  <a:srgbClr val="1E2A3B"/>
+                </a:solidFill>
+                <a:latin typeface="Calibri"/>
+              </a:rPr>
+              <a:t>A 4 KiB memory. Answers bursts of up to 256 beats.</a:t>
+            </a:r>
+          </a:p>
+        </p:txBody>
+      </p:sp>
+      <p:sp>
+        <p:nvSpPr>
+          <p:cNvPr id="16" name="Rounded Rectangle 15"/>
+          <p:cNvSpPr/>
+          <p:nvPr/>
+        </p:nvSpPr>
+        <p:spPr>
+          <a:xfrm>
+            <a:off x="7285756" y="2011680"/>
+            <a:ext cx="2050633" cy="3566160"/>
           </a:xfrm>
           <a:prstGeom prst="roundRect">
             <a:avLst>
@@ -9857,14 +10155,14 @@
       </p:sp>
       <p:sp>
         <p:nvSpPr>
-          <p:cNvPr id="9" name="TextBox 8"/>
-          <p:cNvSpPr txBox="1"/>
-          <p:nvPr/>
-        </p:nvSpPr>
-        <p:spPr>
-          <a:xfrm>
-            <a:off x="3674287" y="2240280"/>
-            <a:ext cx="2064943" cy="457200"/>
+          <p:cNvPr id="17" name="TextBox 16"/>
+          <p:cNvSpPr txBox="1"/>
+          <p:nvPr/>
+        </p:nvSpPr>
+        <p:spPr>
+          <a:xfrm>
+            <a:off x="7541788" y="2240280"/>
+            <a:ext cx="1538569" cy="457200"/>
           </a:xfrm>
           <a:prstGeom prst="rect">
             <a:avLst/>
@@ -9879,27 +10177,27 @@
           <a:p>
             <a:pPr algn="l"/>
             <a:r>
-              <a:rPr sz="2200" b="1" i="0">
+              <a:rPr sz="2000" b="1" i="0">
                 <a:solidFill>
                   <a:srgbClr val="1E2A3B"/>
                 </a:solidFill>
                 <a:latin typeface="Cambria"/>
               </a:rPr>
-              <a:t>Stage</a:t>
-            </a:r>
-          </a:p>
-        </p:txBody>
-      </p:sp>
-      <p:sp>
-        <p:nvSpPr>
-          <p:cNvPr id="10" name="TextBox 9"/>
-          <p:cNvSpPr txBox="1"/>
-          <p:nvPr/>
-        </p:nvSpPr>
-        <p:spPr>
-          <a:xfrm>
-            <a:off x="3674287" y="2788920"/>
-            <a:ext cx="2064943" cy="320040"/>
+              <a:t>Output DFFs</a:t>
+            </a:r>
+          </a:p>
+        </p:txBody>
+      </p:sp>
+      <p:sp>
+        <p:nvSpPr>
+          <p:cNvPr id="18" name="TextBox 17"/>
+          <p:cNvSpPr txBox="1"/>
+          <p:nvPr/>
+        </p:nvSpPr>
+        <p:spPr>
+          <a:xfrm>
+            <a:off x="7541788" y="2788920"/>
+            <a:ext cx="1538569" cy="320040"/>
           </a:xfrm>
           <a:prstGeom prst="rect">
             <a:avLst/>
@@ -9920,21 +10218,21 @@
                 </a:solidFill>
                 <a:latin typeface="Consolas"/>
               </a:rPr>
-              <a:t>axi4_reg_stage.v</a:t>
-            </a:r>
-          </a:p>
-        </p:txBody>
-      </p:sp>
-      <p:sp>
-        <p:nvSpPr>
-          <p:cNvPr id="11" name="TextBox 10"/>
-          <p:cNvSpPr txBox="1"/>
-          <p:nvPr/>
-        </p:nvSpPr>
-        <p:spPr>
-          <a:xfrm>
-            <a:off x="3674287" y="3246120"/>
-            <a:ext cx="2064943" cy="2148839"/>
+              <a:t>axi4_out_dff.v</a:t>
+            </a:r>
+          </a:p>
+        </p:txBody>
+      </p:sp>
+      <p:sp>
+        <p:nvSpPr>
+          <p:cNvPr id="19" name="TextBox 18"/>
+          <p:cNvSpPr txBox="1"/>
+          <p:nvPr/>
+        </p:nvSpPr>
+        <p:spPr>
+          <a:xfrm>
+            <a:off x="7541788" y="3246120"/>
+            <a:ext cx="1538569" cy="2148839"/>
           </a:xfrm>
           <a:prstGeom prst="rect">
             <a:avLst/>
@@ -9949,176 +10247,27 @@
           <a:p>
             <a:pPr algn="l"/>
             <a:r>
-              <a:rPr sz="1600" b="0" i="0">
+              <a:rPr sz="1500" b="0" i="0">
                 <a:solidFill>
                   <a:srgbClr val="1E2A3B"/>
                 </a:solidFill>
                 <a:latin typeface="Calibri"/>
               </a:rPr>
-              <a:t>A D flip-flop stage that holds one beat. Two of them sit on every channel.</a:t>
-            </a:r>
-          </a:p>
-        </p:txBody>
-      </p:sp>
-      <p:sp>
-        <p:nvSpPr>
-          <p:cNvPr id="12" name="Rounded Rectangle 11"/>
+              <a:t>Four registers that hold the words read back.</a:t>
+            </a:r>
+          </a:p>
+        </p:txBody>
+      </p:sp>
+      <p:sp>
+        <p:nvSpPr>
+          <p:cNvPr id="20" name="Rounded Rectangle 19"/>
           <p:cNvSpPr/>
           <p:nvPr/>
         </p:nvSpPr>
         <p:spPr>
           <a:xfrm>
-            <a:off x="6196431" y="2011680"/>
-            <a:ext cx="2577007" cy="3566160"/>
-          </a:xfrm>
-          <a:prstGeom prst="roundRect">
-            <a:avLst>
-              <a:gd name="adj" fmla="val 6000"/>
-            </a:avLst>
-          </a:prstGeom>
-          <a:solidFill>
-            <a:srgbClr val="E6DEFA"/>
-          </a:solidFill>
-          <a:ln>
-            <a:noFill/>
-          </a:ln>
-          <a:effectLst/>
-        </p:spPr>
-        <p:style>
-          <a:lnRef idx="1">
-            <a:schemeClr val="accent1"/>
-          </a:lnRef>
-          <a:fillRef idx="3">
-            <a:schemeClr val="accent1"/>
-          </a:fillRef>
-          <a:effectRef idx="2">
-            <a:schemeClr val="accent1"/>
-          </a:effectRef>
-          <a:fontRef idx="minor">
-            <a:schemeClr val="lt1"/>
-          </a:fontRef>
-        </p:style>
-        <p:txBody>
-          <a:bodyPr rtlCol="0" anchor="ctr"/>
-          <a:lstStyle/>
-          <a:p/>
-        </p:txBody>
-      </p:sp>
-      <p:sp>
-        <p:nvSpPr>
-          <p:cNvPr id="13" name="TextBox 12"/>
-          <p:cNvSpPr txBox="1"/>
-          <p:nvPr/>
-        </p:nvSpPr>
-        <p:spPr>
-          <a:xfrm>
-            <a:off x="6452463" y="2240280"/>
-            <a:ext cx="2064943" cy="457200"/>
-          </a:xfrm>
-          <a:prstGeom prst="rect">
-            <a:avLst/>
-          </a:prstGeom>
-          <a:noFill/>
-        </p:spPr>
-        <p:txBody>
-          <a:bodyPr wrap="square" lIns="0" rIns="0" tIns="0" bIns="0" anchor="t">
-            <a:spAutoFit/>
-          </a:bodyPr>
-          <a:lstStyle/>
-          <a:p>
-            <a:pPr algn="l"/>
-            <a:r>
-              <a:rPr sz="2200" b="1" i="0">
-                <a:solidFill>
-                  <a:srgbClr val="1E2A3B"/>
-                </a:solidFill>
-                <a:latin typeface="Cambria"/>
-              </a:rPr>
-              <a:t>Slave</a:t>
-            </a:r>
-          </a:p>
-        </p:txBody>
-      </p:sp>
-      <p:sp>
-        <p:nvSpPr>
-          <p:cNvPr id="14" name="TextBox 13"/>
-          <p:cNvSpPr txBox="1"/>
-          <p:nvPr/>
-        </p:nvSpPr>
-        <p:spPr>
-          <a:xfrm>
-            <a:off x="6452463" y="2788920"/>
-            <a:ext cx="2064943" cy="320040"/>
-          </a:xfrm>
-          <a:prstGeom prst="rect">
-            <a:avLst/>
-          </a:prstGeom>
-          <a:noFill/>
-        </p:spPr>
-        <p:txBody>
-          <a:bodyPr wrap="square" lIns="0" rIns="0" tIns="0" bIns="0" anchor="t">
-            <a:spAutoFit/>
-          </a:bodyPr>
-          <a:lstStyle/>
-          <a:p>
-            <a:pPr algn="l"/>
-            <a:r>
-              <a:rPr sz="1300" b="0" i="0">
-                <a:solidFill>
-                  <a:srgbClr val="4F5F74"/>
-                </a:solidFill>
-                <a:latin typeface="Consolas"/>
-              </a:rPr>
-              <a:t>axi4_slave.v</a:t>
-            </a:r>
-          </a:p>
-        </p:txBody>
-      </p:sp>
-      <p:sp>
-        <p:nvSpPr>
-          <p:cNvPr id="15" name="TextBox 14"/>
-          <p:cNvSpPr txBox="1"/>
-          <p:nvPr/>
-        </p:nvSpPr>
-        <p:spPr>
-          <a:xfrm>
-            <a:off x="6452463" y="3246120"/>
-            <a:ext cx="2064943" cy="2148839"/>
-          </a:xfrm>
-          <a:prstGeom prst="rect">
-            <a:avLst/>
-          </a:prstGeom>
-          <a:noFill/>
-        </p:spPr>
-        <p:txBody>
-          <a:bodyPr wrap="square" lIns="0" rIns="0" tIns="0" bIns="0" anchor="t">
-            <a:spAutoFit/>
-          </a:bodyPr>
-          <a:lstStyle/>
-          <a:p>
-            <a:pPr algn="l"/>
-            <a:r>
-              <a:rPr sz="1600" b="0" i="0">
-                <a:solidFill>
-                  <a:srgbClr val="1E2A3B"/>
-                </a:solidFill>
-                <a:latin typeface="Calibri"/>
-              </a:rPr>
-              <a:t>A 4 KiB memory. Answers bursts of up to 256 beats on the five channels.</a:t>
-            </a:r>
-          </a:p>
-        </p:txBody>
-      </p:sp>
-      <p:sp>
-        <p:nvSpPr>
-          <p:cNvPr id="16" name="Rounded Rectangle 15"/>
-          <p:cNvSpPr/>
-          <p:nvPr/>
-        </p:nvSpPr>
-        <p:spPr>
-          <a:xfrm>
-            <a:off x="8974607" y="2011680"/>
-            <a:ext cx="2577007" cy="3566160"/>
+            <a:off x="9500981" y="2011680"/>
+            <a:ext cx="2050633" cy="3566160"/>
           </a:xfrm>
           <a:prstGeom prst="roundRect">
             <a:avLst>
@@ -10155,14 +10304,14 @@
       </p:sp>
       <p:sp>
         <p:nvSpPr>
-          <p:cNvPr id="17" name="TextBox 16"/>
-          <p:cNvSpPr txBox="1"/>
-          <p:nvPr/>
-        </p:nvSpPr>
-        <p:spPr>
-          <a:xfrm>
-            <a:off x="9230639" y="2240280"/>
-            <a:ext cx="2064943" cy="457200"/>
+          <p:cNvPr id="21" name="TextBox 20"/>
+          <p:cNvSpPr txBox="1"/>
+          <p:nvPr/>
+        </p:nvSpPr>
+        <p:spPr>
+          <a:xfrm>
+            <a:off x="9757013" y="2240280"/>
+            <a:ext cx="1538569" cy="457200"/>
           </a:xfrm>
           <a:prstGeom prst="rect">
             <a:avLst/>
@@ -10177,7 +10326,7 @@
           <a:p>
             <a:pPr algn="l"/>
             <a:r>
-              <a:rPr sz="2200" b="1" i="0">
+              <a:rPr sz="2000" b="1" i="0">
                 <a:solidFill>
                   <a:srgbClr val="1E2A3B"/>
                 </a:solidFill>
@@ -10190,14 +10339,14 @@
       </p:sp>
       <p:sp>
         <p:nvSpPr>
-          <p:cNvPr id="18" name="TextBox 17"/>
-          <p:cNvSpPr txBox="1"/>
-          <p:nvPr/>
-        </p:nvSpPr>
-        <p:spPr>
-          <a:xfrm>
-            <a:off x="9230639" y="2788920"/>
-            <a:ext cx="2064943" cy="320040"/>
+          <p:cNvPr id="22" name="TextBox 21"/>
+          <p:cNvSpPr txBox="1"/>
+          <p:nvPr/>
+        </p:nvSpPr>
+        <p:spPr>
+          <a:xfrm>
+            <a:off x="9757013" y="2788920"/>
+            <a:ext cx="1538569" cy="320040"/>
           </a:xfrm>
           <a:prstGeom prst="rect">
             <a:avLst/>
@@ -10225,14 +10374,14 @@
       </p:sp>
       <p:sp>
         <p:nvSpPr>
-          <p:cNvPr id="19" name="TextBox 18"/>
-          <p:cNvSpPr txBox="1"/>
-          <p:nvPr/>
-        </p:nvSpPr>
-        <p:spPr>
-          <a:xfrm>
-            <a:off x="9230639" y="3246120"/>
-            <a:ext cx="2064943" cy="2148839"/>
+          <p:cNvPr id="23" name="TextBox 22"/>
+          <p:cNvSpPr txBox="1"/>
+          <p:nvPr/>
+        </p:nvSpPr>
+        <p:spPr>
+          <a:xfrm>
+            <a:off x="9757013" y="3246120"/>
+            <a:ext cx="1538569" cy="2148839"/>
           </a:xfrm>
           <a:prstGeom prst="rect">
             <a:avLst/>
@@ -10247,20 +10396,20 @@
           <a:p>
             <a:pPr algn="l"/>
             <a:r>
-              <a:rPr sz="1600" b="0" i="0">
+              <a:rPr sz="1500" b="0" i="0">
                 <a:solidFill>
                   <a:srgbClr val="1E2A3B"/>
                 </a:solidFill>
                 <a:latin typeface="Calibri"/>
               </a:rPr>
-              <a:t>Wires the master, the ten stages and the slave together.</a:t>
-            </a:r>
-          </a:p>
-        </p:txBody>
-      </p:sp>
-      <p:sp>
-        <p:nvSpPr>
-          <p:cNvPr id="20" name="TextBox 19"/>
+              <a:t>Wires it all together. Master and slave connect directly.</a:t>
+            </a:r>
+          </a:p>
+        </p:txBody>
+      </p:sp>
+      <p:sp>
+        <p:nvSpPr>
+          <p:cNvPr id="24" name="TextBox 23"/>
           <p:cNvSpPr txBox="1"/>
           <p:nvPr/>
         </p:nvSpPr>
@@ -10295,14 +10444,14 @@
       </p:sp>
       <p:sp>
         <p:nvSpPr>
-          <p:cNvPr id="21" name="Footer"/>
+          <p:cNvPr id="25" name="Footer"/>
           <p:cNvSpPr txBox="1"/>
           <p:nvPr/>
         </p:nvSpPr>
         <p:spPr>
           <a:xfrm>
             <a:off x="640080" y="6400800"/>
-            <a:ext cx="7315200" cy="274320"/>
+            <a:ext cx="9144000" cy="274320"/>
           </a:xfrm>
           <a:prstGeom prst="rect">
             <a:avLst/>
@@ -10323,14 +10472,14 @@
                 </a:solidFill>
                 <a:latin typeface="Calibri"/>
               </a:rPr>
-              <a:t>AXI4: a master, D flip-flop stages and a memory, in Verilog</a:t>
-            </a:r>
-          </a:p>
-        </p:txBody>
-      </p:sp>
-      <p:sp>
-        <p:nvSpPr>
-          <p:cNvPr id="22" name="Page number"/>
+              <a:t>AXI4: input D flip-flops, a master, a slave and output D flip-flops, in Verilog</a:t>
+            </a:r>
+          </a:p>
+        </p:txBody>
+      </p:sp>
+      <p:sp>
+        <p:nvSpPr>
+          <p:cNvPr id="26" name="Page number"/>
           <p:cNvSpPr txBox="1"/>
           <p:nvPr/>
         </p:nvSpPr>
@@ -11144,7 +11293,7 @@
         <p:spPr>
           <a:xfrm>
             <a:off x="640080" y="6400800"/>
-            <a:ext cx="7315200" cy="274320"/>
+            <a:ext cx="9144000" cy="274320"/>
           </a:xfrm>
           <a:prstGeom prst="rect">
             <a:avLst/>
@@ -11165,7 +11314,7 @@
                 </a:solidFill>
                 <a:latin typeface="Calibri"/>
               </a:rPr>
-              <a:t>AXI4: a master, D flip-flop stages and a memory, in Verilog</a:t>
+              <a:t>AXI4: input D flip-flops, a master, a slave and output D flip-flops, in Verilog</a:t>
             </a:r>
           </a:p>
         </p:txBody>
@@ -13569,7 +13718,7 @@
         <p:spPr>
           <a:xfrm>
             <a:off x="640080" y="6400800"/>
-            <a:ext cx="7315200" cy="274320"/>
+            <a:ext cx="9144000" cy="274320"/>
           </a:xfrm>
           <a:prstGeom prst="rect">
             <a:avLst/>
@@ -13590,7 +13739,7 @@
                 </a:solidFill>
                 <a:latin typeface="Calibri"/>
               </a:rPr>
-              <a:t>AXI4: a master, D flip-flop stages and a memory, in Verilog</a:t>
+              <a:t>AXI4: input D flip-flops, a master, a slave and output D flip-flops, in Verilog</a:t>
             </a:r>
           </a:p>
         </p:txBody>
@@ -14962,7 +15111,7 @@
         <p:spPr>
           <a:xfrm>
             <a:off x="640080" y="6400800"/>
-            <a:ext cx="7315200" cy="274320"/>
+            <a:ext cx="9144000" cy="274320"/>
           </a:xfrm>
           <a:prstGeom prst="rect">
             <a:avLst/>
@@ -14983,7 +15132,7 @@
                 </a:solidFill>
                 <a:latin typeface="Calibri"/>
               </a:rPr>
-              <a:t>AXI4: a master, D flip-flop stages and a memory, in Verilog</a:t>
+              <a:t>AXI4: input D flip-flops, a master, a slave and output D flip-flops, in Verilog</a:t>
             </a:r>
           </a:p>
         </p:txBody>
@@ -15086,7 +15235,7 @@
       </p:sp>
       <p:pic>
         <p:nvPicPr>
-          <p:cNvPr id="3" name="Picture 2" descr="Block diagram: axi4_master, a D flip-flop stage at each end of every one of the five channels with signal names, axi4_slave with write engine, read engine and 4 KiB memory."/>
+          <p:cNvPr id="3" name="Picture 2" descr="Block diagram: input D flip-flops, axi4_master, the five channels connecting directly to axi4_slave with write engine, read engine and 4 KiB memory, and output D flip-flops that catch the read data."/>
           <p:cNvPicPr>
             <a:picLocks noChangeAspect="1"/>
           </p:cNvPicPr>
@@ -15100,8 +15249,8 @@
         </p:blipFill>
         <p:spPr>
           <a:xfrm>
-            <a:off x="822960" y="1325880"/>
-            <a:ext cx="10515600" cy="4673600"/>
+            <a:off x="822960" y="1371600"/>
+            <a:ext cx="10515600" cy="4089400"/>
           </a:xfrm>
           <a:prstGeom prst="rect">
             <a:avLst/>
@@ -15116,7 +15265,7 @@
         </p:nvSpPr>
         <p:spPr>
           <a:xfrm>
-            <a:off x="640080" y="6080760"/>
+            <a:off x="640080" y="5760720"/>
             <a:ext cx="10881360" cy="274320"/>
           </a:xfrm>
           <a:prstGeom prst="rect">
@@ -15138,7 +15287,7 @@
                 </a:solidFill>
                 <a:latin typeface="Calibri"/>
               </a:rPr>
-              <a:t>Amber boxes are the D flip-flop stages: ten in total, two on every channel.</a:t>
+              <a:t>Yellow boxes are the D flip-flops. The master and the slave are connected directly.</a:t>
             </a:r>
           </a:p>
         </p:txBody>
@@ -15152,7 +15301,7 @@
         <p:spPr>
           <a:xfrm>
             <a:off x="640080" y="6400800"/>
-            <a:ext cx="7315200" cy="274320"/>
+            <a:ext cx="9144000" cy="274320"/>
           </a:xfrm>
           <a:prstGeom prst="rect">
             <a:avLst/>
@@ -15173,7 +15322,7 @@
                 </a:solidFill>
                 <a:latin typeface="Calibri"/>
               </a:rPr>
-              <a:t>AXI4: a master, D flip-flop stages and a memory, in Verilog</a:t>
+              <a:t>AXI4: input D flip-flops, a master, a slave and output D flip-flops, in Verilog</a:t>
             </a:r>
           </a:p>
         </p:txBody>
@@ -15283,7 +15432,159 @@
         <p:spPr>
           <a:xfrm>
             <a:off x="640080" y="1463040"/>
-            <a:ext cx="1666189" cy="2651760"/>
+            <a:ext cx="1449062" cy="2651760"/>
+          </a:xfrm>
+          <a:prstGeom prst="roundRect">
+            <a:avLst>
+              <a:gd name="adj" fmla="val 6000"/>
+            </a:avLst>
+          </a:prstGeom>
+          <a:solidFill>
+            <a:srgbClr val="FFFFFF"/>
+          </a:solidFill>
+          <a:ln w="19050">
+            <a:solidFill>
+              <a:srgbClr val="D5DCE6"/>
+            </a:solidFill>
+          </a:ln>
+          <a:effectLst/>
+        </p:spPr>
+        <p:style>
+          <a:lnRef idx="1">
+            <a:schemeClr val="accent1"/>
+          </a:lnRef>
+          <a:fillRef idx="3">
+            <a:schemeClr val="accent1"/>
+          </a:fillRef>
+          <a:effectRef idx="2">
+            <a:schemeClr val="accent1"/>
+          </a:effectRef>
+          <a:fontRef idx="minor">
+            <a:schemeClr val="lt1"/>
+          </a:fontRef>
+        </p:style>
+        <p:txBody>
+          <a:bodyPr rtlCol="0" anchor="ctr"/>
+          <a:lstStyle/>
+          <a:p/>
+        </p:txBody>
+      </p:sp>
+      <p:sp>
+        <p:nvSpPr>
+          <p:cNvPr id="4" name="TextBox 3"/>
+          <p:cNvSpPr txBox="1"/>
+          <p:nvPr/>
+        </p:nvSpPr>
+        <p:spPr>
+          <a:xfrm>
+            <a:off x="749808" y="1627632"/>
+            <a:ext cx="1229606" cy="457200"/>
+          </a:xfrm>
+          <a:prstGeom prst="rect">
+            <a:avLst/>
+          </a:prstGeom>
+          <a:noFill/>
+        </p:spPr>
+        <p:txBody>
+          <a:bodyPr wrap="square" lIns="0" rIns="0" tIns="0" bIns="0" anchor="t">
+            <a:spAutoFit/>
+          </a:bodyPr>
+          <a:lstStyle/>
+          <a:p>
+            <a:pPr algn="l"/>
+            <a:r>
+              <a:rPr sz="1600" b="1" i="0">
+                <a:solidFill>
+                  <a:srgbClr val="1E2A3B"/>
+                </a:solidFill>
+                <a:latin typeface="Consolas"/>
+              </a:rPr>
+              <a:t>S_IDLE</a:t>
+            </a:r>
+          </a:p>
+        </p:txBody>
+      </p:sp>
+      <p:sp>
+        <p:nvSpPr>
+          <p:cNvPr id="5" name="TextBox 4"/>
+          <p:cNvSpPr txBox="1"/>
+          <p:nvPr/>
+        </p:nvSpPr>
+        <p:spPr>
+          <a:xfrm>
+            <a:off x="749808" y="2194560"/>
+            <a:ext cx="1229606" cy="1828800"/>
+          </a:xfrm>
+          <a:prstGeom prst="rect">
+            <a:avLst/>
+          </a:prstGeom>
+          <a:noFill/>
+        </p:spPr>
+        <p:txBody>
+          <a:bodyPr wrap="square" lIns="0" rIns="0" tIns="0" bIns="0" anchor="t">
+            <a:spAutoFit/>
+          </a:bodyPr>
+          <a:lstStyle/>
+          <a:p>
+            <a:pPr algn="l"/>
+            <a:r>
+              <a:rPr sz="1400" b="0" i="0">
+                <a:solidFill>
+                  <a:srgbClr val="1E2A3B"/>
+                </a:solidFill>
+                <a:latin typeface="Calibri"/>
+              </a:rPr>
+              <a:t>Waits for start.</a:t>
+            </a:r>
+          </a:p>
+        </p:txBody>
+      </p:sp>
+      <p:cxnSp>
+        <p:nvCxnSpPr>
+          <p:cNvPr id="6" name="Connector 5"/>
+          <p:cNvCxnSpPr/>
+          <p:nvPr/>
+        </p:nvCxnSpPr>
+        <p:spPr>
+          <a:xfrm>
+            <a:off x="2098286" y="2788920"/>
+            <a:ext cx="109728" cy="0"/>
+          </a:xfrm>
+          <a:prstGeom prst="line">
+            <a:avLst/>
+          </a:prstGeom>
+          <a:ln w="25400">
+            <a:solidFill>
+              <a:srgbClr val="4F5F74"/>
+            </a:solidFill>
+            <a:tailEnd type="triangle" w="med" len="med"/>
+          </a:ln>
+        </p:spPr>
+        <p:style>
+          <a:lnRef idx="2">
+            <a:schemeClr val="accent1"/>
+          </a:lnRef>
+          <a:fillRef idx="0">
+            <a:schemeClr val="accent1"/>
+          </a:fillRef>
+          <a:effectRef idx="1">
+            <a:schemeClr val="accent1"/>
+          </a:effectRef>
+          <a:fontRef idx="minor">
+            <a:schemeClr val="tx1"/>
+          </a:fontRef>
+        </p:style>
+      </p:cxnSp>
+      <p:sp>
+        <p:nvSpPr>
+          <p:cNvPr id="7" name="Rounded Rectangle 6"/>
+          <p:cNvSpPr/>
+          <p:nvPr/>
+        </p:nvSpPr>
+        <p:spPr>
+          <a:xfrm>
+            <a:off x="2217158" y="1463040"/>
+            <a:ext cx="1449062" cy="2651760"/>
           </a:xfrm>
           <a:prstGeom prst="roundRect">
             <a:avLst>
@@ -15320,14 +15621,14 @@
       </p:sp>
       <p:sp>
         <p:nvSpPr>
-          <p:cNvPr id="4" name="TextBox 3"/>
-          <p:cNvSpPr txBox="1"/>
-          <p:nvPr/>
-        </p:nvSpPr>
-        <p:spPr>
-          <a:xfrm>
-            <a:off x="777240" y="1627632"/>
-            <a:ext cx="1391869" cy="457200"/>
+          <p:cNvPr id="8" name="TextBox 7"/>
+          <p:cNvSpPr txBox="1"/>
+          <p:nvPr/>
+        </p:nvSpPr>
+        <p:spPr>
+          <a:xfrm>
+            <a:off x="2326886" y="1627632"/>
+            <a:ext cx="1229606" cy="457200"/>
           </a:xfrm>
           <a:prstGeom prst="rect">
             <a:avLst/>
@@ -15342,7 +15643,7 @@
           <a:p>
             <a:pPr algn="l"/>
             <a:r>
-              <a:rPr sz="1900" b="1" i="0">
+              <a:rPr sz="1600" b="1" i="0">
                 <a:solidFill>
                   <a:srgbClr val="1E2A3B"/>
                 </a:solidFill>
@@ -15355,14 +15656,14 @@
       </p:sp>
       <p:sp>
         <p:nvSpPr>
-          <p:cNvPr id="5" name="TextBox 4"/>
-          <p:cNvSpPr txBox="1"/>
-          <p:nvPr/>
-        </p:nvSpPr>
-        <p:spPr>
-          <a:xfrm>
-            <a:off x="777240" y="2194560"/>
-            <a:ext cx="1391869" cy="1828800"/>
+          <p:cNvPr id="9" name="TextBox 8"/>
+          <p:cNvSpPr txBox="1"/>
+          <p:nvPr/>
+        </p:nvSpPr>
+        <p:spPr>
+          <a:xfrm>
+            <a:off x="2326886" y="2194560"/>
+            <a:ext cx="1229606" cy="1828800"/>
           </a:xfrm>
           <a:prstGeom prst="rect">
             <a:avLst/>
@@ -15377,27 +15678,27 @@
           <a:p>
             <a:pPr algn="l"/>
             <a:r>
-              <a:rPr sz="1500" b="0" i="0">
+              <a:rPr sz="1400" b="0" i="0">
                 <a:solidFill>
                   <a:srgbClr val="1E2A3B"/>
                 </a:solidFill>
                 <a:latin typeface="Calibri"/>
               </a:rPr>
-              <a:t>Sends the write address: 0x10, four beats.</a:t>
+              <a:t>Sends the write address.</a:t>
             </a:r>
           </a:p>
         </p:txBody>
       </p:sp>
       <p:cxnSp>
         <p:nvCxnSpPr>
-          <p:cNvPr id="6" name="Connector 5"/>
+          <p:cNvPr id="10" name="Connector 9"/>
           <p:cNvCxnSpPr/>
           <p:nvPr/>
         </p:nvCxnSpPr>
         <p:spPr>
           <a:xfrm>
-            <a:off x="2324557" y="2788920"/>
-            <a:ext cx="146304" cy="0"/>
+            <a:off x="3675365" y="2788920"/>
+            <a:ext cx="109728" cy="0"/>
           </a:xfrm>
           <a:prstGeom prst="line">
             <a:avLst/>
@@ -15426,14 +15727,14 @@
       </p:cxnSp>
       <p:sp>
         <p:nvSpPr>
-          <p:cNvPr id="7" name="Rounded Rectangle 6"/>
+          <p:cNvPr id="11" name="Rounded Rectangle 10"/>
           <p:cNvSpPr/>
           <p:nvPr/>
         </p:nvSpPr>
         <p:spPr>
           <a:xfrm>
-            <a:off x="2489149" y="1463040"/>
-            <a:ext cx="1666189" cy="2651760"/>
+            <a:off x="3794237" y="1463040"/>
+            <a:ext cx="1449062" cy="2651760"/>
           </a:xfrm>
           <a:prstGeom prst="roundRect">
             <a:avLst>
@@ -15470,14 +15771,14 @@
       </p:sp>
       <p:sp>
         <p:nvSpPr>
-          <p:cNvPr id="8" name="TextBox 7"/>
-          <p:cNvSpPr txBox="1"/>
-          <p:nvPr/>
-        </p:nvSpPr>
-        <p:spPr>
-          <a:xfrm>
-            <a:off x="2626309" y="1627632"/>
-            <a:ext cx="1391869" cy="457200"/>
+          <p:cNvPr id="12" name="TextBox 11"/>
+          <p:cNvSpPr txBox="1"/>
+          <p:nvPr/>
+        </p:nvSpPr>
+        <p:spPr>
+          <a:xfrm>
+            <a:off x="3903965" y="1627632"/>
+            <a:ext cx="1229606" cy="457200"/>
           </a:xfrm>
           <a:prstGeom prst="rect">
             <a:avLst/>
@@ -15492,7 +15793,7 @@
           <a:p>
             <a:pPr algn="l"/>
             <a:r>
-              <a:rPr sz="1900" b="1" i="0">
+              <a:rPr sz="1600" b="1" i="0">
                 <a:solidFill>
                   <a:srgbClr val="1E2A3B"/>
                 </a:solidFill>
@@ -15505,14 +15806,14 @@
       </p:sp>
       <p:sp>
         <p:nvSpPr>
-          <p:cNvPr id="9" name="TextBox 8"/>
-          <p:cNvSpPr txBox="1"/>
-          <p:nvPr/>
-        </p:nvSpPr>
-        <p:spPr>
-          <a:xfrm>
-            <a:off x="2626309" y="2194560"/>
-            <a:ext cx="1391869" cy="1828800"/>
+          <p:cNvPr id="13" name="TextBox 12"/>
+          <p:cNvSpPr txBox="1"/>
+          <p:nvPr/>
+        </p:nvSpPr>
+        <p:spPr>
+          <a:xfrm>
+            <a:off x="3903965" y="2194560"/>
+            <a:ext cx="1229606" cy="1828800"/>
           </a:xfrm>
           <a:prstGeom prst="rect">
             <a:avLst/>
@@ -15527,27 +15828,27 @@
           <a:p>
             <a:pPr algn="l"/>
             <a:r>
-              <a:rPr sz="1500" b="0" i="0">
+              <a:rPr sz="1400" b="0" i="0">
                 <a:solidFill>
                   <a:srgbClr val="1E2A3B"/>
                 </a:solidFill>
                 <a:latin typeface="Calibri"/>
               </a:rPr>
-              <a:t>Sends the four words from the data registers. WLAST on the fourth.</a:t>
+              <a:t>Sends the four words from the input DFFs. WLAST on the fourth.</a:t>
             </a:r>
           </a:p>
         </p:txBody>
       </p:sp>
       <p:cxnSp>
         <p:nvCxnSpPr>
-          <p:cNvPr id="10" name="Connector 9"/>
+          <p:cNvPr id="14" name="Connector 13"/>
           <p:cNvCxnSpPr/>
           <p:nvPr/>
         </p:nvCxnSpPr>
         <p:spPr>
           <a:xfrm>
-            <a:off x="4173626" y="2788920"/>
-            <a:ext cx="146304" cy="0"/>
+            <a:off x="5252444" y="2788920"/>
+            <a:ext cx="109728" cy="0"/>
           </a:xfrm>
           <a:prstGeom prst="line">
             <a:avLst/>
@@ -15576,14 +15877,14 @@
       </p:cxnSp>
       <p:sp>
         <p:nvSpPr>
-          <p:cNvPr id="11" name="Rounded Rectangle 10"/>
+          <p:cNvPr id="15" name="Rounded Rectangle 14"/>
           <p:cNvSpPr/>
           <p:nvPr/>
         </p:nvSpPr>
         <p:spPr>
           <a:xfrm>
-            <a:off x="4338218" y="1463040"/>
-            <a:ext cx="1666189" cy="2651760"/>
+            <a:off x="5371316" y="1463040"/>
+            <a:ext cx="1449062" cy="2651760"/>
           </a:xfrm>
           <a:prstGeom prst="roundRect">
             <a:avLst>
@@ -15620,14 +15921,14 @@
       </p:sp>
       <p:sp>
         <p:nvSpPr>
-          <p:cNvPr id="12" name="TextBox 11"/>
-          <p:cNvSpPr txBox="1"/>
-          <p:nvPr/>
-        </p:nvSpPr>
-        <p:spPr>
-          <a:xfrm>
-            <a:off x="4475378" y="1627632"/>
-            <a:ext cx="1391869" cy="457200"/>
+          <p:cNvPr id="16" name="TextBox 15"/>
+          <p:cNvSpPr txBox="1"/>
+          <p:nvPr/>
+        </p:nvSpPr>
+        <p:spPr>
+          <a:xfrm>
+            <a:off x="5481044" y="1627632"/>
+            <a:ext cx="1229606" cy="457200"/>
           </a:xfrm>
           <a:prstGeom prst="rect">
             <a:avLst/>
@@ -15642,7 +15943,7 @@
           <a:p>
             <a:pPr algn="l"/>
             <a:r>
-              <a:rPr sz="1900" b="1" i="0">
+              <a:rPr sz="1600" b="1" i="0">
                 <a:solidFill>
                   <a:srgbClr val="1E2A3B"/>
                 </a:solidFill>
@@ -15655,14 +15956,14 @@
       </p:sp>
       <p:sp>
         <p:nvSpPr>
-          <p:cNvPr id="13" name="TextBox 12"/>
-          <p:cNvSpPr txBox="1"/>
-          <p:nvPr/>
-        </p:nvSpPr>
-        <p:spPr>
-          <a:xfrm>
-            <a:off x="4475378" y="2194560"/>
-            <a:ext cx="1391869" cy="1828800"/>
+          <p:cNvPr id="17" name="TextBox 16"/>
+          <p:cNvSpPr txBox="1"/>
+          <p:nvPr/>
+        </p:nvSpPr>
+        <p:spPr>
+          <a:xfrm>
+            <a:off x="5481044" y="2194560"/>
+            <a:ext cx="1229606" cy="1828800"/>
           </a:xfrm>
           <a:prstGeom prst="rect">
             <a:avLst/>
@@ -15677,7 +15978,7 @@
           <a:p>
             <a:pPr algn="l"/>
             <a:r>
-              <a:rPr sz="1500" b="0" i="0">
+              <a:rPr sz="1400" b="0" i="0">
                 <a:solidFill>
                   <a:srgbClr val="1E2A3B"/>
                 </a:solidFill>
@@ -15690,14 +15991,14 @@
       </p:sp>
       <p:cxnSp>
         <p:nvCxnSpPr>
-          <p:cNvPr id="14" name="Connector 13"/>
+          <p:cNvPr id="18" name="Connector 17"/>
           <p:cNvCxnSpPr/>
           <p:nvPr/>
         </p:nvCxnSpPr>
         <p:spPr>
           <a:xfrm>
-            <a:off x="6022695" y="2788920"/>
-            <a:ext cx="146304" cy="0"/>
+            <a:off x="6829522" y="2788920"/>
+            <a:ext cx="109728" cy="0"/>
           </a:xfrm>
           <a:prstGeom prst="line">
             <a:avLst/>
@@ -15726,14 +16027,14 @@
       </p:cxnSp>
       <p:sp>
         <p:nvSpPr>
-          <p:cNvPr id="15" name="Rounded Rectangle 14"/>
+          <p:cNvPr id="19" name="Rounded Rectangle 18"/>
           <p:cNvSpPr/>
           <p:nvPr/>
         </p:nvSpPr>
         <p:spPr>
           <a:xfrm>
-            <a:off x="6187287" y="1463040"/>
-            <a:ext cx="1666189" cy="2651760"/>
+            <a:off x="6948394" y="1463040"/>
+            <a:ext cx="1449062" cy="2651760"/>
           </a:xfrm>
           <a:prstGeom prst="roundRect">
             <a:avLst>
@@ -15770,14 +16071,14 @@
       </p:sp>
       <p:sp>
         <p:nvSpPr>
-          <p:cNvPr id="16" name="TextBox 15"/>
-          <p:cNvSpPr txBox="1"/>
-          <p:nvPr/>
-        </p:nvSpPr>
-        <p:spPr>
-          <a:xfrm>
-            <a:off x="6324447" y="1627632"/>
-            <a:ext cx="1391869" cy="457200"/>
+          <p:cNvPr id="20" name="TextBox 19"/>
+          <p:cNvSpPr txBox="1"/>
+          <p:nvPr/>
+        </p:nvSpPr>
+        <p:spPr>
+          <a:xfrm>
+            <a:off x="7058122" y="1627632"/>
+            <a:ext cx="1229606" cy="457200"/>
           </a:xfrm>
           <a:prstGeom prst="rect">
             <a:avLst/>
@@ -15792,7 +16093,7 @@
           <a:p>
             <a:pPr algn="l"/>
             <a:r>
-              <a:rPr sz="1900" b="1" i="0">
+              <a:rPr sz="1600" b="1" i="0">
                 <a:solidFill>
                   <a:srgbClr val="1E2A3B"/>
                 </a:solidFill>
@@ -15805,14 +16106,14 @@
       </p:sp>
       <p:sp>
         <p:nvSpPr>
-          <p:cNvPr id="17" name="TextBox 16"/>
-          <p:cNvSpPr txBox="1"/>
-          <p:nvPr/>
-        </p:nvSpPr>
-        <p:spPr>
-          <a:xfrm>
-            <a:off x="6324447" y="2194560"/>
-            <a:ext cx="1391869" cy="1828800"/>
+          <p:cNvPr id="21" name="TextBox 20"/>
+          <p:cNvSpPr txBox="1"/>
+          <p:nvPr/>
+        </p:nvSpPr>
+        <p:spPr>
+          <a:xfrm>
+            <a:off x="7058122" y="2194560"/>
+            <a:ext cx="1229606" cy="1828800"/>
           </a:xfrm>
           <a:prstGeom prst="rect">
             <a:avLst/>
@@ -15827,27 +16128,27 @@
           <a:p>
             <a:pPr algn="l"/>
             <a:r>
-              <a:rPr sz="1500" b="0" i="0">
+              <a:rPr sz="1400" b="0" i="0">
                 <a:solidFill>
                   <a:srgbClr val="1E2A3B"/>
                 </a:solidFill>
                 <a:latin typeface="Calibri"/>
               </a:rPr>
-              <a:t>Sends the read address: 0x10, four beats.</a:t>
+              <a:t>Sends the read address.</a:t>
             </a:r>
           </a:p>
         </p:txBody>
       </p:sp>
       <p:cxnSp>
         <p:nvCxnSpPr>
-          <p:cNvPr id="18" name="Connector 17"/>
+          <p:cNvPr id="22" name="Connector 21"/>
           <p:cNvCxnSpPr/>
           <p:nvPr/>
         </p:nvCxnSpPr>
         <p:spPr>
           <a:xfrm>
-            <a:off x="7871764" y="2788920"/>
-            <a:ext cx="146304" cy="0"/>
+            <a:off x="8406601" y="2788920"/>
+            <a:ext cx="109728" cy="0"/>
           </a:xfrm>
           <a:prstGeom prst="line">
             <a:avLst/>
@@ -15876,14 +16177,14 @@
       </p:cxnSp>
       <p:sp>
         <p:nvSpPr>
-          <p:cNvPr id="19" name="Rounded Rectangle 18"/>
+          <p:cNvPr id="23" name="Rounded Rectangle 22"/>
           <p:cNvSpPr/>
           <p:nvPr/>
         </p:nvSpPr>
         <p:spPr>
           <a:xfrm>
-            <a:off x="8036356" y="1463040"/>
-            <a:ext cx="1666189" cy="2651760"/>
+            <a:off x="8525473" y="1463040"/>
+            <a:ext cx="1449062" cy="2651760"/>
           </a:xfrm>
           <a:prstGeom prst="roundRect">
             <a:avLst>
@@ -15920,14 +16221,14 @@
       </p:sp>
       <p:sp>
         <p:nvSpPr>
-          <p:cNvPr id="20" name="TextBox 19"/>
-          <p:cNvSpPr txBox="1"/>
-          <p:nvPr/>
-        </p:nvSpPr>
-        <p:spPr>
-          <a:xfrm>
-            <a:off x="8173516" y="1627632"/>
-            <a:ext cx="1391869" cy="457200"/>
+          <p:cNvPr id="24" name="TextBox 23"/>
+          <p:cNvSpPr txBox="1"/>
+          <p:nvPr/>
+        </p:nvSpPr>
+        <p:spPr>
+          <a:xfrm>
+            <a:off x="8635201" y="1627632"/>
+            <a:ext cx="1229606" cy="457200"/>
           </a:xfrm>
           <a:prstGeom prst="rect">
             <a:avLst/>
@@ -15942,7 +16243,7 @@
           <a:p>
             <a:pPr algn="l"/>
             <a:r>
-              <a:rPr sz="1900" b="1" i="0">
+              <a:rPr sz="1600" b="1" i="0">
                 <a:solidFill>
                   <a:srgbClr val="1E2A3B"/>
                 </a:solidFill>
@@ -15955,14 +16256,14 @@
       </p:sp>
       <p:sp>
         <p:nvSpPr>
-          <p:cNvPr id="21" name="TextBox 20"/>
-          <p:cNvSpPr txBox="1"/>
-          <p:nvPr/>
-        </p:nvSpPr>
-        <p:spPr>
-          <a:xfrm>
-            <a:off x="8173516" y="2194560"/>
-            <a:ext cx="1391869" cy="1828800"/>
+          <p:cNvPr id="25" name="TextBox 24"/>
+          <p:cNvSpPr txBox="1"/>
+          <p:nvPr/>
+        </p:nvSpPr>
+        <p:spPr>
+          <a:xfrm>
+            <a:off x="8635201" y="2194560"/>
+            <a:ext cx="1229606" cy="1828800"/>
           </a:xfrm>
           <a:prstGeom prst="rect">
             <a:avLst/>
@@ -15977,27 +16278,27 @@
           <a:p>
             <a:pPr algn="l"/>
             <a:r>
-              <a:rPr sz="1500" b="0" i="0">
+              <a:rPr sz="1400" b="0" i="0">
                 <a:solidFill>
                   <a:srgbClr val="1E2A3B"/>
                 </a:solidFill>
                 <a:latin typeface="Calibri"/>
               </a:rPr>
-              <a:t>Takes four beats into the read registers. Ends on RLAST.</a:t>
+              <a:t>Hands each beat to the output DFFs. Ends on RLAST.</a:t>
             </a:r>
           </a:p>
         </p:txBody>
       </p:sp>
       <p:cxnSp>
         <p:nvCxnSpPr>
-          <p:cNvPr id="22" name="Connector 21"/>
+          <p:cNvPr id="26" name="Connector 25"/>
           <p:cNvCxnSpPr/>
           <p:nvPr/>
         </p:nvCxnSpPr>
         <p:spPr>
           <a:xfrm>
-            <a:off x="9720834" y="2788920"/>
-            <a:ext cx="146304" cy="0"/>
+            <a:off x="9983680" y="2788920"/>
+            <a:ext cx="109728" cy="0"/>
           </a:xfrm>
           <a:prstGeom prst="line">
             <a:avLst/>
@@ -16026,14 +16327,14 @@
       </p:cxnSp>
       <p:sp>
         <p:nvSpPr>
-          <p:cNvPr id="23" name="Rounded Rectangle 22"/>
+          <p:cNvPr id="27" name="Rounded Rectangle 26"/>
           <p:cNvSpPr/>
           <p:nvPr/>
         </p:nvSpPr>
         <p:spPr>
           <a:xfrm>
-            <a:off x="9885426" y="1463040"/>
-            <a:ext cx="1666189" cy="2651760"/>
+            <a:off x="10102552" y="1463040"/>
+            <a:ext cx="1449062" cy="2651760"/>
           </a:xfrm>
           <a:prstGeom prst="roundRect">
             <a:avLst>
@@ -16070,14 +16371,14 @@
       </p:sp>
       <p:sp>
         <p:nvSpPr>
-          <p:cNvPr id="24" name="TextBox 23"/>
-          <p:cNvSpPr txBox="1"/>
-          <p:nvPr/>
-        </p:nvSpPr>
-        <p:spPr>
-          <a:xfrm>
-            <a:off x="10022586" y="1627632"/>
-            <a:ext cx="1391869" cy="457200"/>
+          <p:cNvPr id="28" name="TextBox 27"/>
+          <p:cNvSpPr txBox="1"/>
+          <p:nvPr/>
+        </p:nvSpPr>
+        <p:spPr>
+          <a:xfrm>
+            <a:off x="10212280" y="1627632"/>
+            <a:ext cx="1229606" cy="457200"/>
           </a:xfrm>
           <a:prstGeom prst="rect">
             <a:avLst/>
@@ -16092,7 +16393,7 @@
           <a:p>
             <a:pPr algn="l"/>
             <a:r>
-              <a:rPr sz="1900" b="1" i="0">
+              <a:rPr sz="1600" b="1" i="0">
                 <a:solidFill>
                   <a:srgbClr val="1E2A3B"/>
                 </a:solidFill>
@@ -16105,14 +16406,14 @@
       </p:sp>
       <p:sp>
         <p:nvSpPr>
-          <p:cNvPr id="25" name="TextBox 24"/>
-          <p:cNvSpPr txBox="1"/>
-          <p:nvPr/>
-        </p:nvSpPr>
-        <p:spPr>
-          <a:xfrm>
-            <a:off x="10022586" y="2194560"/>
-            <a:ext cx="1391869" cy="1828800"/>
+          <p:cNvPr id="29" name="TextBox 28"/>
+          <p:cNvSpPr txBox="1"/>
+          <p:nvPr/>
+        </p:nvSpPr>
+        <p:spPr>
+          <a:xfrm>
+            <a:off x="10212280" y="2194560"/>
+            <a:ext cx="1229606" cy="1828800"/>
           </a:xfrm>
           <a:prstGeom prst="rect">
             <a:avLst/>
@@ -16127,20 +16428,20 @@
           <a:p>
             <a:pPr algn="l"/>
             <a:r>
-              <a:rPr sz="1500" b="0" i="0">
+              <a:rPr sz="1400" b="0" i="0">
                 <a:solidFill>
                   <a:srgbClr val="1E2A3B"/>
                 </a:solidFill>
                 <a:latin typeface="Calibri"/>
               </a:rPr>
-              <a:t>done = 1. pass = 1 if read-back equals what was written.</a:t>
-            </a:r>
-          </a:p>
-        </p:txBody>
-      </p:sp>
-      <p:sp>
-        <p:nvSpPr>
-          <p:cNvPr id="26" name="Rounded Rectangle 25"/>
+              <a:t>done = 1 until start drops.</a:t>
+            </a:r>
+          </a:p>
+        </p:txBody>
+      </p:sp>
+      <p:sp>
+        <p:nvSpPr>
+          <p:cNvPr id="30" name="Rounded Rectangle 29"/>
           <p:cNvSpPr/>
           <p:nvPr/>
         </p:nvSpPr>
@@ -16184,7 +16485,7 @@
       </p:sp>
       <p:sp>
         <p:nvSpPr>
-          <p:cNvPr id="27" name="TextBox 26"/>
+          <p:cNvPr id="31" name="TextBox 30"/>
           <p:cNvSpPr txBox="1"/>
           <p:nvPr/>
         </p:nvSpPr>
@@ -16212,14 +16513,14 @@
                 </a:solidFill>
                 <a:latin typeface="Cambria"/>
               </a:rPr>
-              <a:t>Data from D flip-flops</a:t>
-            </a:r>
-          </a:p>
-        </p:txBody>
-      </p:sp>
-      <p:sp>
-        <p:nvSpPr>
-          <p:cNvPr id="28" name="TextBox 27"/>
+              <a:t>Data from the input DFFs</a:t>
+            </a:r>
+          </a:p>
+        </p:txBody>
+      </p:sp>
+      <p:sp>
+        <p:nvSpPr>
+          <p:cNvPr id="32" name="TextBox 31"/>
           <p:cNvSpPr txBox="1"/>
           <p:nvPr/>
         </p:nvSpPr>
@@ -16247,14 +16548,14 @@
                 </a:solidFill>
                 <a:latin typeface="Calibri"/>
               </a:rPr>
-              <a:t>The address and four words sit in registers inside the master, set at reset. To send something else, change them in axi4_master.v.</a:t>
-            </a:r>
-          </a:p>
-        </p:txBody>
-      </p:sp>
-      <p:sp>
-        <p:nvSpPr>
-          <p:cNvPr id="29" name="Rounded Rectangle 28"/>
+              <a:t>The address and four words are not in the master. The testbench loads them into the input DFFs and the master reads them from there.</a:t>
+            </a:r>
+          </a:p>
+        </p:txBody>
+      </p:sp>
+      <p:sp>
+        <p:nvSpPr>
+          <p:cNvPr id="33" name="Rounded Rectangle 32"/>
           <p:cNvSpPr/>
           <p:nvPr/>
         </p:nvSpPr>
@@ -16298,7 +16599,7 @@
       </p:sp>
       <p:sp>
         <p:nvSpPr>
-          <p:cNvPr id="30" name="TextBox 29"/>
+          <p:cNvPr id="34" name="TextBox 33"/>
           <p:cNvSpPr txBox="1"/>
           <p:nvPr/>
         </p:nvSpPr>
@@ -16326,14 +16627,14 @@
                 </a:solidFill>
                 <a:latin typeface="Cambria"/>
               </a:rPr>
-              <a:t>No host interface</a:t>
-            </a:r>
-          </a:p>
-        </p:txBody>
-      </p:sp>
-      <p:sp>
-        <p:nvSpPr>
-          <p:cNvPr id="31" name="TextBox 30"/>
+              <a:t>Start and done</a:t>
+            </a:r>
+          </a:p>
+        </p:txBody>
+      </p:sp>
+      <p:sp>
+        <p:nvSpPr>
+          <p:cNvPr id="35" name="TextBox 34"/>
           <p:cNvSpPr txBox="1"/>
           <p:nvPr/>
         </p:nvSpPr>
@@ -16361,21 +16662,21 @@
                 </a:solidFill>
                 <a:latin typeface="Calibri"/>
               </a:rPr>
-              <a:t>Nothing tells the master what to do. After reset it runs the sequence by itself and reports done and pass.</a:t>
-            </a:r>
-          </a:p>
-        </p:txBody>
-      </p:sp>
-      <p:sp>
-        <p:nvSpPr>
-          <p:cNvPr id="32" name="Footer"/>
+              <a:t>Nothing happens until start goes high. done goes high when the read has finished; drop start to run it again.</a:t>
+            </a:r>
+          </a:p>
+        </p:txBody>
+      </p:sp>
+      <p:sp>
+        <p:nvSpPr>
+          <p:cNvPr id="36" name="Footer"/>
           <p:cNvSpPr txBox="1"/>
           <p:nvPr/>
         </p:nvSpPr>
         <p:spPr>
           <a:xfrm>
             <a:off x="640080" y="6400800"/>
-            <a:ext cx="7315200" cy="274320"/>
+            <a:ext cx="9144000" cy="274320"/>
           </a:xfrm>
           <a:prstGeom prst="rect">
             <a:avLst/>
@@ -16396,14 +16697,14 @@
                 </a:solidFill>
                 <a:latin typeface="Calibri"/>
               </a:rPr>
-              <a:t>AXI4: a master, D flip-flop stages and a memory, in Verilog</a:t>
-            </a:r>
-          </a:p>
-        </p:txBody>
-      </p:sp>
-      <p:sp>
-        <p:nvSpPr>
-          <p:cNvPr id="33" name="Page number"/>
+              <a:t>AXI4: input D flip-flops, a master, a slave and output D flip-flops, in Verilog</a:t>
+            </a:r>
+          </a:p>
+        </p:txBody>
+      </p:sp>
+      <p:sp>
+        <p:nvSpPr>
+          <p:cNvPr id="37" name="Page number"/>
           <p:cNvSpPr txBox="1"/>
           <p:nvPr/>
         </p:nvSpPr>
@@ -16492,7 +16793,7 @@
                 </a:solidFill>
                 <a:latin typeface="Cambria"/>
               </a:rPr>
-              <a:t>The D flip-flop stage</a:t>
+              <a:t>The D flip-flops at both ends</a:t>
             </a:r>
           </a:p>
         </p:txBody>
@@ -16506,155 +16807,6 @@
         <p:spPr>
           <a:xfrm>
             <a:off x="640080" y="1463040"/>
-            <a:ext cx="3493008" cy="2743200"/>
-          </a:xfrm>
-          <a:prstGeom prst="roundRect">
-            <a:avLst>
-              <a:gd name="adj" fmla="val 6000"/>
-            </a:avLst>
-          </a:prstGeom>
-          <a:solidFill>
-            <a:srgbClr val="D9F0E3"/>
-          </a:solidFill>
-          <a:ln>
-            <a:noFill/>
-          </a:ln>
-          <a:effectLst/>
-        </p:spPr>
-        <p:style>
-          <a:lnRef idx="1">
-            <a:schemeClr val="accent1"/>
-          </a:lnRef>
-          <a:fillRef idx="3">
-            <a:schemeClr val="accent1"/>
-          </a:fillRef>
-          <a:effectRef idx="2">
-            <a:schemeClr val="accent1"/>
-          </a:effectRef>
-          <a:fontRef idx="minor">
-            <a:schemeClr val="lt1"/>
-          </a:fontRef>
-        </p:style>
-        <p:txBody>
-          <a:bodyPr rtlCol="0" anchor="ctr"/>
-          <a:lstStyle/>
-          <a:p/>
-        </p:txBody>
-      </p:sp>
-      <p:sp>
-        <p:nvSpPr>
-          <p:cNvPr id="4" name="TextBox 3"/>
-          <p:cNvSpPr txBox="1"/>
-          <p:nvPr/>
-        </p:nvSpPr>
-        <p:spPr>
-          <a:xfrm>
-            <a:off x="914400" y="1645920"/>
-            <a:ext cx="3017520" cy="457200"/>
-          </a:xfrm>
-          <a:prstGeom prst="rect">
-            <a:avLst/>
-          </a:prstGeom>
-          <a:noFill/>
-        </p:spPr>
-        <p:txBody>
-          <a:bodyPr wrap="square" lIns="0" rIns="0" tIns="0" bIns="0" anchor="t">
-            <a:spAutoFit/>
-          </a:bodyPr>
-          <a:lstStyle/>
-          <a:p>
-            <a:pPr algn="l"/>
-            <a:r>
-              <a:rPr sz="2400" b="1" i="0">
-                <a:solidFill>
-                  <a:srgbClr val="1E2A3B"/>
-                </a:solidFill>
-                <a:latin typeface="Cambria"/>
-              </a:rPr>
-              <a:t>Empty</a:t>
-            </a:r>
-          </a:p>
-        </p:txBody>
-      </p:sp>
-      <p:sp>
-        <p:nvSpPr>
-          <p:cNvPr id="5" name="TextBox 4"/>
-          <p:cNvSpPr txBox="1"/>
-          <p:nvPr/>
-        </p:nvSpPr>
-        <p:spPr>
-          <a:xfrm>
-            <a:off x="914400" y="2240280"/>
-            <a:ext cx="3017520" cy="365760"/>
-          </a:xfrm>
-          <a:prstGeom prst="rect">
-            <a:avLst/>
-          </a:prstGeom>
-          <a:noFill/>
-        </p:spPr>
-        <p:txBody>
-          <a:bodyPr wrap="square" lIns="0" rIns="0" tIns="0" bIns="0" anchor="t">
-            <a:spAutoFit/>
-          </a:bodyPr>
-          <a:lstStyle/>
-          <a:p>
-            <a:pPr algn="l"/>
-            <a:r>
-              <a:rPr sz="1800" b="1" i="0">
-                <a:solidFill>
-                  <a:srgbClr val="1E2A3B"/>
-                </a:solidFill>
-                <a:latin typeface="Consolas"/>
-              </a:rPr>
-              <a:t>in_ready = 1</a:t>
-            </a:r>
-          </a:p>
-        </p:txBody>
-      </p:sp>
-      <p:sp>
-        <p:nvSpPr>
-          <p:cNvPr id="6" name="TextBox 5"/>
-          <p:cNvSpPr txBox="1"/>
-          <p:nvPr/>
-        </p:nvSpPr>
-        <p:spPr>
-          <a:xfrm>
-            <a:off x="914400" y="2788920"/>
-            <a:ext cx="3017520" cy="1371600"/>
-          </a:xfrm>
-          <a:prstGeom prst="rect">
-            <a:avLst/>
-          </a:prstGeom>
-          <a:noFill/>
-        </p:spPr>
-        <p:txBody>
-          <a:bodyPr wrap="square" lIns="0" rIns="0" tIns="0" bIns="0" anchor="t">
-            <a:spAutoFit/>
-          </a:bodyPr>
-          <a:lstStyle/>
-          <a:p>
-            <a:pPr algn="l"/>
-            <a:r>
-              <a:rPr sz="1600" b="0" i="0">
-                <a:solidFill>
-                  <a:srgbClr val="1E2A3B"/>
-                </a:solidFill>
-                <a:latin typeface="Calibri"/>
-              </a:rPr>
-              <a:t>The sender may hand over a beat. The beat is captured in the flip-flops.</a:t>
-            </a:r>
-          </a:p>
-        </p:txBody>
-      </p:sp>
-      <p:sp>
-        <p:nvSpPr>
-          <p:cNvPr id="7" name="Rounded Rectangle 6"/>
-          <p:cNvSpPr/>
-          <p:nvPr/>
-        </p:nvSpPr>
-        <p:spPr>
-          <a:xfrm>
-            <a:off x="4334256" y="1463040"/>
             <a:ext cx="3493008" cy="2743200"/>
           </a:xfrm>
           <a:prstGeom prst="roundRect">
@@ -16692,13 +16844,13 @@
       </p:sp>
       <p:sp>
         <p:nvSpPr>
-          <p:cNvPr id="8" name="TextBox 7"/>
-          <p:cNvSpPr txBox="1"/>
-          <p:nvPr/>
-        </p:nvSpPr>
-        <p:spPr>
-          <a:xfrm>
-            <a:off x="4608576" y="1645920"/>
+          <p:cNvPr id="4" name="TextBox 3"/>
+          <p:cNvSpPr txBox="1"/>
+          <p:nvPr/>
+        </p:nvSpPr>
+        <p:spPr>
+          <a:xfrm>
+            <a:off x="914400" y="1645920"/>
             <a:ext cx="3017520" cy="457200"/>
           </a:xfrm>
           <a:prstGeom prst="rect">
@@ -16720,20 +16872,20 @@
                 </a:solidFill>
                 <a:latin typeface="Cambria"/>
               </a:rPr>
-              <a:t>Full</a:t>
-            </a:r>
-          </a:p>
-        </p:txBody>
-      </p:sp>
-      <p:sp>
-        <p:nvSpPr>
-          <p:cNvPr id="9" name="TextBox 8"/>
-          <p:cNvSpPr txBox="1"/>
-          <p:nvPr/>
-        </p:nvSpPr>
-        <p:spPr>
-          <a:xfrm>
-            <a:off x="4608576" y="2240280"/>
+              <a:t>Input DFFs</a:t>
+            </a:r>
+          </a:p>
+        </p:txBody>
+      </p:sp>
+      <p:sp>
+        <p:nvSpPr>
+          <p:cNvPr id="5" name="TextBox 4"/>
+          <p:cNvSpPr txBox="1"/>
+          <p:nvPr/>
+        </p:nvSpPr>
+        <p:spPr>
+          <a:xfrm>
+            <a:off x="914400" y="2240280"/>
             <a:ext cx="3017520" cy="365760"/>
           </a:xfrm>
           <a:prstGeom prst="rect">
@@ -16749,26 +16901,26 @@
           <a:p>
             <a:pPr algn="l"/>
             <a:r>
-              <a:rPr sz="1800" b="1" i="0">
+              <a:rPr sz="1400" b="1" i="0">
                 <a:solidFill>
                   <a:srgbClr val="1E2A3B"/>
                 </a:solidFill>
                 <a:latin typeface="Consolas"/>
               </a:rPr>
-              <a:t>in_ready = 0</a:t>
-            </a:r>
-          </a:p>
-        </p:txBody>
-      </p:sp>
-      <p:sp>
-        <p:nvSpPr>
-          <p:cNvPr id="10" name="TextBox 9"/>
-          <p:cNvSpPr txBox="1"/>
-          <p:nvPr/>
-        </p:nvSpPr>
-        <p:spPr>
-          <a:xfrm>
-            <a:off x="4608576" y="2788920"/>
+              <a:t>load, load_sel, load_data</a:t>
+            </a:r>
+          </a:p>
+        </p:txBody>
+      </p:sp>
+      <p:sp>
+        <p:nvSpPr>
+          <p:cNvPr id="6" name="TextBox 5"/>
+          <p:cNvSpPr txBox="1"/>
+          <p:nvPr/>
+        </p:nvSpPr>
+        <p:spPr>
+          <a:xfrm>
+            <a:off x="914400" y="2788920"/>
             <a:ext cx="3017520" cy="1371600"/>
           </a:xfrm>
           <a:prstGeom prst="rect">
@@ -16790,20 +16942,20 @@
                 </a:solidFill>
                 <a:latin typeface="Calibri"/>
               </a:rPr>
-              <a:t>The beat is offered on out_valid until the next side takes it. The sender waits.</a:t>
-            </a:r>
-          </a:p>
-        </p:txBody>
-      </p:sp>
-      <p:sp>
-        <p:nvSpPr>
-          <p:cNvPr id="11" name="Rounded Rectangle 10"/>
+              <a:t>Five registers: an address and four words. One value is stored per clock edge where load = 1.</a:t>
+            </a:r>
+          </a:p>
+        </p:txBody>
+      </p:sp>
+      <p:sp>
+        <p:nvSpPr>
+          <p:cNvPr id="7" name="Rounded Rectangle 6"/>
           <p:cNvSpPr/>
           <p:nvPr/>
         </p:nvSpPr>
         <p:spPr>
           <a:xfrm>
-            <a:off x="8028431" y="1463040"/>
+            <a:off x="4334256" y="1463040"/>
             <a:ext cx="3493008" cy="2743200"/>
           </a:xfrm>
           <a:prstGeom prst="roundRect">
@@ -16841,6 +16993,155 @@
       </p:sp>
       <p:sp>
         <p:nvSpPr>
+          <p:cNvPr id="8" name="TextBox 7"/>
+          <p:cNvSpPr txBox="1"/>
+          <p:nvPr/>
+        </p:nvSpPr>
+        <p:spPr>
+          <a:xfrm>
+            <a:off x="4608576" y="1645920"/>
+            <a:ext cx="3017520" cy="457200"/>
+          </a:xfrm>
+          <a:prstGeom prst="rect">
+            <a:avLst/>
+          </a:prstGeom>
+          <a:noFill/>
+        </p:spPr>
+        <p:txBody>
+          <a:bodyPr wrap="square" lIns="0" rIns="0" tIns="0" bIns="0" anchor="t">
+            <a:spAutoFit/>
+          </a:bodyPr>
+          <a:lstStyle/>
+          <a:p>
+            <a:pPr algn="l"/>
+            <a:r>
+              <a:rPr sz="2400" b="1" i="0">
+                <a:solidFill>
+                  <a:srgbClr val="1E2A3B"/>
+                </a:solidFill>
+                <a:latin typeface="Cambria"/>
+              </a:rPr>
+              <a:t>Master</a:t>
+            </a:r>
+          </a:p>
+        </p:txBody>
+      </p:sp>
+      <p:sp>
+        <p:nvSpPr>
+          <p:cNvPr id="9" name="TextBox 8"/>
+          <p:cNvSpPr txBox="1"/>
+          <p:nvPr/>
+        </p:nvSpPr>
+        <p:spPr>
+          <a:xfrm>
+            <a:off x="4608576" y="2240280"/>
+            <a:ext cx="3017520" cy="365760"/>
+          </a:xfrm>
+          <a:prstGeom prst="rect">
+            <a:avLst/>
+          </a:prstGeom>
+          <a:noFill/>
+        </p:spPr>
+        <p:txBody>
+          <a:bodyPr wrap="square" lIns="0" rIns="0" tIns="0" bIns="0" anchor="t">
+            <a:spAutoFit/>
+          </a:bodyPr>
+          <a:lstStyle/>
+          <a:p>
+            <a:pPr algn="l"/>
+            <a:r>
+              <a:rPr sz="1400" b="1" i="0">
+                <a:solidFill>
+                  <a:srgbClr val="1E2A3B"/>
+                </a:solidFill>
+                <a:latin typeface="Consolas"/>
+              </a:rPr>
+              <a:t>start, done</a:t>
+            </a:r>
+          </a:p>
+        </p:txBody>
+      </p:sp>
+      <p:sp>
+        <p:nvSpPr>
+          <p:cNvPr id="10" name="TextBox 9"/>
+          <p:cNvSpPr txBox="1"/>
+          <p:nvPr/>
+        </p:nvSpPr>
+        <p:spPr>
+          <a:xfrm>
+            <a:off x="4608576" y="2788920"/>
+            <a:ext cx="3017520" cy="1371600"/>
+          </a:xfrm>
+          <a:prstGeom prst="rect">
+            <a:avLst/>
+          </a:prstGeom>
+          <a:noFill/>
+        </p:spPr>
+        <p:txBody>
+          <a:bodyPr wrap="square" lIns="0" rIns="0" tIns="0" bIns="0" anchor="t">
+            <a:spAutoFit/>
+          </a:bodyPr>
+          <a:lstStyle/>
+          <a:p>
+            <a:pPr algn="l"/>
+            <a:r>
+              <a:rPr sz="1600" b="0" i="0">
+                <a:solidFill>
+                  <a:srgbClr val="1E2A3B"/>
+                </a:solidFill>
+                <a:latin typeface="Calibri"/>
+              </a:rPr>
+              <a:t>Reads the values straight from the input DFFs, writes them, reads them back.</a:t>
+            </a:r>
+          </a:p>
+        </p:txBody>
+      </p:sp>
+      <p:sp>
+        <p:nvSpPr>
+          <p:cNvPr id="11" name="Rounded Rectangle 10"/>
+          <p:cNvSpPr/>
+          <p:nvPr/>
+        </p:nvSpPr>
+        <p:spPr>
+          <a:xfrm>
+            <a:off x="8028431" y="1463040"/>
+            <a:ext cx="3493008" cy="2743200"/>
+          </a:xfrm>
+          <a:prstGeom prst="roundRect">
+            <a:avLst>
+              <a:gd name="adj" fmla="val 6000"/>
+            </a:avLst>
+          </a:prstGeom>
+          <a:solidFill>
+            <a:srgbClr val="FFE9A8"/>
+          </a:solidFill>
+          <a:ln>
+            <a:noFill/>
+          </a:ln>
+          <a:effectLst/>
+        </p:spPr>
+        <p:style>
+          <a:lnRef idx="1">
+            <a:schemeClr val="accent1"/>
+          </a:lnRef>
+          <a:fillRef idx="3">
+            <a:schemeClr val="accent1"/>
+          </a:fillRef>
+          <a:effectRef idx="2">
+            <a:schemeClr val="accent1"/>
+          </a:effectRef>
+          <a:fontRef idx="minor">
+            <a:schemeClr val="lt1"/>
+          </a:fontRef>
+        </p:style>
+        <p:txBody>
+          <a:bodyPr rtlCol="0" anchor="ctr"/>
+          <a:lstStyle/>
+          <a:p/>
+        </p:txBody>
+      </p:sp>
+      <p:sp>
+        <p:nvSpPr>
           <p:cNvPr id="12" name="TextBox 11"/>
           <p:cNvSpPr txBox="1"/>
           <p:nvPr/>
@@ -16869,7 +17170,7 @@
                 </a:solidFill>
                 <a:latin typeface="Cambria"/>
               </a:rPr>
-              <a:t>Taken</a:t>
+              <a:t>Output DFFs</a:t>
             </a:r>
           </a:p>
         </p:txBody>
@@ -16898,13 +17199,13 @@
           <a:p>
             <a:pPr algn="l"/>
             <a:r>
-              <a:rPr sz="1800" b="1" i="0">
+              <a:rPr sz="1400" b="1" i="0">
                 <a:solidFill>
                   <a:srgbClr val="1E2A3B"/>
                 </a:solidFill>
                 <a:latin typeface="Consolas"/>
               </a:rPr>
-              <a:t>out_ready = 1</a:t>
+              <a:t>rd_valid, rd_idx, rd_data</a:t>
             </a:r>
           </a:p>
         </p:txBody>
@@ -16939,7 +17240,7 @@
                 </a:solidFill>
                 <a:latin typeface="Calibri"/>
               </a:rPr>
-              <a:t>The next side has taken the beat. The stage is empty again.</a:t>
+              <a:t>Four registers. Each read beat is stored in its own register as it arrives.</a:t>
             </a:r>
           </a:p>
         </p:txBody>
@@ -17018,7 +17319,7 @@
                 </a:solidFill>
                 <a:latin typeface="Cambria"/>
               </a:rPr>
-              <a:t>Why not a bare flip-flop?</a:t>
+              <a:t>How pass is made</a:t>
             </a:r>
           </a:p>
         </p:txBody>
@@ -17053,7 +17354,7 @@
                 </a:solidFill>
                 <a:latin typeface="Calibri"/>
               </a:rPr>
-              <a:t>READY would arrive a cycle late, and the sender could send the same beat twice. Here in_ready comes straight from a flip-flop, so that cannot happen.</a:t>
+              <a:t>pass = done and the four output registers equal the four input registers.</a:t>
             </a:r>
           </a:p>
         </p:txBody>
@@ -17132,7 +17433,7 @@
                 </a:solidFill>
                 <a:latin typeface="Cambria"/>
               </a:rPr>
-              <a:t>What it costs</a:t>
+              <a:t>Direct connection</a:t>
             </a:r>
           </a:p>
         </p:txBody>
@@ -17167,7 +17468,7 @@
                 </a:solidFill>
                 <a:latin typeface="Calibri"/>
               </a:rPr>
-              <a:t>A beat sits in a stage for a clock, so one beat moves every two clocks. Correct and simple, but half rate.</a:t>
+              <a:t>Nothing sits between the master and the slave, so a beat moves every clock the receiver is ready.</a:t>
             </a:r>
           </a:p>
         </p:txBody>
@@ -17181,7 +17482,7 @@
         <p:spPr>
           <a:xfrm>
             <a:off x="640080" y="6400800"/>
-            <a:ext cx="7315200" cy="274320"/>
+            <a:ext cx="9144000" cy="274320"/>
           </a:xfrm>
           <a:prstGeom prst="rect">
             <a:avLst/>
@@ -17202,7 +17503,7 @@
                 </a:solidFill>
                 <a:latin typeface="Calibri"/>
               </a:rPr>
-              <a:t>AXI4: a master, D flip-flop stages and a memory, in Verilog</a:t>
+              <a:t>AXI4: input D flip-flops, a master, a slave and output D flip-flops, in Verilog</a:t>
             </a:r>
           </a:p>
         </p:txBody>
@@ -17724,7 +18025,7 @@
         <p:spPr>
           <a:xfrm>
             <a:off x="640080" y="6400800"/>
-            <a:ext cx="7315200" cy="274320"/>
+            <a:ext cx="9144000" cy="274320"/>
           </a:xfrm>
           <a:prstGeom prst="rect">
             <a:avLst/>
@@ -17745,7 +18046,7 @@
                 </a:solidFill>
                 <a:latin typeface="Calibri"/>
               </a:rPr>
-              <a:t>AXI4: a master, D flip-flop stages and a memory, in Verilog</a:t>
+              <a:t>AXI4: input D flip-flops, a master, a slave and output D flip-flops, in Verilog</a:t>
             </a:r>
           </a:p>
         </p:txBody>

</xml_diff>